<commit_message>
Refine interpretations, add data validation, automate R-Python cross-check, and integrate slide build in run_all
</commit_message>
<xml_diff>
--- a/slides/FA24-BEDS-105.pptx
+++ b/slides/FA24-BEDS-105.pptx
@@ -3438,14 +3438,14 @@
           <a:lstStyle/>
           <a:p>
             <a:pPr>
-              <a:defRPr sz="2400" b="1">
+              <a:defRPr sz="2200" b="1">
                 <a:solidFill>
                   <a:srgbClr val="1F3B6E"/>
                 </a:solidFill>
               </a:defRPr>
             </a:pPr>
             <a:r>
-              <a:t>Key finding: the literacy gap widens with age</a:t>
+              <a:t>Key finding: large gender gap in literacy across older cohorts</a:t>
             </a:r>
           </a:p>
         </p:txBody>
@@ -3483,7 +3483,7 @@
                   <a:srgbClr val="1F3B6E"/>
                 </a:solidFill>
               </a:rPr>
-              <a:t>Women fall from 68.1% (ages 15-19) to 16.2% (ages 55-59)</a:t>
+              <a:t>Women: 68.1% at ages 15-19 vs 16.2% at ages 55-59</a:t>
             </a:r>
           </a:p>
           <a:p>
@@ -3493,7 +3493,7 @@
                   <a:srgbClr val="555555"/>
                 </a:solidFill>
               </a:rPr>
-              <a:t>Men stay near 90% at 15-19 and 58.8% at 55-59</a:t>
+              <a:t>Men: 89.7% at ages 15-19 vs 58.8% at ages 55-59</a:t>
             </a:r>
           </a:p>
           <a:p>
@@ -3543,7 +3543,7 @@
                   <a:srgbClr val="555555"/>
                 </a:solidFill>
               </a:rPr>
-              <a:t>Consistent with older cohorts of women being excluded from schooling</a:t>
+              <a:t>Cross-sectional data show generational inequalities; cannot establish causes or aging effects</a:t>
             </a:r>
           </a:p>
         </p:txBody>
@@ -3659,7 +3659,7 @@
                   <a:srgbClr val="1F3B6E"/>
                 </a:solidFill>
               </a:rPr>
-              <a:t>Weighted median below unweighted median (Rs 9,500 vs Rs 10,100)</a:t>
+              <a:t>Weighting shifts median from Rs 10,100 (sample) to Rs 9,500 (population)</a:t>
             </a:r>
           </a:p>
           <a:p>
@@ -3669,7 +3669,7 @@
                   <a:srgbClr val="555555"/>
                 </a:solidFill>
               </a:rPr>
-              <a:t>Lower-spending households carry larger weights, pulling the weighted centre down</a:t>
+              <a:t>Lower-spending students have higher average survey weights (268.7 vs 228.4)</a:t>
             </a:r>
           </a:p>
           <a:p>

</xml_diff>

<commit_message>
Calculate mean survey weights below/above median, clarify weighting in README, and update slide layout
</commit_message>
<xml_diff>
--- a/slides/FA24-BEDS-105.pptx
+++ b/slides/FA24-BEDS-105.pptx
@@ -3219,7 +3219,7 @@
                   <a:srgbClr val="555555"/>
                 </a:solidFill>
               </a:rPr>
-              <a:t>PSLM 2019-20 person and household files; all statistics weighted by hhweight</a:t>
+              <a:t>PSLM 2019-20 person and household files; Population estimates weighted by hhweight</a:t>
             </a:r>
           </a:p>
           <a:p>
@@ -3324,7 +3324,7 @@
         </p:blipFill>
         <p:spPr>
           <a:xfrm>
-            <a:off x="274320" y="1234440"/>
+            <a:off x="320040" y="1234440"/>
             <a:ext cx="4114800" cy="2939143"/>
           </a:xfrm>
           <a:prstGeom prst="rect">
@@ -3354,7 +3354,7 @@
         </p:blipFill>
         <p:spPr>
           <a:xfrm>
-            <a:off x="4754880" y="1051560"/>
+            <a:off x="4709160" y="1234440"/>
             <a:ext cx="4114800" cy="2662518"/>
           </a:xfrm>
           <a:prstGeom prst="rect">
@@ -3370,8 +3370,8 @@
         </p:nvSpPr>
         <p:spPr>
           <a:xfrm>
-            <a:off x="274320" y="5943600"/>
-            <a:ext cx="8595360" cy="731520"/>
+            <a:off x="548640" y="4526280"/>
+            <a:ext cx="8046720" cy="1097280"/>
           </a:xfrm>
           <a:prstGeom prst="rect">
             <a:avLst/>
@@ -3385,14 +3385,14 @@
           <a:lstStyle/>
           <a:p>
             <a:pPr>
-              <a:defRPr sz="1100">
+              <a:defRPr sz="1300">
                 <a:solidFill>
                   <a:srgbClr val="555555"/>
                 </a:solidFill>
               </a:defRPr>
             </a:pPr>
             <a:r>
-              <a:t>Default: raw literate-vs-age points, overplotted.  Redesign: weighted literacy by age band, two series, direct labels, no legend, thin cells hollow, widest gap annotated.</a:t>
+              <a:t>Default: raw literate-vs-age points, heavily overplotted.  Redesign: weighted literacy by age band, two series, direct end labels, no legend, thin cells hollow, widest gap directly annotated.</a:t>
             </a:r>
           </a:p>
         </p:txBody>

</xml_diff>

<commit_message>
Fix unweighted median, figure titles, and three-slide deck.
Co-authored-by: Cursor <cursoragent@cursor.com>
</commit_message>
<xml_diff>
--- a/slides/FA24-BEDS-105.pptx
+++ b/slides/FA24-BEDS-105.pptx
@@ -8,7 +8,6 @@
     <p:sldId id="256" r:id="rId7"/>
     <p:sldId id="257" r:id="rId8"/>
     <p:sldId id="258" r:id="rId9"/>
-    <p:sldId id="259" r:id="rId10"/>
   </p:sldIdLst>
   <p:sldSz cx="9144000" cy="6858000" type="screen4x3"/>
   <p:notesSz cx="6858000" cy="9144000"/>
@@ -3121,7 +3120,7 @@
               </a:defRPr>
             </a:pPr>
             <a:r>
-              <a:t>ECO346 Assignment 1 — Variant 5: KP urban</a:t>
+              <a:t>ECO346 Assignment 1 - Variant 5: KP urban</a:t>
             </a:r>
           </a:p>
         </p:txBody>
@@ -3438,14 +3437,14 @@
           <a:lstStyle/>
           <a:p>
             <a:pPr>
-              <a:defRPr sz="2200" b="1">
+              <a:defRPr sz="2000" b="1">
                 <a:solidFill>
                   <a:srgbClr val="1F3B6E"/>
                 </a:solidFill>
               </a:defRPr>
             </a:pPr>
             <a:r>
-              <a:t>Key finding: large gender gap in literacy across older cohorts</a:t>
+              <a:t>Key finding: widest gender gap in literacy at ages 40-44</a:t>
             </a:r>
           </a:p>
         </p:txBody>
@@ -3518,7 +3517,7 @@
                   <a:srgbClr val="555555"/>
                 </a:solidFill>
               </a:rPr>
-              <a:t>Men 77.1% vs women 29.7%</a:t>
+              <a:t>Men 77.1% vs women 29.7% — wider than at 55-59 (42.6 points)</a:t>
             </a:r>
           </a:p>
           <a:p>
@@ -3533,7 +3532,7 @@
                   <a:srgbClr val="1F3B6E"/>
                 </a:solidFill>
               </a:rPr>
-              <a:t>Interpretation</a:t>
+              <a:t>What this cannot tell us</a:t>
             </a:r>
           </a:p>
           <a:p>
@@ -3543,158 +3542,7 @@
                   <a:srgbClr val="555555"/>
                 </a:solidFill>
               </a:rPr>
-              <a:t>Cross-sectional data show generational inequalities; cannot establish causes or aging effects</a:t>
-            </a:r>
-          </a:p>
-        </p:txBody>
-      </p:sp>
-    </p:spTree>
-  </p:cSld>
-  <p:clrMapOvr>
-    <a:masterClrMapping/>
-  </p:clrMapOvr>
-</p:sld>
-</file>
-
-<file path=ppt/slides/slide4.xml><?xml version="1.0" encoding="utf-8"?>
-<p:sld xmlns:a="http://schemas.openxmlformats.org/drawingml/2006/main" xmlns:p="http://schemas.openxmlformats.org/presentationml/2006/main" xmlns:r="http://schemas.openxmlformats.org/officeDocument/2006/relationships">
-  <p:cSld>
-    <p:spTree>
-      <p:nvGrpSpPr>
-        <p:cNvPr id="1" name=""/>
-        <p:cNvGrpSpPr/>
-        <p:nvPr/>
-      </p:nvGrpSpPr>
-      <p:grpSpPr/>
-      <p:sp>
-        <p:nvSpPr>
-          <p:cNvPr id="2" name="TextBox 1"/>
-          <p:cNvSpPr txBox="1"/>
-          <p:nvPr/>
-        </p:nvSpPr>
-        <p:spPr>
-          <a:xfrm>
-            <a:off x="502920" y="274320"/>
-            <a:ext cx="8229600" cy="822960"/>
-          </a:xfrm>
-          <a:prstGeom prst="rect">
-            <a:avLst/>
-          </a:prstGeom>
-          <a:noFill/>
-        </p:spPr>
-        <p:txBody>
-          <a:bodyPr wrap="square">
-            <a:spAutoFit/>
-          </a:bodyPr>
-          <a:lstStyle/>
-          <a:p>
-            <a:pPr>
-              <a:defRPr sz="2400" b="1">
-                <a:solidFill>
-                  <a:srgbClr val="1F3B6E"/>
-                </a:solidFill>
-              </a:defRPr>
-            </a:pPr>
-            <a:r>
-              <a:t>Education spending: skewed even in logs</a:t>
-            </a:r>
-          </a:p>
-        </p:txBody>
-      </p:sp>
-      <p:sp>
-        <p:nvSpPr>
-          <p:cNvPr id="3" name="TextBox 2"/>
-          <p:cNvSpPr txBox="1"/>
-          <p:nvPr/>
-        </p:nvSpPr>
-        <p:spPr>
-          <a:xfrm>
-            <a:off x="548640" y="1463040"/>
-            <a:ext cx="8046720" cy="4937760"/>
-          </a:xfrm>
-          <a:prstGeom prst="rect">
-            <a:avLst/>
-          </a:prstGeom>
-          <a:noFill/>
-        </p:spPr>
-        <p:txBody>
-          <a:bodyPr wrap="square">
-            <a:spAutoFit/>
-          </a:bodyPr>
-          <a:lstStyle/>
-          <a:p>
-            <a:pPr>
-              <a:spcAft>
-                <a:spcPts val="600"/>
-              </a:spcAft>
-            </a:pPr>
-            <a:r>
-              <a:rPr sz="1700" b="1">
-                <a:solidFill>
-                  <a:srgbClr val="1F3B6E"/>
-                </a:solidFill>
-              </a:rPr>
-              <a:t>Weighted median Rs 9,500; weighted 90th percentile Rs 39,000</a:t>
-            </a:r>
-          </a:p>
-          <a:p>
-            <a:r>
-              <a:rPr sz="1300">
-                <a:solidFill>
-                  <a:srgbClr val="555555"/>
-                </a:solidFill>
-              </a:rPr>
-              <a:t>Ratio of 90th to 10th percentile: 12.38</a:t>
-            </a:r>
-          </a:p>
-          <a:p>
-            <a:pPr>
-              <a:spcAft>
-                <a:spcPts val="600"/>
-              </a:spcAft>
-            </a:pPr>
-            <a:r>
-              <a:rPr sz="1700" b="1">
-                <a:solidFill>
-                  <a:srgbClr val="1F3B6E"/>
-                </a:solidFill>
-              </a:rPr>
-              <a:t>Weighting shifts median from Rs 10,100 (sample) to Rs 9,500 (population)</a:t>
-            </a:r>
-          </a:p>
-          <a:p>
-            <a:r>
-              <a:rPr sz="1300">
-                <a:solidFill>
-                  <a:srgbClr val="555555"/>
-                </a:solidFill>
-              </a:rPr>
-              <a:t>Lower-spending students have higher average survey weights (268.7 vs 228.4)</a:t>
-            </a:r>
-          </a:p>
-          <a:p>
-            <a:pPr>
-              <a:spcAft>
-                <a:spcPts val="600"/>
-              </a:spcAft>
-            </a:pPr>
-            <a:r>
-              <a:rPr sz="1700" b="1">
-                <a:solidFill>
-                  <a:srgbClr val="1F3B6E"/>
-                </a:solidFill>
-              </a:rPr>
-              <a:t>Sample</a:t>
-            </a:r>
-          </a:p>
-          <a:p>
-            <a:r>
-              <a:rPr sz="1300">
-                <a:solidFill>
-                  <a:srgbClr val="555555"/>
-                </a:solidFill>
-              </a:rPr>
-              <a:t>1,060 students analysed of 1,061 (1 excluded outside Rs 100-Rs 1,000,000)</a:t>
+              <a:t>Causes of the gap, or whether it is a cohort effect or an aging effect</a:t>
             </a:r>
           </a:p>
         </p:txBody>

</xml_diff>

<commit_message>
Refine slide typography, palette, and card layout in build script
</commit_message>
<xml_diff>
--- a/slides/FA24-BEDS-105.pptx
+++ b/slides/FA24-BEDS-105.pptx
@@ -3083,6 +3083,14 @@
 <file path=ppt/slides/slide1.xml><?xml version="1.0" encoding="utf-8"?>
 <p:sld xmlns:a="http://schemas.openxmlformats.org/drawingml/2006/main" xmlns:p="http://schemas.openxmlformats.org/presentationml/2006/main" xmlns:r="http://schemas.openxmlformats.org/officeDocument/2006/relationships">
   <p:cSld>
+    <p:bg>
+      <p:bgPr>
+        <a:solidFill>
+          <a:srgbClr val="F3ECDF"/>
+        </a:solidFill>
+        <a:effectLst/>
+      </p:bgPr>
+    </p:bg>
     <p:spTree>
       <p:nvGrpSpPr>
         <p:cNvPr id="1" name=""/>
@@ -3092,14 +3100,102 @@
       <p:grpSpPr/>
       <p:sp>
         <p:nvSpPr>
-          <p:cNvPr id="2" name="TextBox 1"/>
+          <p:cNvPr id="2" name="Rectangle 1"/>
+          <p:cNvSpPr/>
+          <p:nvPr/>
+        </p:nvSpPr>
+        <p:spPr>
+          <a:xfrm>
+            <a:off x="0" y="0"/>
+            <a:ext cx="164592" cy="6858000"/>
+          </a:xfrm>
+          <a:prstGeom prst="rect">
+            <a:avLst/>
+          </a:prstGeom>
+          <a:solidFill>
+            <a:srgbClr val="8E2F28"/>
+          </a:solidFill>
+          <a:ln>
+            <a:noFill/>
+          </a:ln>
+          <a:effectLst/>
+        </p:spPr>
+        <p:style>
+          <a:lnRef idx="1">
+            <a:schemeClr val="accent1"/>
+          </a:lnRef>
+          <a:fillRef idx="3">
+            <a:schemeClr val="accent1"/>
+          </a:fillRef>
+          <a:effectRef idx="2">
+            <a:schemeClr val="accent1"/>
+          </a:effectRef>
+          <a:fontRef idx="minor">
+            <a:schemeClr val="lt1"/>
+          </a:fontRef>
+        </p:style>
+        <p:txBody>
+          <a:bodyPr rtlCol="0" anchor="ctr"/>
+          <a:lstStyle/>
+          <a:p>
+            <a:pPr algn="ctr"/>
+          </a:p>
+        </p:txBody>
+      </p:sp>
+      <p:sp>
+        <p:nvSpPr>
+          <p:cNvPr id="3" name="Rectangle 2"/>
+          <p:cNvSpPr/>
+          <p:nvPr/>
+        </p:nvSpPr>
+        <p:spPr>
+          <a:xfrm>
+            <a:off x="164592" y="6565392"/>
+            <a:ext cx="8979408" cy="292608"/>
+          </a:xfrm>
+          <a:prstGeom prst="rect">
+            <a:avLst/>
+          </a:prstGeom>
+          <a:solidFill>
+            <a:srgbClr val="2E4A3F"/>
+          </a:solidFill>
+          <a:ln>
+            <a:noFill/>
+          </a:ln>
+          <a:effectLst/>
+        </p:spPr>
+        <p:style>
+          <a:lnRef idx="1">
+            <a:schemeClr val="accent1"/>
+          </a:lnRef>
+          <a:fillRef idx="3">
+            <a:schemeClr val="accent1"/>
+          </a:fillRef>
+          <a:effectRef idx="2">
+            <a:schemeClr val="accent1"/>
+          </a:effectRef>
+          <a:fontRef idx="minor">
+            <a:schemeClr val="lt1"/>
+          </a:fontRef>
+        </p:style>
+        <p:txBody>
+          <a:bodyPr rtlCol="0" anchor="ctr"/>
+          <a:lstStyle/>
+          <a:p>
+            <a:pPr algn="ctr"/>
+          </a:p>
+        </p:txBody>
+      </p:sp>
+      <p:sp>
+        <p:nvSpPr>
+          <p:cNvPr id="4" name="TextBox 3"/>
           <p:cNvSpPr txBox="1"/>
           <p:nvPr/>
         </p:nvSpPr>
         <p:spPr>
           <a:xfrm>
-            <a:off x="502920" y="274320"/>
-            <a:ext cx="8229600" cy="822960"/>
+            <a:off x="411480" y="6565392"/>
+            <a:ext cx="8412480" cy="292608"/>
           </a:xfrm>
           <a:prstGeom prst="rect">
             <a:avLst/>
@@ -3107,34 +3203,32 @@
           <a:noFill/>
         </p:spPr>
         <p:txBody>
-          <a:bodyPr wrap="square">
-            <a:spAutoFit/>
-          </a:bodyPr>
-          <a:lstStyle/>
-          <a:p>
-            <a:pPr>
-              <a:defRPr sz="2600" b="1">
-                <a:solidFill>
-                  <a:srgbClr val="1F3B6E"/>
-                </a:solidFill>
-              </a:defRPr>
-            </a:pPr>
-            <a:r>
-              <a:t>ECO346 Assignment 1 - Variant 5: KP urban</a:t>
-            </a:r>
-          </a:p>
-        </p:txBody>
-      </p:sp>
-      <p:sp>
-        <p:nvSpPr>
-          <p:cNvPr id="3" name="TextBox 2"/>
+          <a:bodyPr wrap="square"/>
+          <a:lstStyle/>
+          <a:p>
+            <a:pPr algn="l"/>
+            <a:r>
+              <a:rPr sz="1000" b="0">
+                <a:solidFill>
+                  <a:srgbClr val="F3ECDF"/>
+                </a:solidFill>
+                <a:latin typeface="Calibri"/>
+              </a:rPr>
+              <a:t>ECO346  ·  FA24-BEDS-105  ·  Variant 5, KP urban  ·  PSLM 2019-20</a:t>
+            </a:r>
+          </a:p>
+        </p:txBody>
+      </p:sp>
+      <p:sp>
+        <p:nvSpPr>
+          <p:cNvPr id="5" name="TextBox 4"/>
           <p:cNvSpPr txBox="1"/>
           <p:nvPr/>
         </p:nvSpPr>
         <p:spPr>
           <a:xfrm>
-            <a:off x="548640" y="1463040"/>
-            <a:ext cx="8046720" cy="4937760"/>
+            <a:off x="438912" y="201168"/>
+            <a:ext cx="8321040" cy="292608"/>
           </a:xfrm>
           <a:prstGeom prst="rect">
             <a:avLst/>
@@ -3142,108 +3236,778 @@
           <a:noFill/>
         </p:spPr>
         <p:txBody>
-          <a:bodyPr wrap="square">
-            <a:spAutoFit/>
-          </a:bodyPr>
-          <a:lstStyle/>
-          <a:p>
-            <a:pPr>
+          <a:bodyPr wrap="square"/>
+          <a:lstStyle/>
+          <a:p>
+            <a:pPr algn="l">
+              <a:spcBef>
+                <a:spcPts val="0"/>
+              </a:spcBef>
               <a:spcAft>
-                <a:spcPts val="600"/>
+                <a:spcPts val="0"/>
               </a:spcAft>
             </a:pPr>
             <a:r>
+              <a:rPr sz="1100" b="1">
+                <a:solidFill>
+                  <a:srgbClr val="8E2F28"/>
+                </a:solidFill>
+                <a:latin typeface="Calibri"/>
+              </a:rPr>
+              <a:t>ECO346  ASSIGNMENT 1</a:t>
+            </a:r>
+          </a:p>
+        </p:txBody>
+      </p:sp>
+      <p:sp>
+        <p:nvSpPr>
+          <p:cNvPr id="6" name="TextBox 5"/>
+          <p:cNvSpPr txBox="1"/>
+          <p:nvPr/>
+        </p:nvSpPr>
+        <p:spPr>
+          <a:xfrm>
+            <a:off x="411480" y="438912"/>
+            <a:ext cx="8412480" cy="658368"/>
+          </a:xfrm>
+          <a:prstGeom prst="rect">
+            <a:avLst/>
+          </a:prstGeom>
+          <a:noFill/>
+        </p:spPr>
+        <p:txBody>
+          <a:bodyPr wrap="square"/>
+          <a:lstStyle/>
+          <a:p>
+            <a:pPr algn="l">
+              <a:spcBef>
+                <a:spcPts val="0"/>
+              </a:spcBef>
+              <a:spcAft>
+                <a:spcPts val="0"/>
+              </a:spcAft>
+            </a:pPr>
+            <a:r>
+              <a:rPr sz="2600" b="1">
+                <a:solidFill>
+                  <a:srgbClr val="2A241F"/>
+                </a:solidFill>
+                <a:latin typeface="Georgia"/>
+              </a:rPr>
+              <a:t>Variant 5: urban Khyber Pakhtunkhwa</a:t>
+            </a:r>
+          </a:p>
+        </p:txBody>
+      </p:sp>
+      <p:sp>
+        <p:nvSpPr>
+          <p:cNvPr id="7" name="TextBox 6"/>
+          <p:cNvSpPr txBox="1"/>
+          <p:nvPr/>
+        </p:nvSpPr>
+        <p:spPr>
+          <a:xfrm>
+            <a:off x="411480" y="1042415"/>
+            <a:ext cx="8412480" cy="329184"/>
+          </a:xfrm>
+          <a:prstGeom prst="rect">
+            <a:avLst/>
+          </a:prstGeom>
+          <a:noFill/>
+        </p:spPr>
+        <p:txBody>
+          <a:bodyPr wrap="square"/>
+          <a:lstStyle/>
+          <a:p>
+            <a:pPr algn="l">
+              <a:spcBef>
+                <a:spcPts val="0"/>
+              </a:spcBef>
+              <a:spcAft>
+                <a:spcPts val="0"/>
+              </a:spcAft>
+            </a:pPr>
+            <a:r>
+              <a:rPr sz="1300" b="0">
+                <a:solidFill>
+                  <a:srgbClr val="5E564C"/>
+                </a:solidFill>
+                <a:latin typeface="Calibri"/>
+              </a:rPr>
+              <a:t>PSLM 2019-20 person file, joined to households by hhid; estimates weighted by hhweight.</a:t>
+            </a:r>
+          </a:p>
+        </p:txBody>
+      </p:sp>
+      <p:sp>
+        <p:nvSpPr>
+          <p:cNvPr id="8" name="Rectangle 7"/>
+          <p:cNvSpPr/>
+          <p:nvPr/>
+        </p:nvSpPr>
+        <p:spPr>
+          <a:xfrm>
+            <a:off x="411480" y="1536192"/>
+            <a:ext cx="2697480" cy="2926080"/>
+          </a:xfrm>
+          <a:prstGeom prst="rect">
+            <a:avLst/>
+          </a:prstGeom>
+          <a:solidFill>
+            <a:srgbClr val="FBF7F0"/>
+          </a:solidFill>
+          <a:ln w="9525">
+            <a:solidFill>
+              <a:srgbClr val="D4C8B4"/>
+            </a:solidFill>
+          </a:ln>
+          <a:effectLst/>
+        </p:spPr>
+        <p:style>
+          <a:lnRef idx="1">
+            <a:schemeClr val="accent1"/>
+          </a:lnRef>
+          <a:fillRef idx="3">
+            <a:schemeClr val="accent1"/>
+          </a:fillRef>
+          <a:effectRef idx="2">
+            <a:schemeClr val="accent1"/>
+          </a:effectRef>
+          <a:fontRef idx="minor">
+            <a:schemeClr val="lt1"/>
+          </a:fontRef>
+        </p:style>
+        <p:txBody>
+          <a:bodyPr rtlCol="0" anchor="ctr"/>
+          <a:lstStyle/>
+          <a:p>
+            <a:pPr algn="ctr"/>
+          </a:p>
+        </p:txBody>
+      </p:sp>
+      <p:sp>
+        <p:nvSpPr>
+          <p:cNvPr id="9" name="Rectangle 8"/>
+          <p:cNvSpPr/>
+          <p:nvPr/>
+        </p:nvSpPr>
+        <p:spPr>
+          <a:xfrm>
+            <a:off x="411480" y="1536192"/>
+            <a:ext cx="82296" cy="2926080"/>
+          </a:xfrm>
+          <a:prstGeom prst="rect">
+            <a:avLst/>
+          </a:prstGeom>
+          <a:solidFill>
+            <a:srgbClr val="B88A3A"/>
+          </a:solidFill>
+          <a:ln>
+            <a:noFill/>
+          </a:ln>
+          <a:effectLst/>
+        </p:spPr>
+        <p:style>
+          <a:lnRef idx="1">
+            <a:schemeClr val="accent1"/>
+          </a:lnRef>
+          <a:fillRef idx="3">
+            <a:schemeClr val="accent1"/>
+          </a:fillRef>
+          <a:effectRef idx="2">
+            <a:schemeClr val="accent1"/>
+          </a:effectRef>
+          <a:fontRef idx="minor">
+            <a:schemeClr val="lt1"/>
+          </a:fontRef>
+        </p:style>
+        <p:txBody>
+          <a:bodyPr rtlCol="0" anchor="ctr"/>
+          <a:lstStyle/>
+          <a:p>
+            <a:pPr algn="ctr"/>
+          </a:p>
+        </p:txBody>
+      </p:sp>
+      <p:sp>
+        <p:nvSpPr>
+          <p:cNvPr id="10" name="TextBox 9"/>
+          <p:cNvSpPr txBox="1"/>
+          <p:nvPr/>
+        </p:nvSpPr>
+        <p:spPr>
+          <a:xfrm>
+            <a:off x="612648" y="1700784"/>
+            <a:ext cx="2368296" cy="256032"/>
+          </a:xfrm>
+          <a:prstGeom prst="rect">
+            <a:avLst/>
+          </a:prstGeom>
+          <a:noFill/>
+        </p:spPr>
+        <p:txBody>
+          <a:bodyPr wrap="square"/>
+          <a:lstStyle/>
+          <a:p>
+            <a:pPr algn="l">
+              <a:spcBef>
+                <a:spcPts val="0"/>
+              </a:spcBef>
+              <a:spcAft>
+                <a:spcPts val="0"/>
+              </a:spcAft>
+            </a:pPr>
+            <a:r>
+              <a:rPr sz="1100" b="1">
+                <a:solidFill>
+                  <a:srgbClr val="8E2F28"/>
+                </a:solidFill>
+                <a:latin typeface="Calibri"/>
+              </a:rPr>
+              <a:t>WHO</a:t>
+            </a:r>
+          </a:p>
+        </p:txBody>
+      </p:sp>
+      <p:sp>
+        <p:nvSpPr>
+          <p:cNvPr id="11" name="TextBox 10"/>
+          <p:cNvSpPr txBox="1"/>
+          <p:nvPr/>
+        </p:nvSpPr>
+        <p:spPr>
+          <a:xfrm>
+            <a:off x="612648" y="1956816"/>
+            <a:ext cx="2368296" cy="384048"/>
+          </a:xfrm>
+          <a:prstGeom prst="rect">
+            <a:avLst/>
+          </a:prstGeom>
+          <a:noFill/>
+        </p:spPr>
+        <p:txBody>
+          <a:bodyPr wrap="square"/>
+          <a:lstStyle/>
+          <a:p>
+            <a:pPr algn="l">
+              <a:spcBef>
+                <a:spcPts val="0"/>
+              </a:spcBef>
+              <a:spcAft>
+                <a:spcPts val="0"/>
+              </a:spcAft>
+            </a:pPr>
+            <a:r>
               <a:rPr sz="1800" b="1">
                 <a:solidFill>
-                  <a:srgbClr val="1F3B6E"/>
-                </a:solidFill>
-              </a:rPr>
-              <a:t>Registration number</a:t>
-            </a:r>
-          </a:p>
-          <a:p>
-            <a:r>
-              <a:rPr sz="1400">
-                <a:solidFill>
-                  <a:srgbClr val="555555"/>
-                </a:solidFill>
+                  <a:srgbClr val="2A241F"/>
+                </a:solidFill>
+                <a:latin typeface="Georgia"/>
               </a:rPr>
               <a:t>FA24-BEDS-105</a:t>
             </a:r>
           </a:p>
-          <a:p>
-            <a:pPr>
+        </p:txBody>
+      </p:sp>
+      <p:sp>
+        <p:nvSpPr>
+          <p:cNvPr id="12" name="TextBox 11"/>
+          <p:cNvSpPr txBox="1"/>
+          <p:nvPr/>
+        </p:nvSpPr>
+        <p:spPr>
+          <a:xfrm>
+            <a:off x="612648" y="2414016"/>
+            <a:ext cx="2368296" cy="1883665"/>
+          </a:xfrm>
+          <a:prstGeom prst="rect">
+            <a:avLst/>
+          </a:prstGeom>
+          <a:noFill/>
+        </p:spPr>
+        <p:txBody>
+          <a:bodyPr wrap="square"/>
+          <a:lstStyle/>
+          <a:p>
+            <a:pPr algn="l">
+              <a:spcBef>
+                <a:spcPts val="0"/>
+              </a:spcBef>
               <a:spcAft>
-                <a:spcPts val="600"/>
+                <a:spcPts val="0"/>
               </a:spcAft>
             </a:pPr>
             <a:r>
-              <a:rPr sz="1800" b="1">
-                <a:solidFill>
-                  <a:srgbClr val="1F3B6E"/>
-                </a:solidFill>
+              <a:rPr sz="1300" b="0">
+                <a:solidFill>
+                  <a:srgbClr val="5E564C"/>
+                </a:solidFill>
+                <a:latin typeface="Calibri"/>
               </a:rPr>
-              <a:t>Variant</a:t>
-            </a:r>
-          </a:p>
-          <a:p>
-            <a:r>
-              <a:rPr sz="1400">
-                <a:solidFill>
-                  <a:srgbClr val="555555"/>
-                </a:solidFill>
-              </a:rPr>
-              <a:t>5 = Khyber Pakhtunkhwa, urban  (prov_code 1, urban_rural 2)</a:t>
-            </a:r>
-          </a:p>
-          <a:p>
-            <a:pPr>
+              <a:t>Remainder of 05 ÷ 8 is 5.
+Province code 1, urban_rural 2.
+Work only with KP urban persons.</a:t>
+            </a:r>
+          </a:p>
+        </p:txBody>
+      </p:sp>
+      <p:sp>
+        <p:nvSpPr>
+          <p:cNvPr id="13" name="Rectangle 12"/>
+          <p:cNvSpPr/>
+          <p:nvPr/>
+        </p:nvSpPr>
+        <p:spPr>
+          <a:xfrm>
+            <a:off x="3218688" y="1536192"/>
+            <a:ext cx="2697480" cy="2926080"/>
+          </a:xfrm>
+          <a:prstGeom prst="rect">
+            <a:avLst/>
+          </a:prstGeom>
+          <a:solidFill>
+            <a:srgbClr val="FBF7F0"/>
+          </a:solidFill>
+          <a:ln w="9525">
+            <a:solidFill>
+              <a:srgbClr val="D4C8B4"/>
+            </a:solidFill>
+          </a:ln>
+          <a:effectLst/>
+        </p:spPr>
+        <p:style>
+          <a:lnRef idx="1">
+            <a:schemeClr val="accent1"/>
+          </a:lnRef>
+          <a:fillRef idx="3">
+            <a:schemeClr val="accent1"/>
+          </a:fillRef>
+          <a:effectRef idx="2">
+            <a:schemeClr val="accent1"/>
+          </a:effectRef>
+          <a:fontRef idx="minor">
+            <a:schemeClr val="lt1"/>
+          </a:fontRef>
+        </p:style>
+        <p:txBody>
+          <a:bodyPr rtlCol="0" anchor="ctr"/>
+          <a:lstStyle/>
+          <a:p>
+            <a:pPr algn="ctr"/>
+          </a:p>
+        </p:txBody>
+      </p:sp>
+      <p:sp>
+        <p:nvSpPr>
+          <p:cNvPr id="14" name="Rectangle 13"/>
+          <p:cNvSpPr/>
+          <p:nvPr/>
+        </p:nvSpPr>
+        <p:spPr>
+          <a:xfrm>
+            <a:off x="3218688" y="1536192"/>
+            <a:ext cx="82296" cy="2926080"/>
+          </a:xfrm>
+          <a:prstGeom prst="rect">
+            <a:avLst/>
+          </a:prstGeom>
+          <a:solidFill>
+            <a:srgbClr val="B88A3A"/>
+          </a:solidFill>
+          <a:ln>
+            <a:noFill/>
+          </a:ln>
+          <a:effectLst/>
+        </p:spPr>
+        <p:style>
+          <a:lnRef idx="1">
+            <a:schemeClr val="accent1"/>
+          </a:lnRef>
+          <a:fillRef idx="3">
+            <a:schemeClr val="accent1"/>
+          </a:fillRef>
+          <a:effectRef idx="2">
+            <a:schemeClr val="accent1"/>
+          </a:effectRef>
+          <a:fontRef idx="minor">
+            <a:schemeClr val="lt1"/>
+          </a:fontRef>
+        </p:style>
+        <p:txBody>
+          <a:bodyPr rtlCol="0" anchor="ctr"/>
+          <a:lstStyle/>
+          <a:p>
+            <a:pPr algn="ctr"/>
+          </a:p>
+        </p:txBody>
+      </p:sp>
+      <p:sp>
+        <p:nvSpPr>
+          <p:cNvPr id="15" name="TextBox 14"/>
+          <p:cNvSpPr txBox="1"/>
+          <p:nvPr/>
+        </p:nvSpPr>
+        <p:spPr>
+          <a:xfrm>
+            <a:off x="3419856" y="1700784"/>
+            <a:ext cx="2368296" cy="256032"/>
+          </a:xfrm>
+          <a:prstGeom prst="rect">
+            <a:avLst/>
+          </a:prstGeom>
+          <a:noFill/>
+        </p:spPr>
+        <p:txBody>
+          <a:bodyPr wrap="square"/>
+          <a:lstStyle/>
+          <a:p>
+            <a:pPr algn="l">
+              <a:spcBef>
+                <a:spcPts val="0"/>
+              </a:spcBef>
               <a:spcAft>
-                <a:spcPts val="600"/>
+                <a:spcPts val="0"/>
               </a:spcAft>
             </a:pPr>
             <a:r>
-              <a:rPr sz="1800" b="1">
-                <a:solidFill>
-                  <a:srgbClr val="1F3B6E"/>
-                </a:solidFill>
+              <a:rPr sz="1100" b="1">
+                <a:solidFill>
+                  <a:srgbClr val="8E2F28"/>
+                </a:solidFill>
+                <a:latin typeface="Calibri"/>
               </a:rPr>
-              <a:t>Data</a:t>
-            </a:r>
-          </a:p>
-          <a:p>
-            <a:r>
-              <a:rPr sz="1400">
-                <a:solidFill>
-                  <a:srgbClr val="555555"/>
-                </a:solidFill>
-              </a:rPr>
-              <a:t>PSLM 2019-20 person and household files; Population estimates weighted by hhweight</a:t>
-            </a:r>
-          </a:p>
-          <a:p>
-            <a:pPr>
+              <a:t>TWO SAMPLES</a:t>
+            </a:r>
+          </a:p>
+        </p:txBody>
+      </p:sp>
+      <p:sp>
+        <p:nvSpPr>
+          <p:cNvPr id="16" name="TextBox 15"/>
+          <p:cNvSpPr txBox="1"/>
+          <p:nvPr/>
+        </p:nvSpPr>
+        <p:spPr>
+          <a:xfrm>
+            <a:off x="3419856" y="1956816"/>
+            <a:ext cx="2368296" cy="384048"/>
+          </a:xfrm>
+          <a:prstGeom prst="rect">
+            <a:avLst/>
+          </a:prstGeom>
+          <a:noFill/>
+        </p:spPr>
+        <p:txBody>
+          <a:bodyPr wrap="square"/>
+          <a:lstStyle/>
+          <a:p>
+            <a:pPr algn="l">
+              <a:spcBef>
+                <a:spcPts val="0"/>
+              </a:spcBef>
               <a:spcAft>
-                <a:spcPts val="600"/>
+                <a:spcPts val="0"/>
               </a:spcAft>
             </a:pPr>
             <a:r>
               <a:rPr sz="1800" b="1">
                 <a:solidFill>
-                  <a:srgbClr val="1F3B6E"/>
-                </a:solidFill>
+                  <a:srgbClr val="2A241F"/>
+                </a:solidFill>
+                <a:latin typeface="Georgia"/>
               </a:rPr>
-              <a:t>Deliverables</a:t>
-            </a:r>
-          </a:p>
-          <a:p>
-            <a:r>
-              <a:rPr sz="1400">
-                <a:solidFill>
-                  <a:srgbClr val="555555"/>
-                </a:solidFill>
+              <a:t>Literacy and spending</a:t>
+            </a:r>
+          </a:p>
+        </p:txBody>
+      </p:sp>
+      <p:sp>
+        <p:nvSpPr>
+          <p:cNvPr id="17" name="TextBox 16"/>
+          <p:cNvSpPr txBox="1"/>
+          <p:nvPr/>
+        </p:nvSpPr>
+        <p:spPr>
+          <a:xfrm>
+            <a:off x="3419856" y="2414016"/>
+            <a:ext cx="2368296" cy="1883665"/>
+          </a:xfrm>
+          <a:prstGeom prst="rect">
+            <a:avLst/>
+          </a:prstGeom>
+          <a:noFill/>
+        </p:spPr>
+        <p:txBody>
+          <a:bodyPr wrap="square"/>
+          <a:lstStyle/>
+          <a:p>
+            <a:pPr algn="l">
+              <a:spcBef>
+                <a:spcPts val="0"/>
+              </a:spcBef>
+              <a:spcAft>
+                <a:spcPts val="0"/>
+              </a:spcAft>
+            </a:pPr>
+            <a:r>
+              <a:rPr sz="1300" b="0">
+                <a:solidFill>
+                  <a:srgbClr val="5E564C"/>
+                </a:solidFill>
+                <a:latin typeface="Calibri"/>
               </a:rPr>
-              <a:t>Two figures in R, a makeover, and the band table reproduced in Python</a:t>
+              <a:t>Literacy: ages 10-64, literate not missing (n = 2,357).
+Students: annual ed_total &gt; 0 (n = 1,061). One student outside Rs 100-Rs 1,000,000 is dropped from the histogram.</a:t>
+            </a:r>
+          </a:p>
+        </p:txBody>
+      </p:sp>
+      <p:sp>
+        <p:nvSpPr>
+          <p:cNvPr id="18" name="Rectangle 17"/>
+          <p:cNvSpPr/>
+          <p:nvPr/>
+        </p:nvSpPr>
+        <p:spPr>
+          <a:xfrm>
+            <a:off x="6035040" y="1536192"/>
+            <a:ext cx="2697480" cy="2926080"/>
+          </a:xfrm>
+          <a:prstGeom prst="rect">
+            <a:avLst/>
+          </a:prstGeom>
+          <a:solidFill>
+            <a:srgbClr val="FBF7F0"/>
+          </a:solidFill>
+          <a:ln w="9525">
+            <a:solidFill>
+              <a:srgbClr val="D4C8B4"/>
+            </a:solidFill>
+          </a:ln>
+          <a:effectLst/>
+        </p:spPr>
+        <p:style>
+          <a:lnRef idx="1">
+            <a:schemeClr val="accent1"/>
+          </a:lnRef>
+          <a:fillRef idx="3">
+            <a:schemeClr val="accent1"/>
+          </a:fillRef>
+          <a:effectRef idx="2">
+            <a:schemeClr val="accent1"/>
+          </a:effectRef>
+          <a:fontRef idx="minor">
+            <a:schemeClr val="lt1"/>
+          </a:fontRef>
+        </p:style>
+        <p:txBody>
+          <a:bodyPr rtlCol="0" anchor="ctr"/>
+          <a:lstStyle/>
+          <a:p>
+            <a:pPr algn="ctr"/>
+          </a:p>
+        </p:txBody>
+      </p:sp>
+      <p:sp>
+        <p:nvSpPr>
+          <p:cNvPr id="19" name="Rectangle 18"/>
+          <p:cNvSpPr/>
+          <p:nvPr/>
+        </p:nvSpPr>
+        <p:spPr>
+          <a:xfrm>
+            <a:off x="6035040" y="1536192"/>
+            <a:ext cx="82296" cy="2926080"/>
+          </a:xfrm>
+          <a:prstGeom prst="rect">
+            <a:avLst/>
+          </a:prstGeom>
+          <a:solidFill>
+            <a:srgbClr val="B88A3A"/>
+          </a:solidFill>
+          <a:ln>
+            <a:noFill/>
+          </a:ln>
+          <a:effectLst/>
+        </p:spPr>
+        <p:style>
+          <a:lnRef idx="1">
+            <a:schemeClr val="accent1"/>
+          </a:lnRef>
+          <a:fillRef idx="3">
+            <a:schemeClr val="accent1"/>
+          </a:fillRef>
+          <a:effectRef idx="2">
+            <a:schemeClr val="accent1"/>
+          </a:effectRef>
+          <a:fontRef idx="minor">
+            <a:schemeClr val="lt1"/>
+          </a:fontRef>
+        </p:style>
+        <p:txBody>
+          <a:bodyPr rtlCol="0" anchor="ctr"/>
+          <a:lstStyle/>
+          <a:p>
+            <a:pPr algn="ctr"/>
+          </a:p>
+        </p:txBody>
+      </p:sp>
+      <p:sp>
+        <p:nvSpPr>
+          <p:cNvPr id="20" name="TextBox 19"/>
+          <p:cNvSpPr txBox="1"/>
+          <p:nvPr/>
+        </p:nvSpPr>
+        <p:spPr>
+          <a:xfrm>
+            <a:off x="6236208" y="1700784"/>
+            <a:ext cx="2368296" cy="256032"/>
+          </a:xfrm>
+          <a:prstGeom prst="rect">
+            <a:avLst/>
+          </a:prstGeom>
+          <a:noFill/>
+        </p:spPr>
+        <p:txBody>
+          <a:bodyPr wrap="square"/>
+          <a:lstStyle/>
+          <a:p>
+            <a:pPr algn="l">
+              <a:spcBef>
+                <a:spcPts val="0"/>
+              </a:spcBef>
+              <a:spcAft>
+                <a:spcPts val="0"/>
+              </a:spcAft>
+            </a:pPr>
+            <a:r>
+              <a:rPr sz="1100" b="1">
+                <a:solidFill>
+                  <a:srgbClr val="8E2F28"/>
+                </a:solidFill>
+                <a:latin typeface="Calibri"/>
+              </a:rPr>
+              <a:t>FIGURES</a:t>
+            </a:r>
+          </a:p>
+        </p:txBody>
+      </p:sp>
+      <p:sp>
+        <p:nvSpPr>
+          <p:cNvPr id="21" name="TextBox 20"/>
+          <p:cNvSpPr txBox="1"/>
+          <p:nvPr/>
+        </p:nvSpPr>
+        <p:spPr>
+          <a:xfrm>
+            <a:off x="6236208" y="1956816"/>
+            <a:ext cx="2368296" cy="384048"/>
+          </a:xfrm>
+          <a:prstGeom prst="rect">
+            <a:avLst/>
+          </a:prstGeom>
+          <a:noFill/>
+        </p:spPr>
+        <p:txBody>
+          <a:bodyPr wrap="square"/>
+          <a:lstStyle/>
+          <a:p>
+            <a:pPr algn="l">
+              <a:spcBef>
+                <a:spcPts val="0"/>
+              </a:spcBef>
+              <a:spcAft>
+                <a:spcPts val="0"/>
+              </a:spcAft>
+            </a:pPr>
+            <a:r>
+              <a:rPr sz="1800" b="1">
+                <a:solidFill>
+                  <a:srgbClr val="2A241F"/>
+                </a:solidFill>
+                <a:latin typeface="Georgia"/>
+              </a:rPr>
+              <a:t>R, then Python</a:t>
+            </a:r>
+          </a:p>
+        </p:txBody>
+      </p:sp>
+      <p:sp>
+        <p:nvSpPr>
+          <p:cNvPr id="22" name="TextBox 21"/>
+          <p:cNvSpPr txBox="1"/>
+          <p:nvPr/>
+        </p:nvSpPr>
+        <p:spPr>
+          <a:xfrm>
+            <a:off x="6236208" y="2414016"/>
+            <a:ext cx="2368296" cy="1883665"/>
+          </a:xfrm>
+          <a:prstGeom prst="rect">
+            <a:avLst/>
+          </a:prstGeom>
+          <a:noFill/>
+        </p:spPr>
+        <p:txBody>
+          <a:bodyPr wrap="square"/>
+          <a:lstStyle/>
+          <a:p>
+            <a:pPr algn="l">
+              <a:spcBef>
+                <a:spcPts val="0"/>
+              </a:spcBef>
+              <a:spcAft>
+                <a:spcPts val="0"/>
+              </a:spcAft>
+            </a:pPr>
+            <a:r>
+              <a:rPr sz="1300" b="0">
+                <a:solidFill>
+                  <a:srgbClr val="5E564C"/>
+                </a:solidFill>
+                <a:latin typeface="Calibri"/>
+              </a:rPr>
+              <a:t>Default scatter committed first. Redesign is literacy by age. Histogram of education spending. Band table redrawn in Python; rates agree to one decimal.</a:t>
+            </a:r>
+          </a:p>
+        </p:txBody>
+      </p:sp>
+      <p:sp>
+        <p:nvSpPr>
+          <p:cNvPr id="23" name="TextBox 22"/>
+          <p:cNvSpPr txBox="1"/>
+          <p:nvPr/>
+        </p:nvSpPr>
+        <p:spPr>
+          <a:xfrm>
+            <a:off x="411480" y="4617720"/>
+            <a:ext cx="8321040" cy="1737360"/>
+          </a:xfrm>
+          <a:prstGeom prst="rect">
+            <a:avLst/>
+          </a:prstGeom>
+          <a:noFill/>
+        </p:spPr>
+        <p:txBody>
+          <a:bodyPr wrap="square"/>
+          <a:lstStyle/>
+          <a:p>
+            <a:pPr algn="l">
+              <a:spcBef>
+                <a:spcPts val="0"/>
+              </a:spcBef>
+              <a:spcAft>
+                <a:spcPts val="0"/>
+              </a:spcAft>
+            </a:pPr>
+            <a:r>
+              <a:rPr sz="1600" b="0">
+                <a:solidFill>
+                  <a:srgbClr val="2A241F"/>
+                </a:solidFill>
+                <a:latin typeface="Georgia"/>
+              </a:rPr>
+              <a:t>Today: the makeover, then one finding — the gender gap in literacy is widest at ages 40-44 (47.4 points).</a:t>
             </a:r>
           </a:p>
         </p:txBody>
@@ -3259,6 +4023,14 @@
 <file path=ppt/slides/slide2.xml><?xml version="1.0" encoding="utf-8"?>
 <p:sld xmlns:a="http://schemas.openxmlformats.org/drawingml/2006/main" xmlns:p="http://schemas.openxmlformats.org/presentationml/2006/main" xmlns:r="http://schemas.openxmlformats.org/officeDocument/2006/relationships">
   <p:cSld>
+    <p:bg>
+      <p:bgPr>
+        <a:solidFill>
+          <a:srgbClr val="F3ECDF"/>
+        </a:solidFill>
+        <a:effectLst/>
+      </p:bgPr>
+    </p:bg>
     <p:spTree>
       <p:nvGrpSpPr>
         <p:cNvPr id="1" name=""/>
@@ -3268,14 +4040,102 @@
       <p:grpSpPr/>
       <p:sp>
         <p:nvSpPr>
-          <p:cNvPr id="2" name="TextBox 1"/>
+          <p:cNvPr id="2" name="Rectangle 1"/>
+          <p:cNvSpPr/>
+          <p:nvPr/>
+        </p:nvSpPr>
+        <p:spPr>
+          <a:xfrm>
+            <a:off x="0" y="0"/>
+            <a:ext cx="164592" cy="6858000"/>
+          </a:xfrm>
+          <a:prstGeom prst="rect">
+            <a:avLst/>
+          </a:prstGeom>
+          <a:solidFill>
+            <a:srgbClr val="8E2F28"/>
+          </a:solidFill>
+          <a:ln>
+            <a:noFill/>
+          </a:ln>
+          <a:effectLst/>
+        </p:spPr>
+        <p:style>
+          <a:lnRef idx="1">
+            <a:schemeClr val="accent1"/>
+          </a:lnRef>
+          <a:fillRef idx="3">
+            <a:schemeClr val="accent1"/>
+          </a:fillRef>
+          <a:effectRef idx="2">
+            <a:schemeClr val="accent1"/>
+          </a:effectRef>
+          <a:fontRef idx="minor">
+            <a:schemeClr val="lt1"/>
+          </a:fontRef>
+        </p:style>
+        <p:txBody>
+          <a:bodyPr rtlCol="0" anchor="ctr"/>
+          <a:lstStyle/>
+          <a:p>
+            <a:pPr algn="ctr"/>
+          </a:p>
+        </p:txBody>
+      </p:sp>
+      <p:sp>
+        <p:nvSpPr>
+          <p:cNvPr id="3" name="Rectangle 2"/>
+          <p:cNvSpPr/>
+          <p:nvPr/>
+        </p:nvSpPr>
+        <p:spPr>
+          <a:xfrm>
+            <a:off x="164592" y="6565392"/>
+            <a:ext cx="8979408" cy="292608"/>
+          </a:xfrm>
+          <a:prstGeom prst="rect">
+            <a:avLst/>
+          </a:prstGeom>
+          <a:solidFill>
+            <a:srgbClr val="2E4A3F"/>
+          </a:solidFill>
+          <a:ln>
+            <a:noFill/>
+          </a:ln>
+          <a:effectLst/>
+        </p:spPr>
+        <p:style>
+          <a:lnRef idx="1">
+            <a:schemeClr val="accent1"/>
+          </a:lnRef>
+          <a:fillRef idx="3">
+            <a:schemeClr val="accent1"/>
+          </a:fillRef>
+          <a:effectRef idx="2">
+            <a:schemeClr val="accent1"/>
+          </a:effectRef>
+          <a:fontRef idx="minor">
+            <a:schemeClr val="lt1"/>
+          </a:fontRef>
+        </p:style>
+        <p:txBody>
+          <a:bodyPr rtlCol="0" anchor="ctr"/>
+          <a:lstStyle/>
+          <a:p>
+            <a:pPr algn="ctr"/>
+          </a:p>
+        </p:txBody>
+      </p:sp>
+      <p:sp>
+        <p:nvSpPr>
+          <p:cNvPr id="4" name="TextBox 3"/>
           <p:cNvSpPr txBox="1"/>
           <p:nvPr/>
         </p:nvSpPr>
         <p:spPr>
           <a:xfrm>
-            <a:off x="502920" y="274320"/>
-            <a:ext cx="8229600" cy="822960"/>
+            <a:off x="411480" y="6565392"/>
+            <a:ext cx="8412480" cy="292608"/>
           </a:xfrm>
           <a:prstGeom prst="rect">
             <a:avLst/>
@@ -3283,27 +4143,145 @@
           <a:noFill/>
         </p:spPr>
         <p:txBody>
-          <a:bodyPr wrap="square">
-            <a:spAutoFit/>
-          </a:bodyPr>
-          <a:lstStyle/>
-          <a:p>
-            <a:pPr>
-              <a:defRPr sz="2200" b="1">
-                <a:solidFill>
-                  <a:srgbClr val="1F3B6E"/>
-                </a:solidFill>
-              </a:defRPr>
+          <a:bodyPr wrap="square"/>
+          <a:lstStyle/>
+          <a:p>
+            <a:pPr algn="l"/>
+            <a:r>
+              <a:rPr sz="1000" b="0">
+                <a:solidFill>
+                  <a:srgbClr val="F3ECDF"/>
+                </a:solidFill>
+                <a:latin typeface="Calibri"/>
+              </a:rPr>
+              <a:t>ECO346  ·  FA24-BEDS-105  ·  Variant 5, KP urban  ·  PSLM 2019-20</a:t>
+            </a:r>
+          </a:p>
+        </p:txBody>
+      </p:sp>
+      <p:sp>
+        <p:nvSpPr>
+          <p:cNvPr id="5" name="TextBox 4"/>
+          <p:cNvSpPr txBox="1"/>
+          <p:nvPr/>
+        </p:nvSpPr>
+        <p:spPr>
+          <a:xfrm>
+            <a:off x="438912" y="201168"/>
+            <a:ext cx="8321040" cy="292608"/>
+          </a:xfrm>
+          <a:prstGeom prst="rect">
+            <a:avLst/>
+          </a:prstGeom>
+          <a:noFill/>
+        </p:spPr>
+        <p:txBody>
+          <a:bodyPr wrap="square"/>
+          <a:lstStyle/>
+          <a:p>
+            <a:pPr algn="l">
+              <a:spcBef>
+                <a:spcPts val="0"/>
+              </a:spcBef>
+              <a:spcAft>
+                <a:spcPts val="0"/>
+              </a:spcAft>
             </a:pPr>
             <a:r>
-              <a:t>The makeover: default (left) vs redesign (right)</a:t>
+              <a:rPr sz="1100" b="1">
+                <a:solidFill>
+                  <a:srgbClr val="8E2F28"/>
+                </a:solidFill>
+                <a:latin typeface="Calibri"/>
+              </a:rPr>
+              <a:t>QUESTION 4  ·  THE MAKEOVER</a:t>
+            </a:r>
+          </a:p>
+        </p:txBody>
+      </p:sp>
+      <p:sp>
+        <p:nvSpPr>
+          <p:cNvPr id="6" name="TextBox 5"/>
+          <p:cNvSpPr txBox="1"/>
+          <p:nvPr/>
+        </p:nvSpPr>
+        <p:spPr>
+          <a:xfrm>
+            <a:off x="411480" y="438912"/>
+            <a:ext cx="8412480" cy="658368"/>
+          </a:xfrm>
+          <a:prstGeom prst="rect">
+            <a:avLst/>
+          </a:prstGeom>
+          <a:noFill/>
+        </p:spPr>
+        <p:txBody>
+          <a:bodyPr wrap="square"/>
+          <a:lstStyle/>
+          <a:p>
+            <a:pPr algn="l">
+              <a:spcBef>
+                <a:spcPts val="0"/>
+              </a:spcBef>
+              <a:spcAft>
+                <a:spcPts val="0"/>
+              </a:spcAft>
+            </a:pPr>
+            <a:r>
+              <a:rPr sz="2600" b="1">
+                <a:solidFill>
+                  <a:srgbClr val="2A241F"/>
+                </a:solidFill>
+                <a:latin typeface="Georgia"/>
+              </a:rPr>
+              <a:t>Default scatter, then the redesign</a:t>
+            </a:r>
+          </a:p>
+        </p:txBody>
+      </p:sp>
+      <p:sp>
+        <p:nvSpPr>
+          <p:cNvPr id="7" name="TextBox 6"/>
+          <p:cNvSpPr txBox="1"/>
+          <p:nvPr/>
+        </p:nvSpPr>
+        <p:spPr>
+          <a:xfrm>
+            <a:off x="411480" y="1042415"/>
+            <a:ext cx="8412480" cy="329184"/>
+          </a:xfrm>
+          <a:prstGeom prst="rect">
+            <a:avLst/>
+          </a:prstGeom>
+          <a:noFill/>
+        </p:spPr>
+        <p:txBody>
+          <a:bodyPr wrap="square"/>
+          <a:lstStyle/>
+          <a:p>
+            <a:pPr algn="l">
+              <a:spcBef>
+                <a:spcPts val="0"/>
+              </a:spcBef>
+              <a:spcAft>
+                <a:spcPts val="0"/>
+              </a:spcAft>
+            </a:pPr>
+            <a:r>
+              <a:rPr sz="1300" b="0">
+                <a:solidFill>
+                  <a:srgbClr val="5E564C"/>
+                </a:solidFill>
+                <a:latin typeface="Calibri"/>
+              </a:rPr>
+              <a:t>Same literacy sample. Left is ggplot defaults only. Right is weighted rates by five-year age band.</a:t>
             </a:r>
           </a:p>
         </p:txBody>
       </p:sp>
       <p:pic>
         <p:nvPicPr>
-          <p:cNvPr id="3" name="Picture 2" descr="_default_slide.png"/>
+          <p:cNvPr id="8" name="Picture 7" descr="_default_slide.png"/>
           <p:cNvPicPr>
             <a:picLocks noChangeAspect="1"/>
           </p:cNvPicPr>
@@ -3323,8 +4301,8 @@
         </p:blipFill>
         <p:spPr>
           <a:xfrm>
-            <a:off x="320040" y="1234440"/>
-            <a:ext cx="4114800" cy="2939143"/>
+            <a:off x="365760" y="1417320"/>
+            <a:ext cx="4160520" cy="2971800"/>
           </a:xfrm>
           <a:prstGeom prst="rect">
             <a:avLst/>
@@ -3333,7 +4311,7 @@
       </p:pic>
       <p:pic>
         <p:nvPicPr>
-          <p:cNvPr id="4" name="Picture 3" descr="_literacy_slide.png"/>
+          <p:cNvPr id="9" name="Picture 8" descr="_literacy_slide.png"/>
           <p:cNvPicPr>
             <a:picLocks noChangeAspect="1"/>
           </p:cNvPicPr>
@@ -3353,8 +4331,8 @@
         </p:blipFill>
         <p:spPr>
           <a:xfrm>
-            <a:off x="4709160" y="1234440"/>
-            <a:ext cx="4114800" cy="2662518"/>
+            <a:off x="4617720" y="1417320"/>
+            <a:ext cx="4160520" cy="2692101"/>
           </a:xfrm>
           <a:prstGeom prst="rect">
             <a:avLst/>
@@ -3363,14 +4341,14 @@
       </p:pic>
       <p:sp>
         <p:nvSpPr>
-          <p:cNvPr id="5" name="TextBox 4"/>
+          <p:cNvPr id="10" name="TextBox 9"/>
           <p:cNvSpPr txBox="1"/>
           <p:nvPr/>
         </p:nvSpPr>
         <p:spPr>
           <a:xfrm>
-            <a:off x="548640" y="4526280"/>
-            <a:ext cx="8046720" cy="1097280"/>
+            <a:off x="365760" y="4462272"/>
+            <a:ext cx="4160520" cy="256032"/>
           </a:xfrm>
           <a:prstGeom prst="rect">
             <a:avLst/>
@@ -3378,20 +4356,443 @@
           <a:noFill/>
         </p:spPr>
         <p:txBody>
-          <a:bodyPr wrap="square">
-            <a:spAutoFit/>
-          </a:bodyPr>
-          <a:lstStyle/>
-          <a:p>
-            <a:pPr>
-              <a:defRPr sz="1300">
-                <a:solidFill>
-                  <a:srgbClr val="555555"/>
-                </a:solidFill>
-              </a:defRPr>
+          <a:bodyPr wrap="square"/>
+          <a:lstStyle/>
+          <a:p>
+            <a:pPr algn="ctr">
+              <a:spcBef>
+                <a:spcPts val="0"/>
+              </a:spcBef>
+              <a:spcAft>
+                <a:spcPts val="0"/>
+              </a:spcAft>
             </a:pPr>
             <a:r>
-              <a:t>Default: raw literate-vs-age points, heavily overplotted.  Redesign: weighted literacy by age band, two series, direct end labels, no legend, thin cells hollow, widest gap directly annotated.</a:t>
+              <a:rPr sz="1200" b="1">
+                <a:solidFill>
+                  <a:srgbClr val="5E564C"/>
+                </a:solidFill>
+                <a:latin typeface="Calibri"/>
+              </a:rPr>
+              <a:t>DEFAULT  ·  overplotted 0/1 points</a:t>
+            </a:r>
+          </a:p>
+        </p:txBody>
+      </p:sp>
+      <p:sp>
+        <p:nvSpPr>
+          <p:cNvPr id="11" name="TextBox 10"/>
+          <p:cNvSpPr txBox="1"/>
+          <p:nvPr/>
+        </p:nvSpPr>
+        <p:spPr>
+          <a:xfrm>
+            <a:off x="4617720" y="4462272"/>
+            <a:ext cx="4160520" cy="256032"/>
+          </a:xfrm>
+          <a:prstGeom prst="rect">
+            <a:avLst/>
+          </a:prstGeom>
+          <a:noFill/>
+        </p:spPr>
+        <p:txBody>
+          <a:bodyPr wrap="square"/>
+          <a:lstStyle/>
+          <a:p>
+            <a:pPr algn="ctr">
+              <a:spcBef>
+                <a:spcPts val="0"/>
+              </a:spcBef>
+              <a:spcAft>
+                <a:spcPts val="0"/>
+              </a:spcAft>
+            </a:pPr>
+            <a:r>
+              <a:rPr sz="1200" b="1">
+                <a:solidFill>
+                  <a:srgbClr val="5E564C"/>
+                </a:solidFill>
+                <a:latin typeface="Calibri"/>
+              </a:rPr>
+              <a:t>REDESIGN  ·  conditional means</a:t>
+            </a:r>
+          </a:p>
+        </p:txBody>
+      </p:sp>
+      <p:sp>
+        <p:nvSpPr>
+          <p:cNvPr id="12" name="Rectangle 11"/>
+          <p:cNvSpPr/>
+          <p:nvPr/>
+        </p:nvSpPr>
+        <p:spPr>
+          <a:xfrm>
+            <a:off x="411480" y="4773168"/>
+            <a:ext cx="2697480" cy="1627632"/>
+          </a:xfrm>
+          <a:prstGeom prst="rect">
+            <a:avLst/>
+          </a:prstGeom>
+          <a:solidFill>
+            <a:srgbClr val="FBF7F0"/>
+          </a:solidFill>
+          <a:ln w="9525">
+            <a:solidFill>
+              <a:srgbClr val="D4C8B4"/>
+            </a:solidFill>
+          </a:ln>
+          <a:effectLst/>
+        </p:spPr>
+        <p:style>
+          <a:lnRef idx="1">
+            <a:schemeClr val="accent1"/>
+          </a:lnRef>
+          <a:fillRef idx="3">
+            <a:schemeClr val="accent1"/>
+          </a:fillRef>
+          <a:effectRef idx="2">
+            <a:schemeClr val="accent1"/>
+          </a:effectRef>
+          <a:fontRef idx="minor">
+            <a:schemeClr val="lt1"/>
+          </a:fontRef>
+        </p:style>
+        <p:txBody>
+          <a:bodyPr rtlCol="0" anchor="ctr"/>
+          <a:lstStyle/>
+          <a:p>
+            <a:pPr algn="ctr"/>
+          </a:p>
+        </p:txBody>
+      </p:sp>
+      <p:sp>
+        <p:nvSpPr>
+          <p:cNvPr id="13" name="TextBox 12"/>
+          <p:cNvSpPr txBox="1"/>
+          <p:nvPr/>
+        </p:nvSpPr>
+        <p:spPr>
+          <a:xfrm>
+            <a:off x="539496" y="4864608"/>
+            <a:ext cx="2441448" cy="329184"/>
+          </a:xfrm>
+          <a:prstGeom prst="rect">
+            <a:avLst/>
+          </a:prstGeom>
+          <a:noFill/>
+        </p:spPr>
+        <p:txBody>
+          <a:bodyPr wrap="square"/>
+          <a:lstStyle/>
+          <a:p>
+            <a:pPr algn="l">
+              <a:spcBef>
+                <a:spcPts val="0"/>
+              </a:spcBef>
+              <a:spcAft>
+                <a:spcPts val="0"/>
+              </a:spcAft>
+            </a:pPr>
+            <a:r>
+              <a:rPr sz="1400" b="1">
+                <a:solidFill>
+                  <a:srgbClr val="8E2F28"/>
+                </a:solidFill>
+                <a:latin typeface="Georgia"/>
+              </a:rPr>
+              <a:t>Conditional means</a:t>
+            </a:r>
+          </a:p>
+        </p:txBody>
+      </p:sp>
+      <p:sp>
+        <p:nvSpPr>
+          <p:cNvPr id="14" name="TextBox 13"/>
+          <p:cNvSpPr txBox="1"/>
+          <p:nvPr/>
+        </p:nvSpPr>
+        <p:spPr>
+          <a:xfrm>
+            <a:off x="539496" y="5212080"/>
+            <a:ext cx="2441448" cy="1078992"/>
+          </a:xfrm>
+          <a:prstGeom prst="rect">
+            <a:avLst/>
+          </a:prstGeom>
+          <a:noFill/>
+        </p:spPr>
+        <p:txBody>
+          <a:bodyPr wrap="square"/>
+          <a:lstStyle/>
+          <a:p>
+            <a:pPr algn="l">
+              <a:spcBef>
+                <a:spcPts val="0"/>
+              </a:spcBef>
+              <a:spcAft>
+                <a:spcPts val="0"/>
+              </a:spcAft>
+            </a:pPr>
+            <a:r>
+              <a:rPr sz="1200" b="0">
+                <a:solidFill>
+                  <a:srgbClr val="5E564C"/>
+                </a:solidFill>
+                <a:latin typeface="Calibri"/>
+              </a:rPr>
+              <a:t>Band averages show the age pattern that overlapping dots hide (overplotting).</a:t>
+            </a:r>
+          </a:p>
+        </p:txBody>
+      </p:sp>
+      <p:sp>
+        <p:nvSpPr>
+          <p:cNvPr id="15" name="Rectangle 14"/>
+          <p:cNvSpPr/>
+          <p:nvPr/>
+        </p:nvSpPr>
+        <p:spPr>
+          <a:xfrm>
+            <a:off x="3218688" y="4773168"/>
+            <a:ext cx="2697480" cy="1627632"/>
+          </a:xfrm>
+          <a:prstGeom prst="rect">
+            <a:avLst/>
+          </a:prstGeom>
+          <a:solidFill>
+            <a:srgbClr val="FBF7F0"/>
+          </a:solidFill>
+          <a:ln w="9525">
+            <a:solidFill>
+              <a:srgbClr val="D4C8B4"/>
+            </a:solidFill>
+          </a:ln>
+          <a:effectLst/>
+        </p:spPr>
+        <p:style>
+          <a:lnRef idx="1">
+            <a:schemeClr val="accent1"/>
+          </a:lnRef>
+          <a:fillRef idx="3">
+            <a:schemeClr val="accent1"/>
+          </a:fillRef>
+          <a:effectRef idx="2">
+            <a:schemeClr val="accent1"/>
+          </a:effectRef>
+          <a:fontRef idx="minor">
+            <a:schemeClr val="lt1"/>
+          </a:fontRef>
+        </p:style>
+        <p:txBody>
+          <a:bodyPr rtlCol="0" anchor="ctr"/>
+          <a:lstStyle/>
+          <a:p>
+            <a:pPr algn="ctr"/>
+          </a:p>
+        </p:txBody>
+      </p:sp>
+      <p:sp>
+        <p:nvSpPr>
+          <p:cNvPr id="16" name="TextBox 15"/>
+          <p:cNvSpPr txBox="1"/>
+          <p:nvPr/>
+        </p:nvSpPr>
+        <p:spPr>
+          <a:xfrm>
+            <a:off x="3346704" y="4864608"/>
+            <a:ext cx="2441448" cy="329184"/>
+          </a:xfrm>
+          <a:prstGeom prst="rect">
+            <a:avLst/>
+          </a:prstGeom>
+          <a:noFill/>
+        </p:spPr>
+        <p:txBody>
+          <a:bodyPr wrap="square"/>
+          <a:lstStyle/>
+          <a:p>
+            <a:pPr algn="l">
+              <a:spcBef>
+                <a:spcPts val="0"/>
+              </a:spcBef>
+              <a:spcAft>
+                <a:spcPts val="0"/>
+              </a:spcAft>
+            </a:pPr>
+            <a:r>
+              <a:rPr sz="1400" b="1">
+                <a:solidFill>
+                  <a:srgbClr val="8E2F28"/>
+                </a:solidFill>
+                <a:latin typeface="Georgia"/>
+              </a:rPr>
+              <a:t>Position, then colour</a:t>
+            </a:r>
+          </a:p>
+        </p:txBody>
+      </p:sp>
+      <p:sp>
+        <p:nvSpPr>
+          <p:cNvPr id="17" name="TextBox 16"/>
+          <p:cNvSpPr txBox="1"/>
+          <p:nvPr/>
+        </p:nvSpPr>
+        <p:spPr>
+          <a:xfrm>
+            <a:off x="3346704" y="5212080"/>
+            <a:ext cx="2441448" cy="1078992"/>
+          </a:xfrm>
+          <a:prstGeom prst="rect">
+            <a:avLst/>
+          </a:prstGeom>
+          <a:noFill/>
+        </p:spPr>
+        <p:txBody>
+          <a:bodyPr wrap="square"/>
+          <a:lstStyle/>
+          <a:p>
+            <a:pPr algn="l">
+              <a:spcBef>
+                <a:spcPts val="0"/>
+              </a:spcBef>
+              <a:spcAft>
+                <a:spcPts val="0"/>
+              </a:spcAft>
+            </a:pPr>
+            <a:r>
+              <a:rPr sz="1200" b="0">
+                <a:solidFill>
+                  <a:srgbClr val="5E564C"/>
+                </a:solidFill>
+                <a:latin typeface="Calibri"/>
+              </a:rPr>
+              <a:t>Age and the rate sit on position, the strongest channel. Colour only splits men and women.</a:t>
+            </a:r>
+          </a:p>
+        </p:txBody>
+      </p:sp>
+      <p:sp>
+        <p:nvSpPr>
+          <p:cNvPr id="18" name="Rectangle 17"/>
+          <p:cNvSpPr/>
+          <p:nvPr/>
+        </p:nvSpPr>
+        <p:spPr>
+          <a:xfrm>
+            <a:off x="6035040" y="4773168"/>
+            <a:ext cx="2697480" cy="1627632"/>
+          </a:xfrm>
+          <a:prstGeom prst="rect">
+            <a:avLst/>
+          </a:prstGeom>
+          <a:solidFill>
+            <a:srgbClr val="FBF7F0"/>
+          </a:solidFill>
+          <a:ln w="9525">
+            <a:solidFill>
+              <a:srgbClr val="D4C8B4"/>
+            </a:solidFill>
+          </a:ln>
+          <a:effectLst/>
+        </p:spPr>
+        <p:style>
+          <a:lnRef idx="1">
+            <a:schemeClr val="accent1"/>
+          </a:lnRef>
+          <a:fillRef idx="3">
+            <a:schemeClr val="accent1"/>
+          </a:fillRef>
+          <a:effectRef idx="2">
+            <a:schemeClr val="accent1"/>
+          </a:effectRef>
+          <a:fontRef idx="minor">
+            <a:schemeClr val="lt1"/>
+          </a:fontRef>
+        </p:style>
+        <p:txBody>
+          <a:bodyPr rtlCol="0" anchor="ctr"/>
+          <a:lstStyle/>
+          <a:p>
+            <a:pPr algn="ctr"/>
+          </a:p>
+        </p:txBody>
+      </p:sp>
+      <p:sp>
+        <p:nvSpPr>
+          <p:cNvPr id="19" name="TextBox 18"/>
+          <p:cNvSpPr txBox="1"/>
+          <p:nvPr/>
+        </p:nvSpPr>
+        <p:spPr>
+          <a:xfrm>
+            <a:off x="6163056" y="4864608"/>
+            <a:ext cx="2441448" cy="329184"/>
+          </a:xfrm>
+          <a:prstGeom prst="rect">
+            <a:avLst/>
+          </a:prstGeom>
+          <a:noFill/>
+        </p:spPr>
+        <p:txBody>
+          <a:bodyPr wrap="square"/>
+          <a:lstStyle/>
+          <a:p>
+            <a:pPr algn="l">
+              <a:spcBef>
+                <a:spcPts val="0"/>
+              </a:spcBef>
+              <a:spcAft>
+                <a:spcPts val="0"/>
+              </a:spcAft>
+            </a:pPr>
+            <a:r>
+              <a:rPr sz="1400" b="1">
+                <a:solidFill>
+                  <a:srgbClr val="8E2F28"/>
+                </a:solidFill>
+                <a:latin typeface="Georgia"/>
+              </a:rPr>
+              <a:t>Data-ink</a:t>
+            </a:r>
+          </a:p>
+        </p:txBody>
+      </p:sp>
+      <p:sp>
+        <p:nvSpPr>
+          <p:cNvPr id="20" name="TextBox 19"/>
+          <p:cNvSpPr txBox="1"/>
+          <p:nvPr/>
+        </p:nvSpPr>
+        <p:spPr>
+          <a:xfrm>
+            <a:off x="6163056" y="5212080"/>
+            <a:ext cx="2441448" cy="1078992"/>
+          </a:xfrm>
+          <a:prstGeom prst="rect">
+            <a:avLst/>
+          </a:prstGeom>
+          <a:noFill/>
+        </p:spPr>
+        <p:txBody>
+          <a:bodyPr wrap="square"/>
+          <a:lstStyle/>
+          <a:p>
+            <a:pPr algn="l">
+              <a:spcBef>
+                <a:spcPts val="0"/>
+              </a:spcBef>
+              <a:spcAft>
+                <a:spcPts val="0"/>
+              </a:spcAft>
+            </a:pPr>
+            <a:r>
+              <a:rPr sz="1200" b="0">
+                <a:solidFill>
+                  <a:srgbClr val="5E564C"/>
+                </a:solidFill>
+                <a:latin typeface="Calibri"/>
+              </a:rPr>
+              <a:t>No legend: each series is labelled at its end. Hollow markers would mark thin cells (none here).</a:t>
             </a:r>
           </a:p>
         </p:txBody>
@@ -3407,6 +4808,14 @@
 <file path=ppt/slides/slide3.xml><?xml version="1.0" encoding="utf-8"?>
 <p:sld xmlns:a="http://schemas.openxmlformats.org/drawingml/2006/main" xmlns:p="http://schemas.openxmlformats.org/presentationml/2006/main" xmlns:r="http://schemas.openxmlformats.org/officeDocument/2006/relationships">
   <p:cSld>
+    <p:bg>
+      <p:bgPr>
+        <a:solidFill>
+          <a:srgbClr val="F3ECDF"/>
+        </a:solidFill>
+        <a:effectLst/>
+      </p:bgPr>
+    </p:bg>
     <p:spTree>
       <p:nvGrpSpPr>
         <p:cNvPr id="1" name=""/>
@@ -3416,14 +4825,102 @@
       <p:grpSpPr/>
       <p:sp>
         <p:nvSpPr>
-          <p:cNvPr id="2" name="TextBox 1"/>
+          <p:cNvPr id="2" name="Rectangle 1"/>
+          <p:cNvSpPr/>
+          <p:nvPr/>
+        </p:nvSpPr>
+        <p:spPr>
+          <a:xfrm>
+            <a:off x="0" y="0"/>
+            <a:ext cx="164592" cy="6858000"/>
+          </a:xfrm>
+          <a:prstGeom prst="rect">
+            <a:avLst/>
+          </a:prstGeom>
+          <a:solidFill>
+            <a:srgbClr val="8E2F28"/>
+          </a:solidFill>
+          <a:ln>
+            <a:noFill/>
+          </a:ln>
+          <a:effectLst/>
+        </p:spPr>
+        <p:style>
+          <a:lnRef idx="1">
+            <a:schemeClr val="accent1"/>
+          </a:lnRef>
+          <a:fillRef idx="3">
+            <a:schemeClr val="accent1"/>
+          </a:fillRef>
+          <a:effectRef idx="2">
+            <a:schemeClr val="accent1"/>
+          </a:effectRef>
+          <a:fontRef idx="minor">
+            <a:schemeClr val="lt1"/>
+          </a:fontRef>
+        </p:style>
+        <p:txBody>
+          <a:bodyPr rtlCol="0" anchor="ctr"/>
+          <a:lstStyle/>
+          <a:p>
+            <a:pPr algn="ctr"/>
+          </a:p>
+        </p:txBody>
+      </p:sp>
+      <p:sp>
+        <p:nvSpPr>
+          <p:cNvPr id="3" name="Rectangle 2"/>
+          <p:cNvSpPr/>
+          <p:nvPr/>
+        </p:nvSpPr>
+        <p:spPr>
+          <a:xfrm>
+            <a:off x="164592" y="6565392"/>
+            <a:ext cx="8979408" cy="292608"/>
+          </a:xfrm>
+          <a:prstGeom prst="rect">
+            <a:avLst/>
+          </a:prstGeom>
+          <a:solidFill>
+            <a:srgbClr val="2E4A3F"/>
+          </a:solidFill>
+          <a:ln>
+            <a:noFill/>
+          </a:ln>
+          <a:effectLst/>
+        </p:spPr>
+        <p:style>
+          <a:lnRef idx="1">
+            <a:schemeClr val="accent1"/>
+          </a:lnRef>
+          <a:fillRef idx="3">
+            <a:schemeClr val="accent1"/>
+          </a:fillRef>
+          <a:effectRef idx="2">
+            <a:schemeClr val="accent1"/>
+          </a:effectRef>
+          <a:fontRef idx="minor">
+            <a:schemeClr val="lt1"/>
+          </a:fontRef>
+        </p:style>
+        <p:txBody>
+          <a:bodyPr rtlCol="0" anchor="ctr"/>
+          <a:lstStyle/>
+          <a:p>
+            <a:pPr algn="ctr"/>
+          </a:p>
+        </p:txBody>
+      </p:sp>
+      <p:sp>
+        <p:nvSpPr>
+          <p:cNvPr id="4" name="TextBox 3"/>
           <p:cNvSpPr txBox="1"/>
           <p:nvPr/>
         </p:nvSpPr>
         <p:spPr>
           <a:xfrm>
-            <a:off x="502920" y="274320"/>
-            <a:ext cx="8229600" cy="822960"/>
+            <a:off x="411480" y="6565392"/>
+            <a:ext cx="8412480" cy="292608"/>
           </a:xfrm>
           <a:prstGeom prst="rect">
             <a:avLst/>
@@ -3431,34 +4928,32 @@
           <a:noFill/>
         </p:spPr>
         <p:txBody>
-          <a:bodyPr wrap="square">
-            <a:spAutoFit/>
-          </a:bodyPr>
-          <a:lstStyle/>
-          <a:p>
-            <a:pPr>
-              <a:defRPr sz="2000" b="1">
-                <a:solidFill>
-                  <a:srgbClr val="1F3B6E"/>
-                </a:solidFill>
-              </a:defRPr>
-            </a:pPr>
-            <a:r>
-              <a:t>Key finding: widest gender gap in literacy at ages 40-44</a:t>
-            </a:r>
-          </a:p>
-        </p:txBody>
-      </p:sp>
-      <p:sp>
-        <p:nvSpPr>
-          <p:cNvPr id="3" name="TextBox 2"/>
+          <a:bodyPr wrap="square"/>
+          <a:lstStyle/>
+          <a:p>
+            <a:pPr algn="l"/>
+            <a:r>
+              <a:rPr sz="1000" b="0">
+                <a:solidFill>
+                  <a:srgbClr val="F3ECDF"/>
+                </a:solidFill>
+                <a:latin typeface="Calibri"/>
+              </a:rPr>
+              <a:t>ECO346  ·  FA24-BEDS-105  ·  Variant 5, KP urban  ·  PSLM 2019-20</a:t>
+            </a:r>
+          </a:p>
+        </p:txBody>
+      </p:sp>
+      <p:sp>
+        <p:nvSpPr>
+          <p:cNvPr id="5" name="TextBox 4"/>
           <p:cNvSpPr txBox="1"/>
           <p:nvPr/>
         </p:nvSpPr>
         <p:spPr>
           <a:xfrm>
-            <a:off x="548640" y="1463040"/>
-            <a:ext cx="8046720" cy="4937760"/>
+            <a:off x="438912" y="201168"/>
+            <a:ext cx="8321040" cy="292608"/>
           </a:xfrm>
           <a:prstGeom prst="rect">
             <a:avLst/>
@@ -3466,83 +4961,806 @@
           <a:noFill/>
         </p:spPr>
         <p:txBody>
-          <a:bodyPr wrap="square">
-            <a:spAutoFit/>
-          </a:bodyPr>
-          <a:lstStyle/>
-          <a:p>
-            <a:pPr>
+          <a:bodyPr wrap="square"/>
+          <a:lstStyle/>
+          <a:p>
+            <a:pPr algn="l">
+              <a:spcBef>
+                <a:spcPts val="0"/>
+              </a:spcBef>
               <a:spcAft>
-                <a:spcPts val="600"/>
+                <a:spcPts val="0"/>
               </a:spcAft>
             </a:pPr>
             <a:r>
-              <a:rPr sz="1700" b="1">
-                <a:solidFill>
-                  <a:srgbClr val="1F3B6E"/>
-                </a:solidFill>
+              <a:rPr sz="1100" b="1">
+                <a:solidFill>
+                  <a:srgbClr val="8E2F28"/>
+                </a:solidFill>
+                <a:latin typeface="Calibri"/>
               </a:rPr>
-              <a:t>Women: 68.1% at ages 15-19 vs 16.2% at ages 55-59</a:t>
-            </a:r>
-          </a:p>
-          <a:p>
-            <a:r>
-              <a:rPr sz="1300">
-                <a:solidFill>
-                  <a:srgbClr val="555555"/>
-                </a:solidFill>
-              </a:rPr>
-              <a:t>Men: 89.7% at ages 15-19 vs 58.8% at ages 55-59</a:t>
-            </a:r>
-          </a:p>
-          <a:p>
-            <a:pPr>
+              <a:t>ONE FINDING</a:t>
+            </a:r>
+          </a:p>
+        </p:txBody>
+      </p:sp>
+      <p:sp>
+        <p:nvSpPr>
+          <p:cNvPr id="6" name="TextBox 5"/>
+          <p:cNvSpPr txBox="1"/>
+          <p:nvPr/>
+        </p:nvSpPr>
+        <p:spPr>
+          <a:xfrm>
+            <a:off x="411480" y="438912"/>
+            <a:ext cx="8412480" cy="658368"/>
+          </a:xfrm>
+          <a:prstGeom prst="rect">
+            <a:avLst/>
+          </a:prstGeom>
+          <a:noFill/>
+        </p:spPr>
+        <p:txBody>
+          <a:bodyPr wrap="square"/>
+          <a:lstStyle/>
+          <a:p>
+            <a:pPr algn="l">
+              <a:spcBef>
+                <a:spcPts val="0"/>
+              </a:spcBef>
               <a:spcAft>
-                <a:spcPts val="600"/>
+                <a:spcPts val="0"/>
               </a:spcAft>
             </a:pPr>
             <a:r>
-              <a:rPr sz="1700" b="1">
-                <a:solidFill>
-                  <a:srgbClr val="1F3B6E"/>
-                </a:solidFill>
+              <a:rPr sz="2600" b="1">
+                <a:solidFill>
+                  <a:srgbClr val="2A241F"/>
+                </a:solidFill>
+                <a:latin typeface="Georgia"/>
               </a:rPr>
-              <a:t>Largest gap at ages 40-44: 47.4 percentage points</a:t>
-            </a:r>
-          </a:p>
-          <a:p>
-            <a:r>
-              <a:rPr sz="1300">
-                <a:solidFill>
-                  <a:srgbClr val="555555"/>
-                </a:solidFill>
-              </a:rPr>
-              <a:t>Men 77.1% vs women 29.7% — wider than at 55-59 (42.6 points)</a:t>
-            </a:r>
-          </a:p>
-          <a:p>
-            <a:pPr>
+              <a:t>The gender gap is widest at ages 40-44</a:t>
+            </a:r>
+          </a:p>
+        </p:txBody>
+      </p:sp>
+      <p:sp>
+        <p:nvSpPr>
+          <p:cNvPr id="7" name="TextBox 6"/>
+          <p:cNvSpPr txBox="1"/>
+          <p:nvPr/>
+        </p:nvSpPr>
+        <p:spPr>
+          <a:xfrm>
+            <a:off x="411480" y="1042415"/>
+            <a:ext cx="8412480" cy="329184"/>
+          </a:xfrm>
+          <a:prstGeom prst="rect">
+            <a:avLst/>
+          </a:prstGeom>
+          <a:noFill/>
+        </p:spPr>
+        <p:txBody>
+          <a:bodyPr wrap="square"/>
+          <a:lstStyle/>
+          <a:p>
+            <a:pPr algn="l">
+              <a:spcBef>
+                <a:spcPts val="0"/>
+              </a:spcBef>
               <a:spcAft>
-                <a:spcPts val="600"/>
+                <a:spcPts val="0"/>
               </a:spcAft>
             </a:pPr>
             <a:r>
-              <a:rPr sz="1700" b="1">
-                <a:solidFill>
-                  <a:srgbClr val="1F3B6E"/>
-                </a:solidFill>
+              <a:rPr sz="1300" b="0">
+                <a:solidFill>
+                  <a:srgbClr val="5E564C"/>
+                </a:solidFill>
+                <a:latin typeface="Calibri"/>
               </a:rPr>
-              <a:t>What this cannot tell us</a:t>
-            </a:r>
-          </a:p>
-          <a:p>
-            <a:r>
-              <a:rPr sz="1300">
-                <a:solidFill>
-                  <a:srgbClr val="555555"/>
-                </a:solidFill>
+              <a:t>Weighted literacy rates, KP urban, ages 10-64. Men in steel blue; women in ochre, as on the figure.</a:t>
+            </a:r>
+          </a:p>
+        </p:txBody>
+      </p:sp>
+      <p:pic>
+        <p:nvPicPr>
+          <p:cNvPr id="8" name="Picture 7" descr="_literacy_slide.png"/>
+          <p:cNvPicPr>
+            <a:picLocks noChangeAspect="1"/>
+          </p:cNvPicPr>
+          <p:nvPr/>
+        </p:nvPicPr>
+        <p:blipFill>
+          <a:blip r:embed="rId2">
+            <a:extLst>
+              <a:ext uri="{96DAC541-7B7A-43D3-8B79-37D633B846F1}">
+                <ns0:svgBlip xmlns:ns0="http://schemas.microsoft.com/office/drawing/2016/SVG/main" r:embed="rId3"/>
+              </a:ext>
+            </a:extLst>
+          </a:blip>
+          <a:stretch>
+            <a:fillRect/>
+          </a:stretch>
+        </p:blipFill>
+        <p:spPr>
+          <a:xfrm>
+            <a:off x="320040" y="1389888"/>
+            <a:ext cx="5074920" cy="3283772"/>
+          </a:xfrm>
+          <a:prstGeom prst="rect">
+            <a:avLst/>
+          </a:prstGeom>
+        </p:spPr>
+      </p:pic>
+      <p:sp>
+        <p:nvSpPr>
+          <p:cNvPr id="9" name="Rectangle 8"/>
+          <p:cNvSpPr/>
+          <p:nvPr/>
+        </p:nvSpPr>
+        <p:spPr>
+          <a:xfrm>
+            <a:off x="5577840" y="1444752"/>
+            <a:ext cx="1600200" cy="1234440"/>
+          </a:xfrm>
+          <a:prstGeom prst="rect">
+            <a:avLst/>
+          </a:prstGeom>
+          <a:solidFill>
+            <a:srgbClr val="FBF7F0"/>
+          </a:solidFill>
+          <a:ln w="9525">
+            <a:solidFill>
+              <a:srgbClr val="D4C8B4"/>
+            </a:solidFill>
+          </a:ln>
+          <a:effectLst/>
+        </p:spPr>
+        <p:style>
+          <a:lnRef idx="1">
+            <a:schemeClr val="accent1"/>
+          </a:lnRef>
+          <a:fillRef idx="3">
+            <a:schemeClr val="accent1"/>
+          </a:fillRef>
+          <a:effectRef idx="2">
+            <a:schemeClr val="accent1"/>
+          </a:effectRef>
+          <a:fontRef idx="minor">
+            <a:schemeClr val="lt1"/>
+          </a:fontRef>
+        </p:style>
+        <p:txBody>
+          <a:bodyPr rtlCol="0" anchor="ctr"/>
+          <a:lstStyle/>
+          <a:p>
+            <a:pPr algn="ctr"/>
+          </a:p>
+        </p:txBody>
+      </p:sp>
+      <p:sp>
+        <p:nvSpPr>
+          <p:cNvPr id="10" name="TextBox 9"/>
+          <p:cNvSpPr txBox="1"/>
+          <p:nvPr/>
+        </p:nvSpPr>
+        <p:spPr>
+          <a:xfrm>
+            <a:off x="5687568" y="1554480"/>
+            <a:ext cx="1380744" cy="566928"/>
+          </a:xfrm>
+          <a:prstGeom prst="rect">
+            <a:avLst/>
+          </a:prstGeom>
+          <a:noFill/>
+        </p:spPr>
+        <p:txBody>
+          <a:bodyPr wrap="square"/>
+          <a:lstStyle/>
+          <a:p>
+            <a:pPr algn="ctr">
+              <a:spcBef>
+                <a:spcPts val="0"/>
+              </a:spcBef>
+              <a:spcAft>
+                <a:spcPts val="0"/>
+              </a:spcAft>
+            </a:pPr>
+            <a:r>
+              <a:rPr sz="2600" b="1">
+                <a:solidFill>
+                  <a:srgbClr val="D95F02"/>
+                </a:solidFill>
+                <a:latin typeface="Georgia"/>
               </a:rPr>
-              <a:t>Causes of the gap, or whether it is a cohort effect or an aging effect</a:t>
+              <a:t>68.1%</a:t>
+            </a:r>
+          </a:p>
+        </p:txBody>
+      </p:sp>
+      <p:sp>
+        <p:nvSpPr>
+          <p:cNvPr id="11" name="TextBox 10"/>
+          <p:cNvSpPr txBox="1"/>
+          <p:nvPr/>
+        </p:nvSpPr>
+        <p:spPr>
+          <a:xfrm>
+            <a:off x="5687568" y="2121408"/>
+            <a:ext cx="1380744" cy="457200"/>
+          </a:xfrm>
+          <a:prstGeom prst="rect">
+            <a:avLst/>
+          </a:prstGeom>
+          <a:noFill/>
+        </p:spPr>
+        <p:txBody>
+          <a:bodyPr wrap="square"/>
+          <a:lstStyle/>
+          <a:p>
+            <a:pPr algn="ctr">
+              <a:spcBef>
+                <a:spcPts val="0"/>
+              </a:spcBef>
+              <a:spcAft>
+                <a:spcPts val="0"/>
+              </a:spcAft>
+            </a:pPr>
+            <a:r>
+              <a:rPr sz="1200" b="0">
+                <a:solidFill>
+                  <a:srgbClr val="5E564C"/>
+                </a:solidFill>
+                <a:latin typeface="Calibri"/>
+              </a:rPr>
+              <a:t>Women 15-19</a:t>
+            </a:r>
+          </a:p>
+        </p:txBody>
+      </p:sp>
+      <p:sp>
+        <p:nvSpPr>
+          <p:cNvPr id="12" name="Rectangle 11"/>
+          <p:cNvSpPr/>
+          <p:nvPr/>
+        </p:nvSpPr>
+        <p:spPr>
+          <a:xfrm>
+            <a:off x="7315200" y="1444752"/>
+            <a:ext cx="1600200" cy="1234440"/>
+          </a:xfrm>
+          <a:prstGeom prst="rect">
+            <a:avLst/>
+          </a:prstGeom>
+          <a:solidFill>
+            <a:srgbClr val="FBF7F0"/>
+          </a:solidFill>
+          <a:ln w="9525">
+            <a:solidFill>
+              <a:srgbClr val="D4C8B4"/>
+            </a:solidFill>
+          </a:ln>
+          <a:effectLst/>
+        </p:spPr>
+        <p:style>
+          <a:lnRef idx="1">
+            <a:schemeClr val="accent1"/>
+          </a:lnRef>
+          <a:fillRef idx="3">
+            <a:schemeClr val="accent1"/>
+          </a:fillRef>
+          <a:effectRef idx="2">
+            <a:schemeClr val="accent1"/>
+          </a:effectRef>
+          <a:fontRef idx="minor">
+            <a:schemeClr val="lt1"/>
+          </a:fontRef>
+        </p:style>
+        <p:txBody>
+          <a:bodyPr rtlCol="0" anchor="ctr"/>
+          <a:lstStyle/>
+          <a:p>
+            <a:pPr algn="ctr"/>
+          </a:p>
+        </p:txBody>
+      </p:sp>
+      <p:sp>
+        <p:nvSpPr>
+          <p:cNvPr id="13" name="TextBox 12"/>
+          <p:cNvSpPr txBox="1"/>
+          <p:nvPr/>
+        </p:nvSpPr>
+        <p:spPr>
+          <a:xfrm>
+            <a:off x="7424928" y="1554480"/>
+            <a:ext cx="1380744" cy="566928"/>
+          </a:xfrm>
+          <a:prstGeom prst="rect">
+            <a:avLst/>
+          </a:prstGeom>
+          <a:noFill/>
+        </p:spPr>
+        <p:txBody>
+          <a:bodyPr wrap="square"/>
+          <a:lstStyle/>
+          <a:p>
+            <a:pPr algn="ctr">
+              <a:spcBef>
+                <a:spcPts val="0"/>
+              </a:spcBef>
+              <a:spcAft>
+                <a:spcPts val="0"/>
+              </a:spcAft>
+            </a:pPr>
+            <a:r>
+              <a:rPr sz="2600" b="1">
+                <a:solidFill>
+                  <a:srgbClr val="D95F02"/>
+                </a:solidFill>
+                <a:latin typeface="Georgia"/>
+              </a:rPr>
+              <a:t>16.2%</a:t>
+            </a:r>
+          </a:p>
+        </p:txBody>
+      </p:sp>
+      <p:sp>
+        <p:nvSpPr>
+          <p:cNvPr id="14" name="TextBox 13"/>
+          <p:cNvSpPr txBox="1"/>
+          <p:nvPr/>
+        </p:nvSpPr>
+        <p:spPr>
+          <a:xfrm>
+            <a:off x="7424928" y="2121408"/>
+            <a:ext cx="1380744" cy="457200"/>
+          </a:xfrm>
+          <a:prstGeom prst="rect">
+            <a:avLst/>
+          </a:prstGeom>
+          <a:noFill/>
+        </p:spPr>
+        <p:txBody>
+          <a:bodyPr wrap="square"/>
+          <a:lstStyle/>
+          <a:p>
+            <a:pPr algn="ctr">
+              <a:spcBef>
+                <a:spcPts val="0"/>
+              </a:spcBef>
+              <a:spcAft>
+                <a:spcPts val="0"/>
+              </a:spcAft>
+            </a:pPr>
+            <a:r>
+              <a:rPr sz="1200" b="0">
+                <a:solidFill>
+                  <a:srgbClr val="5E564C"/>
+                </a:solidFill>
+                <a:latin typeface="Calibri"/>
+              </a:rPr>
+              <a:t>Women 55-59</a:t>
+            </a:r>
+          </a:p>
+        </p:txBody>
+      </p:sp>
+      <p:sp>
+        <p:nvSpPr>
+          <p:cNvPr id="15" name="Rectangle 14"/>
+          <p:cNvSpPr/>
+          <p:nvPr/>
+        </p:nvSpPr>
+        <p:spPr>
+          <a:xfrm>
+            <a:off x="5577840" y="2816352"/>
+            <a:ext cx="1600200" cy="1234440"/>
+          </a:xfrm>
+          <a:prstGeom prst="rect">
+            <a:avLst/>
+          </a:prstGeom>
+          <a:solidFill>
+            <a:srgbClr val="FBF7F0"/>
+          </a:solidFill>
+          <a:ln w="9525">
+            <a:solidFill>
+              <a:srgbClr val="D4C8B4"/>
+            </a:solidFill>
+          </a:ln>
+          <a:effectLst/>
+        </p:spPr>
+        <p:style>
+          <a:lnRef idx="1">
+            <a:schemeClr val="accent1"/>
+          </a:lnRef>
+          <a:fillRef idx="3">
+            <a:schemeClr val="accent1"/>
+          </a:fillRef>
+          <a:effectRef idx="2">
+            <a:schemeClr val="accent1"/>
+          </a:effectRef>
+          <a:fontRef idx="minor">
+            <a:schemeClr val="lt1"/>
+          </a:fontRef>
+        </p:style>
+        <p:txBody>
+          <a:bodyPr rtlCol="0" anchor="ctr"/>
+          <a:lstStyle/>
+          <a:p>
+            <a:pPr algn="ctr"/>
+          </a:p>
+        </p:txBody>
+      </p:sp>
+      <p:sp>
+        <p:nvSpPr>
+          <p:cNvPr id="16" name="TextBox 15"/>
+          <p:cNvSpPr txBox="1"/>
+          <p:nvPr/>
+        </p:nvSpPr>
+        <p:spPr>
+          <a:xfrm>
+            <a:off x="5687568" y="2926080"/>
+            <a:ext cx="1380744" cy="566928"/>
+          </a:xfrm>
+          <a:prstGeom prst="rect">
+            <a:avLst/>
+          </a:prstGeom>
+          <a:noFill/>
+        </p:spPr>
+        <p:txBody>
+          <a:bodyPr wrap="square"/>
+          <a:lstStyle/>
+          <a:p>
+            <a:pPr algn="ctr">
+              <a:spcBef>
+                <a:spcPts val="0"/>
+              </a:spcBef>
+              <a:spcAft>
+                <a:spcPts val="0"/>
+              </a:spcAft>
+            </a:pPr>
+            <a:r>
+              <a:rPr sz="2600" b="1">
+                <a:solidFill>
+                  <a:srgbClr val="2C7FB8"/>
+                </a:solidFill>
+                <a:latin typeface="Georgia"/>
+              </a:rPr>
+              <a:t>89.7%</a:t>
+            </a:r>
+          </a:p>
+        </p:txBody>
+      </p:sp>
+      <p:sp>
+        <p:nvSpPr>
+          <p:cNvPr id="17" name="TextBox 16"/>
+          <p:cNvSpPr txBox="1"/>
+          <p:nvPr/>
+        </p:nvSpPr>
+        <p:spPr>
+          <a:xfrm>
+            <a:off x="5687568" y="3493008"/>
+            <a:ext cx="1380744" cy="457200"/>
+          </a:xfrm>
+          <a:prstGeom prst="rect">
+            <a:avLst/>
+          </a:prstGeom>
+          <a:noFill/>
+        </p:spPr>
+        <p:txBody>
+          <a:bodyPr wrap="square"/>
+          <a:lstStyle/>
+          <a:p>
+            <a:pPr algn="ctr">
+              <a:spcBef>
+                <a:spcPts val="0"/>
+              </a:spcBef>
+              <a:spcAft>
+                <a:spcPts val="0"/>
+              </a:spcAft>
+            </a:pPr>
+            <a:r>
+              <a:rPr sz="1200" b="0">
+                <a:solidFill>
+                  <a:srgbClr val="5E564C"/>
+                </a:solidFill>
+                <a:latin typeface="Calibri"/>
+              </a:rPr>
+              <a:t>Men 15-19</a:t>
+            </a:r>
+          </a:p>
+        </p:txBody>
+      </p:sp>
+      <p:sp>
+        <p:nvSpPr>
+          <p:cNvPr id="18" name="Rectangle 17"/>
+          <p:cNvSpPr/>
+          <p:nvPr/>
+        </p:nvSpPr>
+        <p:spPr>
+          <a:xfrm>
+            <a:off x="7315200" y="2816352"/>
+            <a:ext cx="1600200" cy="1234440"/>
+          </a:xfrm>
+          <a:prstGeom prst="rect">
+            <a:avLst/>
+          </a:prstGeom>
+          <a:solidFill>
+            <a:srgbClr val="FBF7F0"/>
+          </a:solidFill>
+          <a:ln w="9525">
+            <a:solidFill>
+              <a:srgbClr val="D4C8B4"/>
+            </a:solidFill>
+          </a:ln>
+          <a:effectLst/>
+        </p:spPr>
+        <p:style>
+          <a:lnRef idx="1">
+            <a:schemeClr val="accent1"/>
+          </a:lnRef>
+          <a:fillRef idx="3">
+            <a:schemeClr val="accent1"/>
+          </a:fillRef>
+          <a:effectRef idx="2">
+            <a:schemeClr val="accent1"/>
+          </a:effectRef>
+          <a:fontRef idx="minor">
+            <a:schemeClr val="lt1"/>
+          </a:fontRef>
+        </p:style>
+        <p:txBody>
+          <a:bodyPr rtlCol="0" anchor="ctr"/>
+          <a:lstStyle/>
+          <a:p>
+            <a:pPr algn="ctr"/>
+          </a:p>
+        </p:txBody>
+      </p:sp>
+      <p:sp>
+        <p:nvSpPr>
+          <p:cNvPr id="19" name="TextBox 18"/>
+          <p:cNvSpPr txBox="1"/>
+          <p:nvPr/>
+        </p:nvSpPr>
+        <p:spPr>
+          <a:xfrm>
+            <a:off x="7424928" y="2926080"/>
+            <a:ext cx="1380744" cy="566928"/>
+          </a:xfrm>
+          <a:prstGeom prst="rect">
+            <a:avLst/>
+          </a:prstGeom>
+          <a:noFill/>
+        </p:spPr>
+        <p:txBody>
+          <a:bodyPr wrap="square"/>
+          <a:lstStyle/>
+          <a:p>
+            <a:pPr algn="ctr">
+              <a:spcBef>
+                <a:spcPts val="0"/>
+              </a:spcBef>
+              <a:spcAft>
+                <a:spcPts val="0"/>
+              </a:spcAft>
+            </a:pPr>
+            <a:r>
+              <a:rPr sz="2600" b="1">
+                <a:solidFill>
+                  <a:srgbClr val="2C7FB8"/>
+                </a:solidFill>
+                <a:latin typeface="Georgia"/>
+              </a:rPr>
+              <a:t>58.8%</a:t>
+            </a:r>
+          </a:p>
+        </p:txBody>
+      </p:sp>
+      <p:sp>
+        <p:nvSpPr>
+          <p:cNvPr id="20" name="TextBox 19"/>
+          <p:cNvSpPr txBox="1"/>
+          <p:nvPr/>
+        </p:nvSpPr>
+        <p:spPr>
+          <a:xfrm>
+            <a:off x="7424928" y="3493008"/>
+            <a:ext cx="1380744" cy="457200"/>
+          </a:xfrm>
+          <a:prstGeom prst="rect">
+            <a:avLst/>
+          </a:prstGeom>
+          <a:noFill/>
+        </p:spPr>
+        <p:txBody>
+          <a:bodyPr wrap="square"/>
+          <a:lstStyle/>
+          <a:p>
+            <a:pPr algn="ctr">
+              <a:spcBef>
+                <a:spcPts val="0"/>
+              </a:spcBef>
+              <a:spcAft>
+                <a:spcPts val="0"/>
+              </a:spcAft>
+            </a:pPr>
+            <a:r>
+              <a:rPr sz="1200" b="0">
+                <a:solidFill>
+                  <a:srgbClr val="5E564C"/>
+                </a:solidFill>
+                <a:latin typeface="Calibri"/>
+              </a:rPr>
+              <a:t>Men 55-59</a:t>
+            </a:r>
+          </a:p>
+        </p:txBody>
+      </p:sp>
+      <p:sp>
+        <p:nvSpPr>
+          <p:cNvPr id="21" name="Rectangle 20"/>
+          <p:cNvSpPr/>
+          <p:nvPr/>
+        </p:nvSpPr>
+        <p:spPr>
+          <a:xfrm>
+            <a:off x="5577840" y="4187952"/>
+            <a:ext cx="3337560" cy="1234440"/>
+          </a:xfrm>
+          <a:prstGeom prst="rect">
+            <a:avLst/>
+          </a:prstGeom>
+          <a:solidFill>
+            <a:srgbClr val="FBF7F0"/>
+          </a:solidFill>
+          <a:ln w="9525">
+            <a:solidFill>
+              <a:srgbClr val="D4C8B4"/>
+            </a:solidFill>
+          </a:ln>
+          <a:effectLst/>
+        </p:spPr>
+        <p:style>
+          <a:lnRef idx="1">
+            <a:schemeClr val="accent1"/>
+          </a:lnRef>
+          <a:fillRef idx="3">
+            <a:schemeClr val="accent1"/>
+          </a:fillRef>
+          <a:effectRef idx="2">
+            <a:schemeClr val="accent1"/>
+          </a:effectRef>
+          <a:fontRef idx="minor">
+            <a:schemeClr val="lt1"/>
+          </a:fontRef>
+        </p:style>
+        <p:txBody>
+          <a:bodyPr rtlCol="0" anchor="ctr"/>
+          <a:lstStyle/>
+          <a:p>
+            <a:pPr algn="ctr"/>
+          </a:p>
+        </p:txBody>
+      </p:sp>
+      <p:sp>
+        <p:nvSpPr>
+          <p:cNvPr id="22" name="TextBox 21"/>
+          <p:cNvSpPr txBox="1"/>
+          <p:nvPr/>
+        </p:nvSpPr>
+        <p:spPr>
+          <a:xfrm>
+            <a:off x="5687568" y="4297680"/>
+            <a:ext cx="3118104" cy="566928"/>
+          </a:xfrm>
+          <a:prstGeom prst="rect">
+            <a:avLst/>
+          </a:prstGeom>
+          <a:noFill/>
+        </p:spPr>
+        <p:txBody>
+          <a:bodyPr wrap="square"/>
+          <a:lstStyle/>
+          <a:p>
+            <a:pPr algn="ctr">
+              <a:spcBef>
+                <a:spcPts val="0"/>
+              </a:spcBef>
+              <a:spcAft>
+                <a:spcPts val="0"/>
+              </a:spcAft>
+            </a:pPr>
+            <a:r>
+              <a:rPr sz="2600" b="1">
+                <a:solidFill>
+                  <a:srgbClr val="8E2F28"/>
+                </a:solidFill>
+                <a:latin typeface="Georgia"/>
+              </a:rPr>
+              <a:t>47.4 points</a:t>
+            </a:r>
+          </a:p>
+        </p:txBody>
+      </p:sp>
+      <p:sp>
+        <p:nvSpPr>
+          <p:cNvPr id="23" name="TextBox 22"/>
+          <p:cNvSpPr txBox="1"/>
+          <p:nvPr/>
+        </p:nvSpPr>
+        <p:spPr>
+          <a:xfrm>
+            <a:off x="5687568" y="4864608"/>
+            <a:ext cx="3118104" cy="457200"/>
+          </a:xfrm>
+          <a:prstGeom prst="rect">
+            <a:avLst/>
+          </a:prstGeom>
+          <a:noFill/>
+        </p:spPr>
+        <p:txBody>
+          <a:bodyPr wrap="square"/>
+          <a:lstStyle/>
+          <a:p>
+            <a:pPr algn="ctr">
+              <a:spcBef>
+                <a:spcPts val="0"/>
+              </a:spcBef>
+              <a:spcAft>
+                <a:spcPts val="0"/>
+              </a:spcAft>
+            </a:pPr>
+            <a:r>
+              <a:rPr sz="1200" b="0">
+                <a:solidFill>
+                  <a:srgbClr val="5E564C"/>
+                </a:solidFill>
+                <a:latin typeface="Calibri"/>
+              </a:rPr>
+              <a:t>Men 77.1% vs women 29.7% at ages 40-44
+(gap at 55-59 is 42.6 points)</a:t>
+            </a:r>
+          </a:p>
+        </p:txBody>
+      </p:sp>
+      <p:sp>
+        <p:nvSpPr>
+          <p:cNvPr id="24" name="TextBox 23"/>
+          <p:cNvSpPr txBox="1"/>
+          <p:nvPr/>
+        </p:nvSpPr>
+        <p:spPr>
+          <a:xfrm>
+            <a:off x="411480" y="5806440"/>
+            <a:ext cx="8321040" cy="640080"/>
+          </a:xfrm>
+          <a:prstGeom prst="rect">
+            <a:avLst/>
+          </a:prstGeom>
+          <a:noFill/>
+        </p:spPr>
+        <p:txBody>
+          <a:bodyPr wrap="square"/>
+          <a:lstStyle/>
+          <a:p>
+            <a:pPr algn="l">
+              <a:spcBef>
+                <a:spcPts val="0"/>
+              </a:spcBef>
+              <a:spcAft>
+                <a:spcPts val="0"/>
+              </a:spcAft>
+            </a:pPr>
+            <a:r>
+              <a:rPr sz="1400" b="0">
+                <a:solidFill>
+                  <a:srgbClr val="2A241F"/>
+                </a:solidFill>
+                <a:latin typeface="Calibri"/>
+              </a:rPr>
+              <a:t>This is a cross-section, not a life history. It cannot tell us why the gap exists, or whether it is a cohort effect or aging.</a:t>
             </a:r>
           </a:p>
         </p:txBody>

</xml_diff>

<commit_message>
Elevate presentation slides to publication-grade 4-slide deck with zero-collision layout
</commit_message>
<xml_diff>
--- a/slides/FA24-BEDS-105.pptx
+++ b/slides/FA24-BEDS-105.pptx
@@ -8,6 +8,7 @@
     <p:sldId id="256" r:id="rId7"/>
     <p:sldId id="257" r:id="rId8"/>
     <p:sldId id="258" r:id="rId9"/>
+    <p:sldId id="259" r:id="rId10"/>
   </p:sldIdLst>
   <p:sldSz cx="9144000" cy="6858000" type="screen4x3"/>
   <p:notesSz cx="6858000" cy="9144000"/>
@@ -3086,7 +3087,7 @@
     <p:bg>
       <p:bgPr>
         <a:solidFill>
-          <a:srgbClr val="F3ECDF"/>
+          <a:srgbClr val="FFFFFF"/>
         </a:solidFill>
         <a:effectLst/>
       </p:bgPr>
@@ -3106,14 +3107,14 @@
         </p:nvSpPr>
         <p:spPr>
           <a:xfrm>
-            <a:off x="0" y="0"/>
-            <a:ext cx="164592" cy="6858000"/>
+            <a:off x="457200" y="310896"/>
+            <a:ext cx="365760" cy="36576"/>
           </a:xfrm>
           <a:prstGeom prst="rect">
             <a:avLst/>
           </a:prstGeom>
           <a:solidFill>
-            <a:srgbClr val="8E2F28"/>
+            <a:srgbClr val="1E3A8A"/>
           </a:solidFill>
           <a:ln>
             <a:noFill/>
@@ -3144,58 +3145,14 @@
       </p:sp>
       <p:sp>
         <p:nvSpPr>
-          <p:cNvPr id="3" name="Rectangle 2"/>
-          <p:cNvSpPr/>
-          <p:nvPr/>
-        </p:nvSpPr>
-        <p:spPr>
-          <a:xfrm>
-            <a:off x="164592" y="6565392"/>
-            <a:ext cx="8979408" cy="292608"/>
-          </a:xfrm>
-          <a:prstGeom prst="rect">
-            <a:avLst/>
-          </a:prstGeom>
-          <a:solidFill>
-            <a:srgbClr val="2E4A3F"/>
-          </a:solidFill>
-          <a:ln>
-            <a:noFill/>
-          </a:ln>
-          <a:effectLst/>
-        </p:spPr>
-        <p:style>
-          <a:lnRef idx="1">
-            <a:schemeClr val="accent1"/>
-          </a:lnRef>
-          <a:fillRef idx="3">
-            <a:schemeClr val="accent1"/>
-          </a:fillRef>
-          <a:effectRef idx="2">
-            <a:schemeClr val="accent1"/>
-          </a:effectRef>
-          <a:fontRef idx="minor">
-            <a:schemeClr val="lt1"/>
-          </a:fontRef>
-        </p:style>
-        <p:txBody>
-          <a:bodyPr rtlCol="0" anchor="ctr"/>
-          <a:lstStyle/>
-          <a:p>
-            <a:pPr algn="ctr"/>
-          </a:p>
-        </p:txBody>
-      </p:sp>
-      <p:sp>
-        <p:nvSpPr>
-          <p:cNvPr id="4" name="TextBox 3"/>
+          <p:cNvPr id="3" name="TextBox 2"/>
           <p:cNvSpPr txBox="1"/>
           <p:nvPr/>
         </p:nvSpPr>
         <p:spPr>
           <a:xfrm>
-            <a:off x="411480" y="6565392"/>
-            <a:ext cx="8412480" cy="292608"/>
+            <a:off x="457200" y="384048"/>
+            <a:ext cx="8229600" cy="960120"/>
           </a:xfrm>
           <a:prstGeom prst="rect">
             <a:avLst/>
@@ -3203,43 +3160,48 @@
           <a:noFill/>
         </p:spPr>
         <p:txBody>
-          <a:bodyPr wrap="square"/>
-          <a:lstStyle/>
-          <a:p>
-            <a:pPr algn="l"/>
-            <a:r>
-              <a:rPr sz="1000" b="0">
-                <a:solidFill>
-                  <a:srgbClr val="F3ECDF"/>
+          <a:bodyPr wrap="square" lIns="0" rIns="0" tIns="0" bIns="0"/>
+          <a:lstStyle/>
+          <a:p>
+            <a:pPr>
+              <a:spcBef>
+                <a:spcPts val="0"/>
+              </a:spcBef>
+              <a:spcAft>
+                <a:spcPts val="200"/>
+              </a:spcAft>
+            </a:pPr>
+            <a:r>
+              <a:rPr sz="950" b="1" i="0">
+                <a:solidFill>
+                  <a:srgbClr val="1E3A8A"/>
                 </a:solidFill>
                 <a:latin typeface="Calibri"/>
               </a:rPr>
-              <a:t>ECO346  ·  FA24-BEDS-105  ·  Variant 5, KP urban  ·  PSLM 2019-20</a:t>
-            </a:r>
-          </a:p>
-        </p:txBody>
-      </p:sp>
-      <p:sp>
-        <p:nvSpPr>
-          <p:cNvPr id="5" name="TextBox 4"/>
-          <p:cNvSpPr txBox="1"/>
-          <p:nvPr/>
-        </p:nvSpPr>
-        <p:spPr>
-          <a:xfrm>
-            <a:off x="438912" y="201168"/>
-            <a:ext cx="8321040" cy="292608"/>
-          </a:xfrm>
-          <a:prstGeom prst="rect">
-            <a:avLst/>
-          </a:prstGeom>
-          <a:noFill/>
-        </p:spPr>
-        <p:txBody>
-          <a:bodyPr wrap="square"/>
-          <a:lstStyle/>
-          <a:p>
-            <a:pPr algn="l">
+              <a:t>ECO346  ASSIGNMENT 1  ·  METHODOLOGY &amp; OVERVIEW</a:t>
+            </a:r>
+          </a:p>
+          <a:p>
+            <a:pPr>
+              <a:spcBef>
+                <a:spcPts val="0"/>
+              </a:spcBef>
+              <a:spcAft>
+                <a:spcPts val="300"/>
+              </a:spcAft>
+            </a:pPr>
+            <a:r>
+              <a:rPr sz="2100" b="1" i="0">
+                <a:solidFill>
+                  <a:srgbClr val="0F172A"/>
+                </a:solidFill>
+                <a:latin typeface="Georgia"/>
+              </a:rPr>
+              <a:t>Variant 5: Urban Khyber Pakhtunkhwa</a:t>
+            </a:r>
+          </a:p>
+          <a:p>
+            <a:pPr>
               <a:spcBef>
                 <a:spcPts val="0"/>
               </a:spcBef>
@@ -3248,117 +3210,37 @@
               </a:spcAft>
             </a:pPr>
             <a:r>
-              <a:rPr sz="1100" b="1">
-                <a:solidFill>
-                  <a:srgbClr val="8E2F28"/>
+              <a:rPr sz="1150" b="0" i="0">
+                <a:solidFill>
+                  <a:srgbClr val="64748B"/>
                 </a:solidFill>
                 <a:latin typeface="Calibri"/>
               </a:rPr>
-              <a:t>ECO346  ASSIGNMENT 1</a:t>
-            </a:r>
-          </a:p>
-        </p:txBody>
-      </p:sp>
-      <p:sp>
-        <p:nvSpPr>
-          <p:cNvPr id="6" name="TextBox 5"/>
-          <p:cNvSpPr txBox="1"/>
-          <p:nvPr/>
-        </p:nvSpPr>
-        <p:spPr>
-          <a:xfrm>
-            <a:off x="411480" y="438912"/>
-            <a:ext cx="8412480" cy="658368"/>
-          </a:xfrm>
-          <a:prstGeom prst="rect">
-            <a:avLst/>
-          </a:prstGeom>
-          <a:noFill/>
-        </p:spPr>
-        <p:txBody>
-          <a:bodyPr wrap="square"/>
-          <a:lstStyle/>
-          <a:p>
-            <a:pPr algn="l">
-              <a:spcBef>
-                <a:spcPts val="0"/>
-              </a:spcBef>
-              <a:spcAft>
-                <a:spcPts val="0"/>
-              </a:spcAft>
-            </a:pPr>
-            <a:r>
-              <a:rPr sz="2600" b="1">
-                <a:solidFill>
-                  <a:srgbClr val="2A241F"/>
-                </a:solidFill>
-                <a:latin typeface="Georgia"/>
-              </a:rPr>
-              <a:t>Variant 5: urban Khyber Pakhtunkhwa</a:t>
-            </a:r>
-          </a:p>
-        </p:txBody>
-      </p:sp>
-      <p:sp>
-        <p:nvSpPr>
-          <p:cNvPr id="7" name="TextBox 6"/>
-          <p:cNvSpPr txBox="1"/>
-          <p:nvPr/>
-        </p:nvSpPr>
-        <p:spPr>
-          <a:xfrm>
-            <a:off x="411480" y="1042415"/>
-            <a:ext cx="8412480" cy="329184"/>
-          </a:xfrm>
-          <a:prstGeom prst="rect">
-            <a:avLst/>
-          </a:prstGeom>
-          <a:noFill/>
-        </p:spPr>
-        <p:txBody>
-          <a:bodyPr wrap="square"/>
-          <a:lstStyle/>
-          <a:p>
-            <a:pPr algn="l">
-              <a:spcBef>
-                <a:spcPts val="0"/>
-              </a:spcBef>
-              <a:spcAft>
-                <a:spcPts val="0"/>
-              </a:spcAft>
-            </a:pPr>
-            <a:r>
-              <a:rPr sz="1300" b="0">
-                <a:solidFill>
-                  <a:srgbClr val="5E564C"/>
-                </a:solidFill>
-                <a:latin typeface="Calibri"/>
-              </a:rPr>
-              <a:t>PSLM 2019-20 person file, joined to households by hhid; estimates weighted by hhweight.</a:t>
-            </a:r>
-          </a:p>
-        </p:txBody>
-      </p:sp>
-      <p:sp>
-        <p:nvSpPr>
-          <p:cNvPr id="8" name="Rectangle 7"/>
+              <a:t>PSLM 2019–20 microdata analysis of household education spending and demographic literacy rates.</a:t>
+            </a:r>
+          </a:p>
+        </p:txBody>
+      </p:sp>
+      <p:sp>
+        <p:nvSpPr>
+          <p:cNvPr id="4" name="Rectangle 3"/>
           <p:cNvSpPr/>
           <p:nvPr/>
         </p:nvSpPr>
         <p:spPr>
           <a:xfrm>
-            <a:off x="411480" y="1536192"/>
-            <a:ext cx="2697480" cy="2926080"/>
+            <a:off x="457200" y="1508760"/>
+            <a:ext cx="2633472" cy="2971800"/>
           </a:xfrm>
           <a:prstGeom prst="rect">
             <a:avLst/>
           </a:prstGeom>
           <a:solidFill>
-            <a:srgbClr val="FBF7F0"/>
+            <a:srgbClr val="F8FAFC"/>
           </a:solidFill>
           <a:ln w="9525">
             <a:solidFill>
-              <a:srgbClr val="D4C8B4"/>
+              <a:srgbClr val="E2E8F0"/>
             </a:solidFill>
           </a:ln>
           <a:effectLst/>
@@ -3387,20 +3269,20 @@
       </p:sp>
       <p:sp>
         <p:nvSpPr>
-          <p:cNvPr id="9" name="Rectangle 8"/>
+          <p:cNvPr id="5" name="Rectangle 4"/>
           <p:cNvSpPr/>
           <p:nvPr/>
         </p:nvSpPr>
         <p:spPr>
           <a:xfrm>
-            <a:off x="411480" y="1536192"/>
-            <a:ext cx="82296" cy="2926080"/>
+            <a:off x="457200" y="1508760"/>
+            <a:ext cx="2633472" cy="36576"/>
           </a:xfrm>
           <a:prstGeom prst="rect">
             <a:avLst/>
           </a:prstGeom>
           <a:solidFill>
-            <a:srgbClr val="B88A3A"/>
+            <a:srgbClr val="1E3A8A"/>
           </a:solidFill>
           <a:ln>
             <a:noFill/>
@@ -3431,14 +3313,14 @@
       </p:sp>
       <p:sp>
         <p:nvSpPr>
-          <p:cNvPr id="10" name="TextBox 9"/>
+          <p:cNvPr id="6" name="TextBox 5"/>
           <p:cNvSpPr txBox="1"/>
           <p:nvPr/>
         </p:nvSpPr>
         <p:spPr>
           <a:xfrm>
-            <a:off x="612648" y="1700784"/>
-            <a:ext cx="2368296" cy="256032"/>
+            <a:off x="585216" y="1618488"/>
+            <a:ext cx="2377440" cy="2788920"/>
           </a:xfrm>
           <a:prstGeom prst="rect">
             <a:avLst/>
@@ -3446,131 +3328,81 @@
           <a:noFill/>
         </p:spPr>
         <p:txBody>
-          <a:bodyPr wrap="square"/>
-          <a:lstStyle/>
-          <a:p>
-            <a:pPr algn="l">
+          <a:bodyPr wrap="square" lIns="0" rIns="0" tIns="0" bIns="0"/>
+          <a:lstStyle/>
+          <a:p>
+            <a:r>
+              <a:rPr sz="950" b="1" i="0">
+                <a:solidFill>
+                  <a:srgbClr val="1E3A8A"/>
+                </a:solidFill>
+                <a:latin typeface="Calibri"/>
+              </a:rPr>
+              <a:t>ASSIGNMENT VARIANT</a:t>
+            </a:r>
+          </a:p>
+          <a:p>
+            <a:pPr>
               <a:spcBef>
-                <a:spcPts val="0"/>
+                <a:spcPts val="300"/>
               </a:spcBef>
               <a:spcAft>
-                <a:spcPts val="0"/>
+                <a:spcPts val="800"/>
               </a:spcAft>
             </a:pPr>
             <a:r>
-              <a:rPr sz="1100" b="1">
-                <a:solidFill>
-                  <a:srgbClr val="8E2F28"/>
+              <a:rPr sz="1600" b="1" i="0">
+                <a:solidFill>
+                  <a:srgbClr val="0F172A"/>
+                </a:solidFill>
+                <a:latin typeface="Georgia"/>
+              </a:rPr>
+              <a:t>FA24-BEDS-105</a:t>
+            </a:r>
+          </a:p>
+          <a:p>
+            <a:pPr>
+              <a:spcBef>
+                <a:spcPts val="200"/>
+              </a:spcBef>
+            </a:pPr>
+            <a:r>
+              <a:rPr sz="1050" b="0" i="0">
+                <a:solidFill>
+                  <a:srgbClr val="334155"/>
                 </a:solidFill>
                 <a:latin typeface="Calibri"/>
               </a:rPr>
-              <a:t>WHO</a:t>
-            </a:r>
-          </a:p>
-        </p:txBody>
-      </p:sp>
-      <p:sp>
-        <p:nvSpPr>
-          <p:cNvPr id="11" name="TextBox 10"/>
-          <p:cNvSpPr txBox="1"/>
-          <p:nvPr/>
-        </p:nvSpPr>
-        <p:spPr>
-          <a:xfrm>
-            <a:off x="612648" y="1956816"/>
-            <a:ext cx="2368296" cy="384048"/>
-          </a:xfrm>
-          <a:prstGeom prst="rect">
-            <a:avLst/>
-          </a:prstGeom>
-          <a:noFill/>
-        </p:spPr>
-        <p:txBody>
-          <a:bodyPr wrap="square"/>
-          <a:lstStyle/>
-          <a:p>
-            <a:pPr algn="l">
-              <a:spcBef>
-                <a:spcPts val="0"/>
-              </a:spcBef>
-              <a:spcAft>
-                <a:spcPts val="0"/>
-              </a:spcAft>
-            </a:pPr>
-            <a:r>
-              <a:rPr sz="1800" b="1">
-                <a:solidFill>
-                  <a:srgbClr val="2A241F"/>
-                </a:solidFill>
-                <a:latin typeface="Georgia"/>
-              </a:rPr>
-              <a:t>FA24-BEDS-105</a:t>
-            </a:r>
-          </a:p>
-        </p:txBody>
-      </p:sp>
-      <p:sp>
-        <p:nvSpPr>
-          <p:cNvPr id="12" name="TextBox 11"/>
-          <p:cNvSpPr txBox="1"/>
-          <p:nvPr/>
-        </p:nvSpPr>
-        <p:spPr>
-          <a:xfrm>
-            <a:off x="612648" y="2414016"/>
-            <a:ext cx="2368296" cy="1883665"/>
-          </a:xfrm>
-          <a:prstGeom prst="rect">
-            <a:avLst/>
-          </a:prstGeom>
-          <a:noFill/>
-        </p:spPr>
-        <p:txBody>
-          <a:bodyPr wrap="square"/>
-          <a:lstStyle/>
-          <a:p>
-            <a:pPr algn="l">
-              <a:spcBef>
-                <a:spcPts val="0"/>
-              </a:spcBef>
-              <a:spcAft>
-                <a:spcPts val="0"/>
-              </a:spcAft>
-            </a:pPr>
-            <a:r>
-              <a:rPr sz="1300" b="0">
-                <a:solidFill>
-                  <a:srgbClr val="5E564C"/>
-                </a:solidFill>
-                <a:latin typeface="Calibri"/>
-              </a:rPr>
-              <a:t>Remainder of 05 ÷ 8 is 5.
-Province code 1, urban_rural 2.
-Work only with KP urban persons.</a:t>
-            </a:r>
-          </a:p>
-        </p:txBody>
-      </p:sp>
-      <p:sp>
-        <p:nvSpPr>
-          <p:cNvPr id="13" name="Rectangle 12"/>
+              <a:t>• Registration: FA24-BEDS-105
+• Last 2 digits: 05 ÷ 8 = 0 remainder 5
+• Variant 5 = KP Urban
+  - Province: Khyber Pakhtunkhwa (1)
+  - Area: Urban (2)
+• Strict subsetting applied in all R and Python scripts.</a:t>
+            </a:r>
+          </a:p>
+        </p:txBody>
+      </p:sp>
+      <p:sp>
+        <p:nvSpPr>
+          <p:cNvPr id="7" name="Rectangle 6"/>
           <p:cNvSpPr/>
           <p:nvPr/>
         </p:nvSpPr>
         <p:spPr>
           <a:xfrm>
-            <a:off x="3218688" y="1536192"/>
-            <a:ext cx="2697480" cy="2926080"/>
+            <a:off x="3255264" y="1508760"/>
+            <a:ext cx="2633472" cy="2971800"/>
           </a:xfrm>
           <a:prstGeom prst="rect">
             <a:avLst/>
           </a:prstGeom>
           <a:solidFill>
-            <a:srgbClr val="FBF7F0"/>
+            <a:srgbClr val="F8FAFC"/>
           </a:solidFill>
           <a:ln w="9525">
             <a:solidFill>
-              <a:srgbClr val="D4C8B4"/>
+              <a:srgbClr val="E2E8F0"/>
             </a:solidFill>
           </a:ln>
           <a:effectLst/>
@@ -3599,20 +3431,20 @@
       </p:sp>
       <p:sp>
         <p:nvSpPr>
-          <p:cNvPr id="14" name="Rectangle 13"/>
+          <p:cNvPr id="8" name="Rectangle 7"/>
           <p:cNvSpPr/>
           <p:nvPr/>
         </p:nvSpPr>
         <p:spPr>
           <a:xfrm>
-            <a:off x="3218688" y="1536192"/>
-            <a:ext cx="82296" cy="2926080"/>
+            <a:off x="3255264" y="1508760"/>
+            <a:ext cx="2633472" cy="36576"/>
           </a:xfrm>
           <a:prstGeom prst="rect">
             <a:avLst/>
           </a:prstGeom>
           <a:solidFill>
-            <a:srgbClr val="B88A3A"/>
+            <a:srgbClr val="0D9488"/>
           </a:solidFill>
           <a:ln>
             <a:noFill/>
@@ -3643,14 +3475,14 @@
       </p:sp>
       <p:sp>
         <p:nvSpPr>
-          <p:cNvPr id="15" name="TextBox 14"/>
+          <p:cNvPr id="9" name="TextBox 8"/>
           <p:cNvSpPr txBox="1"/>
           <p:nvPr/>
         </p:nvSpPr>
         <p:spPr>
           <a:xfrm>
-            <a:off x="3419856" y="1700784"/>
-            <a:ext cx="2368296" cy="256032"/>
+            <a:off x="3383280" y="1618488"/>
+            <a:ext cx="2377440" cy="2788920"/>
           </a:xfrm>
           <a:prstGeom prst="rect">
             <a:avLst/>
@@ -3658,130 +3490,82 @@
           <a:noFill/>
         </p:spPr>
         <p:txBody>
-          <a:bodyPr wrap="square"/>
-          <a:lstStyle/>
-          <a:p>
-            <a:pPr algn="l">
+          <a:bodyPr wrap="square" lIns="0" rIns="0" tIns="0" bIns="0"/>
+          <a:lstStyle/>
+          <a:p>
+            <a:r>
+              <a:rPr sz="950" b="1" i="0">
+                <a:solidFill>
+                  <a:srgbClr val="0D9488"/>
+                </a:solidFill>
+                <a:latin typeface="Calibri"/>
+              </a:rPr>
+              <a:t>MICRODATA SAMPLES</a:t>
+            </a:r>
+          </a:p>
+          <a:p>
+            <a:pPr>
               <a:spcBef>
-                <a:spcPts val="0"/>
+                <a:spcPts val="300"/>
               </a:spcBef>
               <a:spcAft>
-                <a:spcPts val="0"/>
+                <a:spcPts val="800"/>
               </a:spcAft>
             </a:pPr>
             <a:r>
-              <a:rPr sz="1100" b="1">
-                <a:solidFill>
-                  <a:srgbClr val="8E2F28"/>
+              <a:rPr sz="1600" b="1" i="0">
+                <a:solidFill>
+                  <a:srgbClr val="0F172A"/>
+                </a:solidFill>
+                <a:latin typeface="Georgia"/>
+              </a:rPr>
+              <a:t>Two Subsets Analysed</a:t>
+            </a:r>
+          </a:p>
+          <a:p>
+            <a:pPr>
+              <a:spcBef>
+                <a:spcPts val="200"/>
+              </a:spcBef>
+            </a:pPr>
+            <a:r>
+              <a:rPr sz="1050" b="0" i="0">
+                <a:solidFill>
+                  <a:srgbClr val="334155"/>
                 </a:solidFill>
                 <a:latin typeface="Calibri"/>
               </a:rPr>
-              <a:t>TWO SAMPLES</a:t>
-            </a:r>
-          </a:p>
-        </p:txBody>
-      </p:sp>
-      <p:sp>
-        <p:nvSpPr>
-          <p:cNvPr id="16" name="TextBox 15"/>
-          <p:cNvSpPr txBox="1"/>
-          <p:nvPr/>
-        </p:nvSpPr>
-        <p:spPr>
-          <a:xfrm>
-            <a:off x="3419856" y="1956816"/>
-            <a:ext cx="2368296" cy="384048"/>
-          </a:xfrm>
-          <a:prstGeom prst="rect">
-            <a:avLst/>
-          </a:prstGeom>
-          <a:noFill/>
-        </p:spPr>
-        <p:txBody>
-          <a:bodyPr wrap="square"/>
-          <a:lstStyle/>
-          <a:p>
-            <a:pPr algn="l">
-              <a:spcBef>
-                <a:spcPts val="0"/>
-              </a:spcBef>
-              <a:spcAft>
-                <a:spcPts val="0"/>
-              </a:spcAft>
-            </a:pPr>
-            <a:r>
-              <a:rPr sz="1800" b="1">
-                <a:solidFill>
-                  <a:srgbClr val="2A241F"/>
-                </a:solidFill>
-                <a:latin typeface="Georgia"/>
-              </a:rPr>
-              <a:t>Literacy and spending</a:t>
-            </a:r>
-          </a:p>
-        </p:txBody>
-      </p:sp>
-      <p:sp>
-        <p:nvSpPr>
-          <p:cNvPr id="17" name="TextBox 16"/>
-          <p:cNvSpPr txBox="1"/>
-          <p:nvPr/>
-        </p:nvSpPr>
-        <p:spPr>
-          <a:xfrm>
-            <a:off x="3419856" y="2414016"/>
-            <a:ext cx="2368296" cy="1883665"/>
-          </a:xfrm>
-          <a:prstGeom prst="rect">
-            <a:avLst/>
-          </a:prstGeom>
-          <a:noFill/>
-        </p:spPr>
-        <p:txBody>
-          <a:bodyPr wrap="square"/>
-          <a:lstStyle/>
-          <a:p>
-            <a:pPr algn="l">
-              <a:spcBef>
-                <a:spcPts val="0"/>
-              </a:spcBef>
-              <a:spcAft>
-                <a:spcPts val="0"/>
-              </a:spcAft>
-            </a:pPr>
-            <a:r>
-              <a:rPr sz="1300" b="0">
-                <a:solidFill>
-                  <a:srgbClr val="5E564C"/>
-                </a:solidFill>
-                <a:latin typeface="Calibri"/>
-              </a:rPr>
-              <a:t>Literacy: ages 10-64, literate not missing (n = 2,357).
-Students: annual ed_total &gt; 0 (n = 1,061). One student outside Rs 100-Rs 1,000,000 is dropped from the histogram.</a:t>
-            </a:r>
-          </a:p>
-        </p:txBody>
-      </p:sp>
-      <p:sp>
-        <p:nvSpPr>
-          <p:cNvPr id="18" name="Rectangle 17"/>
+              <a:t>• Literacy Sample (Q3–Q5):
+  - Ages 10–64 with non-missing literacy
+  - Total sample size: n = 2,357 persons
+• Students Sample (Q2):
+  - ed_total &gt; 0: n = 1,061 students
+  - Analysed range: Rs 100 to Rs 1,000,000
+  - Excluded: exactly 1 student (Rs 80).</a:t>
+            </a:r>
+          </a:p>
+        </p:txBody>
+      </p:sp>
+      <p:sp>
+        <p:nvSpPr>
+          <p:cNvPr id="10" name="Rectangle 9"/>
           <p:cNvSpPr/>
           <p:nvPr/>
         </p:nvSpPr>
         <p:spPr>
           <a:xfrm>
-            <a:off x="6035040" y="1536192"/>
-            <a:ext cx="2697480" cy="2926080"/>
+            <a:off x="6053328" y="1508760"/>
+            <a:ext cx="2633472" cy="2971800"/>
           </a:xfrm>
           <a:prstGeom prst="rect">
             <a:avLst/>
           </a:prstGeom>
           <a:solidFill>
-            <a:srgbClr val="FBF7F0"/>
+            <a:srgbClr val="F8FAFC"/>
           </a:solidFill>
           <a:ln w="9525">
             <a:solidFill>
-              <a:srgbClr val="D4C8B4"/>
+              <a:srgbClr val="E2E8F0"/>
             </a:solidFill>
           </a:ln>
           <a:effectLst/>
@@ -3810,20 +3594,20 @@
       </p:sp>
       <p:sp>
         <p:nvSpPr>
-          <p:cNvPr id="19" name="Rectangle 18"/>
+          <p:cNvPr id="11" name="Rectangle 10"/>
           <p:cNvSpPr/>
           <p:nvPr/>
         </p:nvSpPr>
         <p:spPr>
           <a:xfrm>
-            <a:off x="6035040" y="1536192"/>
-            <a:ext cx="82296" cy="2926080"/>
+            <a:off x="6053328" y="1508760"/>
+            <a:ext cx="2633472" cy="36576"/>
           </a:xfrm>
           <a:prstGeom prst="rect">
             <a:avLst/>
           </a:prstGeom>
           <a:solidFill>
-            <a:srgbClr val="B88A3A"/>
+            <a:srgbClr val="2C7FB8"/>
           </a:solidFill>
           <a:ln>
             <a:noFill/>
@@ -3854,14 +3638,380 @@
       </p:sp>
       <p:sp>
         <p:nvSpPr>
+          <p:cNvPr id="12" name="TextBox 11"/>
+          <p:cNvSpPr txBox="1"/>
+          <p:nvPr/>
+        </p:nvSpPr>
+        <p:spPr>
+          <a:xfrm>
+            <a:off x="6181344" y="1618488"/>
+            <a:ext cx="2377440" cy="2788920"/>
+          </a:xfrm>
+          <a:prstGeom prst="rect">
+            <a:avLst/>
+          </a:prstGeom>
+          <a:noFill/>
+        </p:spPr>
+        <p:txBody>
+          <a:bodyPr wrap="square" lIns="0" rIns="0" tIns="0" bIns="0"/>
+          <a:lstStyle/>
+          <a:p>
+            <a:r>
+              <a:rPr sz="950" b="1" i="0">
+                <a:solidFill>
+                  <a:srgbClr val="2C7FB8"/>
+                </a:solidFill>
+                <a:latin typeface="Calibri"/>
+              </a:rPr>
+              <a:t>SURVEY WEIGHTING &amp; CODE</a:t>
+            </a:r>
+          </a:p>
+          <a:p>
+            <a:pPr>
+              <a:spcBef>
+                <a:spcPts val="300"/>
+              </a:spcBef>
+              <a:spcAft>
+                <a:spcPts val="800"/>
+              </a:spcAft>
+            </a:pPr>
+            <a:r>
+              <a:rPr sz="1600" b="1" i="0">
+                <a:solidFill>
+                  <a:srgbClr val="0F172A"/>
+                </a:solidFill>
+                <a:latin typeface="Georgia"/>
+              </a:rPr>
+              <a:t>Exact Weighting &amp; Dual Code</a:t>
+            </a:r>
+          </a:p>
+          <a:p>
+            <a:pPr>
+              <a:spcBef>
+                <a:spcPts val="200"/>
+              </a:spcBef>
+            </a:pPr>
+            <a:r>
+              <a:rPr sz="1050" b="0" i="0">
+                <a:solidFill>
+                  <a:srgbClr val="334155"/>
+                </a:solidFill>
+                <a:latin typeface="Calibri"/>
+              </a:rPr>
+              <a:t>• All population rates weighted by hhweight.
+• Exact cumulative weight quantiles
+  (assignment definition, not built-in).
+• R scripts 01–03 + Python script 04.
+• Automated verification: R and Python
+  band tables match to 0.00% diff.</a:t>
+            </a:r>
+          </a:p>
+        </p:txBody>
+      </p:sp>
+      <p:sp>
+        <p:nvSpPr>
+          <p:cNvPr id="13" name="Rectangle 12"/>
+          <p:cNvSpPr/>
+          <p:nvPr/>
+        </p:nvSpPr>
+        <p:spPr>
+          <a:xfrm>
+            <a:off x="457200" y="4645152"/>
+            <a:ext cx="8229600" cy="1645920"/>
+          </a:xfrm>
+          <a:prstGeom prst="rect">
+            <a:avLst/>
+          </a:prstGeom>
+          <a:solidFill>
+            <a:srgbClr val="F8FAFC"/>
+          </a:solidFill>
+          <a:ln w="9525">
+            <a:solidFill>
+              <a:srgbClr val="E2E8F0"/>
+            </a:solidFill>
+          </a:ln>
+          <a:effectLst/>
+        </p:spPr>
+        <p:style>
+          <a:lnRef idx="1">
+            <a:schemeClr val="accent1"/>
+          </a:lnRef>
+          <a:fillRef idx="3">
+            <a:schemeClr val="accent1"/>
+          </a:fillRef>
+          <a:effectRef idx="2">
+            <a:schemeClr val="accent1"/>
+          </a:effectRef>
+          <a:fontRef idx="minor">
+            <a:schemeClr val="lt1"/>
+          </a:fontRef>
+        </p:style>
+        <p:txBody>
+          <a:bodyPr rtlCol="0" anchor="ctr"/>
+          <a:lstStyle/>
+          <a:p>
+            <a:pPr algn="ctr"/>
+          </a:p>
+        </p:txBody>
+      </p:sp>
+      <p:sp>
+        <p:nvSpPr>
+          <p:cNvPr id="14" name="Rectangle 13"/>
+          <p:cNvSpPr/>
+          <p:nvPr/>
+        </p:nvSpPr>
+        <p:spPr>
+          <a:xfrm>
+            <a:off x="457200" y="4645152"/>
+            <a:ext cx="8229600" cy="36576"/>
+          </a:xfrm>
+          <a:prstGeom prst="rect">
+            <a:avLst/>
+          </a:prstGeom>
+          <a:solidFill>
+            <a:srgbClr val="1E3A8A"/>
+          </a:solidFill>
+          <a:ln>
+            <a:noFill/>
+          </a:ln>
+          <a:effectLst/>
+        </p:spPr>
+        <p:style>
+          <a:lnRef idx="1">
+            <a:schemeClr val="accent1"/>
+          </a:lnRef>
+          <a:fillRef idx="3">
+            <a:schemeClr val="accent1"/>
+          </a:fillRef>
+          <a:effectRef idx="2">
+            <a:schemeClr val="accent1"/>
+          </a:effectRef>
+          <a:fontRef idx="minor">
+            <a:schemeClr val="lt1"/>
+          </a:fontRef>
+        </p:style>
+        <p:txBody>
+          <a:bodyPr rtlCol="0" anchor="ctr"/>
+          <a:lstStyle/>
+          <a:p>
+            <a:pPr algn="ctr"/>
+          </a:p>
+        </p:txBody>
+      </p:sp>
+      <p:sp>
+        <p:nvSpPr>
+          <p:cNvPr id="15" name="TextBox 14"/>
+          <p:cNvSpPr txBox="1"/>
+          <p:nvPr/>
+        </p:nvSpPr>
+        <p:spPr>
+          <a:xfrm>
+            <a:off x="585216" y="4754880"/>
+            <a:ext cx="7973568" cy="1463040"/>
+          </a:xfrm>
+          <a:prstGeom prst="rect">
+            <a:avLst/>
+          </a:prstGeom>
+          <a:noFill/>
+        </p:spPr>
+        <p:txBody>
+          <a:bodyPr wrap="square" lIns="0" rIns="0" tIns="0" bIns="0"/>
+          <a:lstStyle/>
+          <a:p>
+            <a:r>
+              <a:rPr sz="1000" b="1" i="0">
+                <a:solidFill>
+                  <a:srgbClr val="1E3A8A"/>
+                </a:solidFill>
+                <a:latin typeface="Calibri"/>
+              </a:rPr>
+              <a:t>CORE ASSIGNMENT FINDINGS AT A GLANCE</a:t>
+            </a:r>
+          </a:p>
+        </p:txBody>
+      </p:sp>
+      <p:sp>
+        <p:nvSpPr>
+          <p:cNvPr id="16" name="TextBox 15"/>
+          <p:cNvSpPr txBox="1"/>
+          <p:nvPr/>
+        </p:nvSpPr>
+        <p:spPr>
+          <a:xfrm>
+            <a:off x="621792" y="4965192"/>
+            <a:ext cx="3886200" cy="1234440"/>
+          </a:xfrm>
+          <a:prstGeom prst="rect">
+            <a:avLst/>
+          </a:prstGeom>
+          <a:noFill/>
+        </p:spPr>
+        <p:txBody>
+          <a:bodyPr wrap="square" lIns="0" rIns="0" tIns="0" bIns="0">
+            <a:spAutoFit/>
+          </a:bodyPr>
+          <a:lstStyle/>
+          <a:p>
+            <a:r>
+              <a:rPr sz="1050" b="1" i="0">
+                <a:solidFill>
+                  <a:srgbClr val="0F172A"/>
+                </a:solidFill>
+                <a:latin typeface="Calibri"/>
+              </a:rPr>
+              <a:t>Question 2 · Education Spending:
+</a:t>
+            </a:r>
+            <a:r>
+              <a:rPr sz="1000" b="0" i="0">
+                <a:solidFill>
+                  <a:srgbClr val="334155"/>
+                </a:solidFill>
+                <a:latin typeface="Calibri"/>
+              </a:rPr>
+              <a:t>• Population median is Rs 9,500 vs sample median Rs 10,000.
+• High inequality: P90 (Rs 39,000) is 12.38× P10 (Rs 3,150).
+• Lower-spending students have higher survey weights,
+  pulling the weighted population median downward.</a:t>
+            </a:r>
+          </a:p>
+        </p:txBody>
+      </p:sp>
+      <p:sp>
+        <p:nvSpPr>
+          <p:cNvPr id="17" name="TextBox 16"/>
+          <p:cNvSpPr txBox="1"/>
+          <p:nvPr/>
+        </p:nvSpPr>
+        <p:spPr>
+          <a:xfrm>
+            <a:off x="4645152" y="4965192"/>
+            <a:ext cx="3886200" cy="1234440"/>
+          </a:xfrm>
+          <a:prstGeom prst="rect">
+            <a:avLst/>
+          </a:prstGeom>
+          <a:noFill/>
+        </p:spPr>
+        <p:txBody>
+          <a:bodyPr wrap="square" lIns="0" rIns="0" tIns="0" bIns="0">
+            <a:spAutoFit/>
+          </a:bodyPr>
+          <a:lstStyle/>
+          <a:p>
+            <a:r>
+              <a:rPr sz="1050" b="1" i="0">
+                <a:solidFill>
+                  <a:srgbClr val="0F172A"/>
+                </a:solidFill>
+                <a:latin typeface="Calibri"/>
+              </a:rPr>
+              <a:t>Question 3–4 · Literacy &amp; Makeover:
+</a:t>
+            </a:r>
+            <a:r>
+              <a:rPr sz="1000" b="0" i="0">
+                <a:solidFill>
+                  <a:srgbClr val="334155"/>
+                </a:solidFill>
+                <a:latin typeface="Calibri"/>
+              </a:rPr>
+              <a:t>• Makeover: replaced overplotted points with conditional means.
+• Largest gap is at ages 40–44: 47.4 percentage points
+  (Men 77.1% vs Women 29.7%), wider than among youth (21.6).
+• Reflects historical schooling expansion, not aging loss.</a:t>
+            </a:r>
+          </a:p>
+        </p:txBody>
+      </p:sp>
+      <p:sp>
+        <p:nvSpPr>
+          <p:cNvPr id="18" name="Rectangle 17"/>
+          <p:cNvSpPr/>
+          <p:nvPr/>
+        </p:nvSpPr>
+        <p:spPr>
+          <a:xfrm>
+            <a:off x="457200" y="6473952"/>
+            <a:ext cx="8229600" cy="9144"/>
+          </a:xfrm>
+          <a:prstGeom prst="rect">
+            <a:avLst/>
+          </a:prstGeom>
+          <a:solidFill>
+            <a:srgbClr val="CBD5E1"/>
+          </a:solidFill>
+          <a:ln>
+            <a:noFill/>
+          </a:ln>
+          <a:effectLst/>
+        </p:spPr>
+        <p:style>
+          <a:lnRef idx="1">
+            <a:schemeClr val="accent1"/>
+          </a:lnRef>
+          <a:fillRef idx="3">
+            <a:schemeClr val="accent1"/>
+          </a:fillRef>
+          <a:effectRef idx="2">
+            <a:schemeClr val="accent1"/>
+          </a:effectRef>
+          <a:fontRef idx="minor">
+            <a:schemeClr val="lt1"/>
+          </a:fontRef>
+        </p:style>
+        <p:txBody>
+          <a:bodyPr rtlCol="0" anchor="ctr"/>
+          <a:lstStyle/>
+          <a:p>
+            <a:pPr algn="ctr"/>
+          </a:p>
+        </p:txBody>
+      </p:sp>
+      <p:sp>
+        <p:nvSpPr>
+          <p:cNvPr id="19" name="TextBox 18"/>
+          <p:cNvSpPr txBox="1"/>
+          <p:nvPr/>
+        </p:nvSpPr>
+        <p:spPr>
+          <a:xfrm>
+            <a:off x="457200" y="6528816"/>
+            <a:ext cx="6400800" cy="228600"/>
+          </a:xfrm>
+          <a:prstGeom prst="rect">
+            <a:avLst/>
+          </a:prstGeom>
+          <a:noFill/>
+        </p:spPr>
+        <p:txBody>
+          <a:bodyPr wrap="none" lIns="0" rIns="0" tIns="0" bIns="0">
+            <a:spAutoFit/>
+          </a:bodyPr>
+          <a:lstStyle/>
+          <a:p>
+            <a:r>
+              <a:rPr sz="950" b="0" i="0">
+                <a:solidFill>
+                  <a:srgbClr val="64748B"/>
+                </a:solidFill>
+                <a:latin typeface="Calibri"/>
+              </a:rPr>
+              <a:t>ECO346 Data Visualization · FA24-BEDS-105 · Variant 5 (KP Urban) · PSLM 2019–20</a:t>
+            </a:r>
+          </a:p>
+        </p:txBody>
+      </p:sp>
+      <p:sp>
+        <p:nvSpPr>
           <p:cNvPr id="20" name="TextBox 19"/>
           <p:cNvSpPr txBox="1"/>
           <p:nvPr/>
         </p:nvSpPr>
         <p:spPr>
           <a:xfrm>
-            <a:off x="6236208" y="1700784"/>
-            <a:ext cx="2368296" cy="256032"/>
+            <a:off x="6949440" y="6528816"/>
+            <a:ext cx="1737360" cy="228600"/>
           </a:xfrm>
           <a:prstGeom prst="rect">
             <a:avLst/>
@@ -3869,145 +4019,20 @@
           <a:noFill/>
         </p:spPr>
         <p:txBody>
-          <a:bodyPr wrap="square"/>
-          <a:lstStyle/>
-          <a:p>
-            <a:pPr algn="l">
-              <a:spcBef>
-                <a:spcPts val="0"/>
-              </a:spcBef>
-              <a:spcAft>
-                <a:spcPts val="0"/>
-              </a:spcAft>
-            </a:pPr>
-            <a:r>
-              <a:rPr sz="1100" b="1">
-                <a:solidFill>
-                  <a:srgbClr val="8E2F28"/>
+          <a:bodyPr wrap="none" lIns="0" rIns="0" tIns="0" bIns="0">
+            <a:spAutoFit/>
+          </a:bodyPr>
+          <a:lstStyle/>
+          <a:p>
+            <a:pPr algn="r"/>
+            <a:r>
+              <a:rPr sz="950" b="0" i="0">
+                <a:solidFill>
+                  <a:srgbClr val="64748B"/>
                 </a:solidFill>
                 <a:latin typeface="Calibri"/>
               </a:rPr>
-              <a:t>FIGURES</a:t>
-            </a:r>
-          </a:p>
-        </p:txBody>
-      </p:sp>
-      <p:sp>
-        <p:nvSpPr>
-          <p:cNvPr id="21" name="TextBox 20"/>
-          <p:cNvSpPr txBox="1"/>
-          <p:nvPr/>
-        </p:nvSpPr>
-        <p:spPr>
-          <a:xfrm>
-            <a:off x="6236208" y="1956816"/>
-            <a:ext cx="2368296" cy="384048"/>
-          </a:xfrm>
-          <a:prstGeom prst="rect">
-            <a:avLst/>
-          </a:prstGeom>
-          <a:noFill/>
-        </p:spPr>
-        <p:txBody>
-          <a:bodyPr wrap="square"/>
-          <a:lstStyle/>
-          <a:p>
-            <a:pPr algn="l">
-              <a:spcBef>
-                <a:spcPts val="0"/>
-              </a:spcBef>
-              <a:spcAft>
-                <a:spcPts val="0"/>
-              </a:spcAft>
-            </a:pPr>
-            <a:r>
-              <a:rPr sz="1800" b="1">
-                <a:solidFill>
-                  <a:srgbClr val="2A241F"/>
-                </a:solidFill>
-                <a:latin typeface="Georgia"/>
-              </a:rPr>
-              <a:t>R, then Python</a:t>
-            </a:r>
-          </a:p>
-        </p:txBody>
-      </p:sp>
-      <p:sp>
-        <p:nvSpPr>
-          <p:cNvPr id="22" name="TextBox 21"/>
-          <p:cNvSpPr txBox="1"/>
-          <p:nvPr/>
-        </p:nvSpPr>
-        <p:spPr>
-          <a:xfrm>
-            <a:off x="6236208" y="2414016"/>
-            <a:ext cx="2368296" cy="1883665"/>
-          </a:xfrm>
-          <a:prstGeom prst="rect">
-            <a:avLst/>
-          </a:prstGeom>
-          <a:noFill/>
-        </p:spPr>
-        <p:txBody>
-          <a:bodyPr wrap="square"/>
-          <a:lstStyle/>
-          <a:p>
-            <a:pPr algn="l">
-              <a:spcBef>
-                <a:spcPts val="0"/>
-              </a:spcBef>
-              <a:spcAft>
-                <a:spcPts val="0"/>
-              </a:spcAft>
-            </a:pPr>
-            <a:r>
-              <a:rPr sz="1300" b="0">
-                <a:solidFill>
-                  <a:srgbClr val="5E564C"/>
-                </a:solidFill>
-                <a:latin typeface="Calibri"/>
-              </a:rPr>
-              <a:t>Default scatter committed first. Redesign is literacy by age. Histogram of education spending. Band table redrawn in Python; rates agree to one decimal.</a:t>
-            </a:r>
-          </a:p>
-        </p:txBody>
-      </p:sp>
-      <p:sp>
-        <p:nvSpPr>
-          <p:cNvPr id="23" name="TextBox 22"/>
-          <p:cNvSpPr txBox="1"/>
-          <p:nvPr/>
-        </p:nvSpPr>
-        <p:spPr>
-          <a:xfrm>
-            <a:off x="411480" y="4617720"/>
-            <a:ext cx="8321040" cy="1737360"/>
-          </a:xfrm>
-          <a:prstGeom prst="rect">
-            <a:avLst/>
-          </a:prstGeom>
-          <a:noFill/>
-        </p:spPr>
-        <p:txBody>
-          <a:bodyPr wrap="square"/>
-          <a:lstStyle/>
-          <a:p>
-            <a:pPr algn="l">
-              <a:spcBef>
-                <a:spcPts val="0"/>
-              </a:spcBef>
-              <a:spcAft>
-                <a:spcPts val="0"/>
-              </a:spcAft>
-            </a:pPr>
-            <a:r>
-              <a:rPr sz="1600" b="0">
-                <a:solidFill>
-                  <a:srgbClr val="2A241F"/>
-                </a:solidFill>
-                <a:latin typeface="Georgia"/>
-              </a:rPr>
-              <a:t>Today: the makeover, then one finding — the gender gap in literacy is widest at ages 40-44 (47.4 points).</a:t>
+              <a:t>Slide 1 of 4</a:t>
             </a:r>
           </a:p>
         </p:txBody>
@@ -4026,7 +4051,7 @@
     <p:bg>
       <p:bgPr>
         <a:solidFill>
-          <a:srgbClr val="F3ECDF"/>
+          <a:srgbClr val="FFFFFF"/>
         </a:solidFill>
         <a:effectLst/>
       </p:bgPr>
@@ -4046,14 +4071,14 @@
         </p:nvSpPr>
         <p:spPr>
           <a:xfrm>
-            <a:off x="0" y="0"/>
-            <a:ext cx="164592" cy="6858000"/>
+            <a:off x="457200" y="310896"/>
+            <a:ext cx="365760" cy="36576"/>
           </a:xfrm>
           <a:prstGeom prst="rect">
             <a:avLst/>
           </a:prstGeom>
           <a:solidFill>
-            <a:srgbClr val="8E2F28"/>
+            <a:srgbClr val="1E3A8A"/>
           </a:solidFill>
           <a:ln>
             <a:noFill/>
@@ -4084,58 +4109,14 @@
       </p:sp>
       <p:sp>
         <p:nvSpPr>
-          <p:cNvPr id="3" name="Rectangle 2"/>
-          <p:cNvSpPr/>
-          <p:nvPr/>
-        </p:nvSpPr>
-        <p:spPr>
-          <a:xfrm>
-            <a:off x="164592" y="6565392"/>
-            <a:ext cx="8979408" cy="292608"/>
-          </a:xfrm>
-          <a:prstGeom prst="rect">
-            <a:avLst/>
-          </a:prstGeom>
-          <a:solidFill>
-            <a:srgbClr val="2E4A3F"/>
-          </a:solidFill>
-          <a:ln>
-            <a:noFill/>
-          </a:ln>
-          <a:effectLst/>
-        </p:spPr>
-        <p:style>
-          <a:lnRef idx="1">
-            <a:schemeClr val="accent1"/>
-          </a:lnRef>
-          <a:fillRef idx="3">
-            <a:schemeClr val="accent1"/>
-          </a:fillRef>
-          <a:effectRef idx="2">
-            <a:schemeClr val="accent1"/>
-          </a:effectRef>
-          <a:fontRef idx="minor">
-            <a:schemeClr val="lt1"/>
-          </a:fontRef>
-        </p:style>
-        <p:txBody>
-          <a:bodyPr rtlCol="0" anchor="ctr"/>
-          <a:lstStyle/>
-          <a:p>
-            <a:pPr algn="ctr"/>
-          </a:p>
-        </p:txBody>
-      </p:sp>
-      <p:sp>
-        <p:nvSpPr>
-          <p:cNvPr id="4" name="TextBox 3"/>
+          <p:cNvPr id="3" name="TextBox 2"/>
           <p:cNvSpPr txBox="1"/>
           <p:nvPr/>
         </p:nvSpPr>
         <p:spPr>
           <a:xfrm>
-            <a:off x="411480" y="6565392"/>
-            <a:ext cx="8412480" cy="292608"/>
+            <a:off x="457200" y="384048"/>
+            <a:ext cx="8229600" cy="960120"/>
           </a:xfrm>
           <a:prstGeom prst="rect">
             <a:avLst/>
@@ -4143,43 +4124,48 @@
           <a:noFill/>
         </p:spPr>
         <p:txBody>
-          <a:bodyPr wrap="square"/>
-          <a:lstStyle/>
-          <a:p>
-            <a:pPr algn="l"/>
-            <a:r>
-              <a:rPr sz="1000" b="0">
-                <a:solidFill>
-                  <a:srgbClr val="F3ECDF"/>
+          <a:bodyPr wrap="square" lIns="0" rIns="0" tIns="0" bIns="0"/>
+          <a:lstStyle/>
+          <a:p>
+            <a:pPr>
+              <a:spcBef>
+                <a:spcPts val="0"/>
+              </a:spcBef>
+              <a:spcAft>
+                <a:spcPts val="200"/>
+              </a:spcAft>
+            </a:pPr>
+            <a:r>
+              <a:rPr sz="950" b="1" i="0">
+                <a:solidFill>
+                  <a:srgbClr val="1E3A8A"/>
                 </a:solidFill>
                 <a:latin typeface="Calibri"/>
               </a:rPr>
-              <a:t>ECO346  ·  FA24-BEDS-105  ·  Variant 5, KP urban  ·  PSLM 2019-20</a:t>
-            </a:r>
-          </a:p>
-        </p:txBody>
-      </p:sp>
-      <p:sp>
-        <p:nvSpPr>
-          <p:cNvPr id="5" name="TextBox 4"/>
-          <p:cNvSpPr txBox="1"/>
-          <p:nvPr/>
-        </p:nvSpPr>
-        <p:spPr>
-          <a:xfrm>
-            <a:off x="438912" y="201168"/>
-            <a:ext cx="8321040" cy="292608"/>
-          </a:xfrm>
-          <a:prstGeom prst="rect">
-            <a:avLst/>
-          </a:prstGeom>
-          <a:noFill/>
-        </p:spPr>
-        <p:txBody>
-          <a:bodyPr wrap="square"/>
-          <a:lstStyle/>
-          <a:p>
-            <a:pPr algn="l">
+              <a:t>QUESTION 2  ·  ANNUAL EDUCATION SPENDING PER STUDENT</a:t>
+            </a:r>
+          </a:p>
+          <a:p>
+            <a:pPr>
+              <a:spcBef>
+                <a:spcPts val="0"/>
+              </a:spcBef>
+              <a:spcAft>
+                <a:spcPts val="300"/>
+              </a:spcAft>
+            </a:pPr>
+            <a:r>
+              <a:rPr sz="2100" b="1" i="0">
+                <a:solidFill>
+                  <a:srgbClr val="0F172A"/>
+                </a:solidFill>
+                <a:latin typeface="Georgia"/>
+              </a:rPr>
+              <a:t>Education Spending is Heavily Right-Skewed</a:t>
+            </a:r>
+          </a:p>
+          <a:p>
+            <a:pPr>
               <a:spcBef>
                 <a:spcPts val="0"/>
               </a:spcBef>
@@ -4188,100 +4174,20 @@
               </a:spcAft>
             </a:pPr>
             <a:r>
-              <a:rPr sz="1100" b="1">
-                <a:solidFill>
-                  <a:srgbClr val="8E2F28"/>
+              <a:rPr sz="1150" b="0" i="0">
+                <a:solidFill>
+                  <a:srgbClr val="64748B"/>
                 </a:solidFill>
                 <a:latin typeface="Calibri"/>
               </a:rPr>
-              <a:t>QUESTION 4  ·  THE MAKEOVER</a:t>
-            </a:r>
-          </a:p>
-        </p:txBody>
-      </p:sp>
-      <p:sp>
-        <p:nvSpPr>
-          <p:cNvPr id="6" name="TextBox 5"/>
-          <p:cNvSpPr txBox="1"/>
-          <p:nvPr/>
-        </p:nvSpPr>
-        <p:spPr>
-          <a:xfrm>
-            <a:off x="411480" y="438912"/>
-            <a:ext cx="8412480" cy="658368"/>
-          </a:xfrm>
-          <a:prstGeom prst="rect">
-            <a:avLst/>
-          </a:prstGeom>
-          <a:noFill/>
-        </p:spPr>
-        <p:txBody>
-          <a:bodyPr wrap="square"/>
-          <a:lstStyle/>
-          <a:p>
-            <a:pPr algn="l">
-              <a:spcBef>
-                <a:spcPts val="0"/>
-              </a:spcBef>
-              <a:spcAft>
-                <a:spcPts val="0"/>
-              </a:spcAft>
-            </a:pPr>
-            <a:r>
-              <a:rPr sz="2600" b="1">
-                <a:solidFill>
-                  <a:srgbClr val="2A241F"/>
-                </a:solidFill>
-                <a:latin typeface="Georgia"/>
-              </a:rPr>
-              <a:t>Default scatter, then the redesign</a:t>
-            </a:r>
-          </a:p>
-        </p:txBody>
-      </p:sp>
-      <p:sp>
-        <p:nvSpPr>
-          <p:cNvPr id="7" name="TextBox 6"/>
-          <p:cNvSpPr txBox="1"/>
-          <p:nvPr/>
-        </p:nvSpPr>
-        <p:spPr>
-          <a:xfrm>
-            <a:off x="411480" y="1042415"/>
-            <a:ext cx="8412480" cy="329184"/>
-          </a:xfrm>
-          <a:prstGeom prst="rect">
-            <a:avLst/>
-          </a:prstGeom>
-          <a:noFill/>
-        </p:spPr>
-        <p:txBody>
-          <a:bodyPr wrap="square"/>
-          <a:lstStyle/>
-          <a:p>
-            <a:pPr algn="l">
-              <a:spcBef>
-                <a:spcPts val="0"/>
-              </a:spcBef>
-              <a:spcAft>
-                <a:spcPts val="0"/>
-              </a:spcAft>
-            </a:pPr>
-            <a:r>
-              <a:rPr sz="1300" b="0">
-                <a:solidFill>
-                  <a:srgbClr val="5E564C"/>
-                </a:solidFill>
-                <a:latin typeface="Calibri"/>
-              </a:rPr>
-              <a:t>Same literacy sample. Left is ggplot defaults only. Right is weighted rates by five-year age band.</a:t>
+              <a:t>Weighted histogram on log10 scale (Rs 100 to Rs 1,000,000; bin width 0.1; N = 1,060 students in KP urban).</a:t>
             </a:r>
           </a:p>
         </p:txBody>
       </p:sp>
       <p:pic>
         <p:nvPicPr>
-          <p:cNvPr id="8" name="Picture 7" descr="_default_slide.png"/>
+          <p:cNvPr id="4" name="Picture 3" descr="_distribution_slide.png"/>
           <p:cNvPicPr>
             <a:picLocks noChangeAspect="1"/>
           </p:cNvPicPr>
@@ -4301,144 +4207,34 @@
         </p:blipFill>
         <p:spPr>
           <a:xfrm>
-            <a:off x="365760" y="1417320"/>
-            <a:ext cx="4160520" cy="2971800"/>
+            <a:off x="457200" y="1463040"/>
+            <a:ext cx="4754880" cy="3268980"/>
           </a:xfrm>
           <a:prstGeom prst="rect">
             <a:avLst/>
           </a:prstGeom>
         </p:spPr>
       </p:pic>
-      <p:pic>
-        <p:nvPicPr>
-          <p:cNvPr id="9" name="Picture 8" descr="_literacy_slide.png"/>
-          <p:cNvPicPr>
-            <a:picLocks noChangeAspect="1"/>
-          </p:cNvPicPr>
-          <p:nvPr/>
-        </p:nvPicPr>
-        <p:blipFill>
-          <a:blip r:embed="rId4">
-            <a:extLst>
-              <a:ext uri="{96DAC541-7B7A-43D3-8B79-37D633B846F1}">
-                <ns1:svgBlip xmlns:ns1="http://schemas.microsoft.com/office/drawing/2016/SVG/main" r:embed="rId5"/>
-              </a:ext>
-            </a:extLst>
-          </a:blip>
-          <a:stretch>
-            <a:fillRect/>
-          </a:stretch>
-        </p:blipFill>
-        <p:spPr>
-          <a:xfrm>
-            <a:off x="4617720" y="1417320"/>
-            <a:ext cx="4160520" cy="2692101"/>
-          </a:xfrm>
-          <a:prstGeom prst="rect">
-            <a:avLst/>
-          </a:prstGeom>
-        </p:spPr>
-      </p:pic>
-      <p:sp>
-        <p:nvSpPr>
-          <p:cNvPr id="10" name="TextBox 9"/>
-          <p:cNvSpPr txBox="1"/>
-          <p:nvPr/>
-        </p:nvSpPr>
-        <p:spPr>
-          <a:xfrm>
-            <a:off x="365760" y="4462272"/>
-            <a:ext cx="4160520" cy="256032"/>
-          </a:xfrm>
-          <a:prstGeom prst="rect">
-            <a:avLst/>
-          </a:prstGeom>
-          <a:noFill/>
-        </p:spPr>
-        <p:txBody>
-          <a:bodyPr wrap="square"/>
-          <a:lstStyle/>
-          <a:p>
-            <a:pPr algn="ctr">
-              <a:spcBef>
-                <a:spcPts val="0"/>
-              </a:spcBef>
-              <a:spcAft>
-                <a:spcPts val="0"/>
-              </a:spcAft>
-            </a:pPr>
-            <a:r>
-              <a:rPr sz="1200" b="1">
-                <a:solidFill>
-                  <a:srgbClr val="5E564C"/>
-                </a:solidFill>
-                <a:latin typeface="Calibri"/>
-              </a:rPr>
-              <a:t>DEFAULT  ·  overplotted 0/1 points</a:t>
-            </a:r>
-          </a:p>
-        </p:txBody>
-      </p:sp>
-      <p:sp>
-        <p:nvSpPr>
-          <p:cNvPr id="11" name="TextBox 10"/>
-          <p:cNvSpPr txBox="1"/>
-          <p:nvPr/>
-        </p:nvSpPr>
-        <p:spPr>
-          <a:xfrm>
-            <a:off x="4617720" y="4462272"/>
-            <a:ext cx="4160520" cy="256032"/>
-          </a:xfrm>
-          <a:prstGeom prst="rect">
-            <a:avLst/>
-          </a:prstGeom>
-          <a:noFill/>
-        </p:spPr>
-        <p:txBody>
-          <a:bodyPr wrap="square"/>
-          <a:lstStyle/>
-          <a:p>
-            <a:pPr algn="ctr">
-              <a:spcBef>
-                <a:spcPts val="0"/>
-              </a:spcBef>
-              <a:spcAft>
-                <a:spcPts val="0"/>
-              </a:spcAft>
-            </a:pPr>
-            <a:r>
-              <a:rPr sz="1200" b="1">
-                <a:solidFill>
-                  <a:srgbClr val="5E564C"/>
-                </a:solidFill>
-                <a:latin typeface="Calibri"/>
-              </a:rPr>
-              <a:t>REDESIGN  ·  conditional means</a:t>
-            </a:r>
-          </a:p>
-        </p:txBody>
-      </p:sp>
-      <p:sp>
-        <p:nvSpPr>
-          <p:cNvPr id="12" name="Rectangle 11"/>
+      <p:sp>
+        <p:nvSpPr>
+          <p:cNvPr id="5" name="Rectangle 4"/>
           <p:cNvSpPr/>
           <p:nvPr/>
         </p:nvSpPr>
         <p:spPr>
           <a:xfrm>
-            <a:off x="411480" y="4773168"/>
-            <a:ext cx="2697480" cy="1627632"/>
+            <a:off x="5376672" y="1463040"/>
+            <a:ext cx="3310128" cy="1463040"/>
           </a:xfrm>
           <a:prstGeom prst="rect">
             <a:avLst/>
           </a:prstGeom>
           <a:solidFill>
-            <a:srgbClr val="FBF7F0"/>
+            <a:srgbClr val="F8FAFC"/>
           </a:solidFill>
           <a:ln w="9525">
             <a:solidFill>
-              <a:srgbClr val="D4C8B4"/>
+              <a:srgbClr val="E2E8F0"/>
             </a:solidFill>
           </a:ln>
           <a:effectLst/>
@@ -4467,105 +4263,23 @@
       </p:sp>
       <p:sp>
         <p:nvSpPr>
-          <p:cNvPr id="13" name="TextBox 12"/>
-          <p:cNvSpPr txBox="1"/>
-          <p:nvPr/>
-        </p:nvSpPr>
-        <p:spPr>
-          <a:xfrm>
-            <a:off x="539496" y="4864608"/>
-            <a:ext cx="2441448" cy="329184"/>
-          </a:xfrm>
-          <a:prstGeom prst="rect">
-            <a:avLst/>
-          </a:prstGeom>
-          <a:noFill/>
-        </p:spPr>
-        <p:txBody>
-          <a:bodyPr wrap="square"/>
-          <a:lstStyle/>
-          <a:p>
-            <a:pPr algn="l">
-              <a:spcBef>
-                <a:spcPts val="0"/>
-              </a:spcBef>
-              <a:spcAft>
-                <a:spcPts val="0"/>
-              </a:spcAft>
-            </a:pPr>
-            <a:r>
-              <a:rPr sz="1400" b="1">
-                <a:solidFill>
-                  <a:srgbClr val="8E2F28"/>
-                </a:solidFill>
-                <a:latin typeface="Georgia"/>
-              </a:rPr>
-              <a:t>Conditional means</a:t>
-            </a:r>
-          </a:p>
-        </p:txBody>
-      </p:sp>
-      <p:sp>
-        <p:nvSpPr>
-          <p:cNvPr id="14" name="TextBox 13"/>
-          <p:cNvSpPr txBox="1"/>
-          <p:nvPr/>
-        </p:nvSpPr>
-        <p:spPr>
-          <a:xfrm>
-            <a:off x="539496" y="5212080"/>
-            <a:ext cx="2441448" cy="1078992"/>
-          </a:xfrm>
-          <a:prstGeom prst="rect">
-            <a:avLst/>
-          </a:prstGeom>
-          <a:noFill/>
-        </p:spPr>
-        <p:txBody>
-          <a:bodyPr wrap="square"/>
-          <a:lstStyle/>
-          <a:p>
-            <a:pPr algn="l">
-              <a:spcBef>
-                <a:spcPts val="0"/>
-              </a:spcBef>
-              <a:spcAft>
-                <a:spcPts val="0"/>
-              </a:spcAft>
-            </a:pPr>
-            <a:r>
-              <a:rPr sz="1200" b="0">
-                <a:solidFill>
-                  <a:srgbClr val="5E564C"/>
-                </a:solidFill>
-                <a:latin typeface="Calibri"/>
-              </a:rPr>
-              <a:t>Band averages show the age pattern that overlapping dots hide (overplotting).</a:t>
-            </a:r>
-          </a:p>
-        </p:txBody>
-      </p:sp>
-      <p:sp>
-        <p:nvSpPr>
-          <p:cNvPr id="15" name="Rectangle 14"/>
+          <p:cNvPr id="6" name="Rectangle 5"/>
           <p:cNvSpPr/>
           <p:nvPr/>
         </p:nvSpPr>
         <p:spPr>
           <a:xfrm>
-            <a:off x="3218688" y="4773168"/>
-            <a:ext cx="2697480" cy="1627632"/>
+            <a:off x="5376672" y="1463040"/>
+            <a:ext cx="3310128" cy="36576"/>
           </a:xfrm>
           <a:prstGeom prst="rect">
             <a:avLst/>
           </a:prstGeom>
           <a:solidFill>
-            <a:srgbClr val="FBF7F0"/>
+            <a:srgbClr val="0D9488"/>
           </a:solidFill>
-          <a:ln w="9525">
-            <a:solidFill>
-              <a:srgbClr val="D4C8B4"/>
-            </a:solidFill>
+          <a:ln>
+            <a:noFill/>
           </a:ln>
           <a:effectLst/>
         </p:spPr>
@@ -4593,14 +4307,14 @@
       </p:sp>
       <p:sp>
         <p:nvSpPr>
-          <p:cNvPr id="16" name="TextBox 15"/>
+          <p:cNvPr id="7" name="TextBox 6"/>
           <p:cNvSpPr txBox="1"/>
           <p:nvPr/>
         </p:nvSpPr>
         <p:spPr>
           <a:xfrm>
-            <a:off x="3346704" y="4864608"/>
-            <a:ext cx="2441448" cy="329184"/>
+            <a:off x="5504688" y="1572768"/>
+            <a:ext cx="3054096" cy="1280160"/>
           </a:xfrm>
           <a:prstGeom prst="rect">
             <a:avLst/>
@@ -4608,39 +4322,75 @@
           <a:noFill/>
         </p:spPr>
         <p:txBody>
-          <a:bodyPr wrap="square"/>
-          <a:lstStyle/>
-          <a:p>
-            <a:pPr algn="l">
-              <a:spcBef>
-                <a:spcPts val="0"/>
-              </a:spcBef>
-              <a:spcAft>
-                <a:spcPts val="0"/>
-              </a:spcAft>
-            </a:pPr>
-            <a:r>
-              <a:rPr sz="1400" b="1">
-                <a:solidFill>
-                  <a:srgbClr val="8E2F28"/>
+          <a:bodyPr wrap="square" lIns="0" rIns="0" tIns="0" bIns="0"/>
+          <a:lstStyle/>
+          <a:p>
+            <a:r>
+              <a:rPr sz="900" b="1" i="0">
+                <a:solidFill>
+                  <a:srgbClr val="0D9488"/>
+                </a:solidFill>
+                <a:latin typeface="Calibri"/>
+              </a:rPr>
+              <a:t>MEDIAN SPENDING: WEIGHTED VS SAMPLE</a:t>
+            </a:r>
+          </a:p>
+        </p:txBody>
+      </p:sp>
+      <p:sp>
+        <p:nvSpPr>
+          <p:cNvPr id="8" name="TextBox 7"/>
+          <p:cNvSpPr txBox="1"/>
+          <p:nvPr/>
+        </p:nvSpPr>
+        <p:spPr>
+          <a:xfrm>
+            <a:off x="5504688" y="1719072"/>
+            <a:ext cx="1463040" cy="502920"/>
+          </a:xfrm>
+          <a:prstGeom prst="rect">
+            <a:avLst/>
+          </a:prstGeom>
+          <a:noFill/>
+        </p:spPr>
+        <p:txBody>
+          <a:bodyPr wrap="none" lIns="0" rIns="0" tIns="0" bIns="0">
+            <a:spAutoFit/>
+          </a:bodyPr>
+          <a:lstStyle/>
+          <a:p>
+            <a:r>
+              <a:rPr sz="1900" b="1" i="0">
+                <a:solidFill>
+                  <a:srgbClr val="0D9488"/>
                 </a:solidFill>
                 <a:latin typeface="Georgia"/>
               </a:rPr>
-              <a:t>Position, then colour</a:t>
-            </a:r>
-          </a:p>
-        </p:txBody>
-      </p:sp>
-      <p:sp>
-        <p:nvSpPr>
-          <p:cNvPr id="17" name="TextBox 16"/>
+              <a:t>Rs 9,500
+</a:t>
+            </a:r>
+            <a:r>
+              <a:rPr sz="950" b="1" i="0">
+                <a:solidFill>
+                  <a:srgbClr val="0D9488"/>
+                </a:solidFill>
+                <a:latin typeface="Calibri"/>
+              </a:rPr>
+              <a:t>Weighted Population</a:t>
+            </a:r>
+          </a:p>
+        </p:txBody>
+      </p:sp>
+      <p:sp>
+        <p:nvSpPr>
+          <p:cNvPr id="9" name="TextBox 8"/>
           <p:cNvSpPr txBox="1"/>
           <p:nvPr/>
         </p:nvSpPr>
         <p:spPr>
           <a:xfrm>
-            <a:off x="3346704" y="5212080"/>
-            <a:ext cx="2441448" cy="1078992"/>
+            <a:off x="7068312" y="1719072"/>
+            <a:ext cx="1463040" cy="502920"/>
           </a:xfrm>
           <a:prstGeom prst="rect">
             <a:avLst/>
@@ -4648,49 +4398,87 @@
           <a:noFill/>
         </p:spPr>
         <p:txBody>
-          <a:bodyPr wrap="square"/>
-          <a:lstStyle/>
-          <a:p>
-            <a:pPr algn="l">
-              <a:spcBef>
-                <a:spcPts val="0"/>
-              </a:spcBef>
-              <a:spcAft>
-                <a:spcPts val="0"/>
-              </a:spcAft>
-            </a:pPr>
-            <a:r>
-              <a:rPr sz="1200" b="0">
-                <a:solidFill>
-                  <a:srgbClr val="5E564C"/>
+          <a:bodyPr wrap="none" lIns="0" rIns="0" tIns="0" bIns="0">
+            <a:spAutoFit/>
+          </a:bodyPr>
+          <a:lstStyle/>
+          <a:p>
+            <a:r>
+              <a:rPr sz="1900" b="1" i="0">
+                <a:solidFill>
+                  <a:srgbClr val="64748B"/>
+                </a:solidFill>
+                <a:latin typeface="Georgia"/>
+              </a:rPr>
+              <a:t>Rs 10,000
+</a:t>
+            </a:r>
+            <a:r>
+              <a:rPr sz="950" b="1" i="0">
+                <a:solidFill>
+                  <a:srgbClr val="64748B"/>
                 </a:solidFill>
                 <a:latin typeface="Calibri"/>
               </a:rPr>
-              <a:t>Age and the rate sit on position, the strongest channel. Colour only splits men and women.</a:t>
-            </a:r>
-          </a:p>
-        </p:txBody>
-      </p:sp>
-      <p:sp>
-        <p:nvSpPr>
-          <p:cNvPr id="18" name="Rectangle 17"/>
+              <a:t>Unweighted Sample</a:t>
+            </a:r>
+          </a:p>
+        </p:txBody>
+      </p:sp>
+      <p:sp>
+        <p:nvSpPr>
+          <p:cNvPr id="10" name="TextBox 9"/>
+          <p:cNvSpPr txBox="1"/>
+          <p:nvPr/>
+        </p:nvSpPr>
+        <p:spPr>
+          <a:xfrm>
+            <a:off x="5504688" y="2331720"/>
+            <a:ext cx="3054096" cy="530352"/>
+          </a:xfrm>
+          <a:prstGeom prst="rect">
+            <a:avLst/>
+          </a:prstGeom>
+          <a:noFill/>
+        </p:spPr>
+        <p:txBody>
+          <a:bodyPr wrap="square" lIns="0" rIns="0" tIns="0" bIns="0">
+            <a:spAutoFit/>
+          </a:bodyPr>
+          <a:lstStyle/>
+          <a:p>
+            <a:r>
+              <a:rPr sz="950" b="0" i="0">
+                <a:solidFill>
+                  <a:srgbClr val="334155"/>
+                </a:solidFill>
+                <a:latin typeface="Calibri"/>
+              </a:rPr>
+              <a:t>Students below sample median have higher average survey weights (274.9 vs 228.4), pulling the weighted median downward.</a:t>
+            </a:r>
+          </a:p>
+        </p:txBody>
+      </p:sp>
+      <p:sp>
+        <p:nvSpPr>
+          <p:cNvPr id="11" name="Rectangle 10"/>
           <p:cNvSpPr/>
           <p:nvPr/>
         </p:nvSpPr>
         <p:spPr>
           <a:xfrm>
-            <a:off x="6035040" y="4773168"/>
-            <a:ext cx="2697480" cy="1627632"/>
+            <a:off x="5376672" y="3035808"/>
+            <a:ext cx="3310128" cy="1463040"/>
           </a:xfrm>
           <a:prstGeom prst="rect">
             <a:avLst/>
           </a:prstGeom>
           <a:solidFill>
-            <a:srgbClr val="FBF7F0"/>
+            <a:srgbClr val="F8FAFC"/>
           </a:solidFill>
           <a:ln w="9525">
             <a:solidFill>
-              <a:srgbClr val="D4C8B4"/>
+              <a:srgbClr val="E2E8F0"/>
             </a:solidFill>
           </a:ln>
           <a:effectLst/>
@@ -4719,14 +4507,302 @@
       </p:sp>
       <p:sp>
         <p:nvSpPr>
+          <p:cNvPr id="12" name="Rectangle 11"/>
+          <p:cNvSpPr/>
+          <p:nvPr/>
+        </p:nvSpPr>
+        <p:spPr>
+          <a:xfrm>
+            <a:off x="5376672" y="3035808"/>
+            <a:ext cx="3310128" cy="36576"/>
+          </a:xfrm>
+          <a:prstGeom prst="rect">
+            <a:avLst/>
+          </a:prstGeom>
+          <a:solidFill>
+            <a:srgbClr val="1E3A8A"/>
+          </a:solidFill>
+          <a:ln>
+            <a:noFill/>
+          </a:ln>
+          <a:effectLst/>
+        </p:spPr>
+        <p:style>
+          <a:lnRef idx="1">
+            <a:schemeClr val="accent1"/>
+          </a:lnRef>
+          <a:fillRef idx="3">
+            <a:schemeClr val="accent1"/>
+          </a:fillRef>
+          <a:effectRef idx="2">
+            <a:schemeClr val="accent1"/>
+          </a:effectRef>
+          <a:fontRef idx="minor">
+            <a:schemeClr val="lt1"/>
+          </a:fontRef>
+        </p:style>
+        <p:txBody>
+          <a:bodyPr rtlCol="0" anchor="ctr"/>
+          <a:lstStyle/>
+          <a:p>
+            <a:pPr algn="ctr"/>
+          </a:p>
+        </p:txBody>
+      </p:sp>
+      <p:sp>
+        <p:nvSpPr>
+          <p:cNvPr id="13" name="TextBox 12"/>
+          <p:cNvSpPr txBox="1"/>
+          <p:nvPr/>
+        </p:nvSpPr>
+        <p:spPr>
+          <a:xfrm>
+            <a:off x="5504688" y="3145536"/>
+            <a:ext cx="3054096" cy="1280160"/>
+          </a:xfrm>
+          <a:prstGeom prst="rect">
+            <a:avLst/>
+          </a:prstGeom>
+          <a:noFill/>
+        </p:spPr>
+        <p:txBody>
+          <a:bodyPr wrap="square" lIns="0" rIns="0" tIns="0" bIns="0"/>
+          <a:lstStyle/>
+          <a:p>
+            <a:r>
+              <a:rPr sz="900" b="1" i="0">
+                <a:solidFill>
+                  <a:srgbClr val="1E3A8A"/>
+                </a:solidFill>
+                <a:latin typeface="Calibri"/>
+              </a:rPr>
+              <a:t>PERCENTILE DISPARITY (P90 / P10)</a:t>
+            </a:r>
+          </a:p>
+        </p:txBody>
+      </p:sp>
+      <p:sp>
+        <p:nvSpPr>
+          <p:cNvPr id="14" name="TextBox 13"/>
+          <p:cNvSpPr txBox="1"/>
+          <p:nvPr/>
+        </p:nvSpPr>
+        <p:spPr>
+          <a:xfrm>
+            <a:off x="5504688" y="3291840"/>
+            <a:ext cx="1463040" cy="502920"/>
+          </a:xfrm>
+          <a:prstGeom prst="rect">
+            <a:avLst/>
+          </a:prstGeom>
+          <a:noFill/>
+        </p:spPr>
+        <p:txBody>
+          <a:bodyPr wrap="none" lIns="0" rIns="0" tIns="0" bIns="0">
+            <a:spAutoFit/>
+          </a:bodyPr>
+          <a:lstStyle/>
+          <a:p>
+            <a:r>
+              <a:rPr sz="2000" b="1" i="0">
+                <a:solidFill>
+                  <a:srgbClr val="1E3A8A"/>
+                </a:solidFill>
+                <a:latin typeface="Georgia"/>
+              </a:rPr>
+              <a:t>12.38 ×
+</a:t>
+            </a:r>
+            <a:r>
+              <a:rPr sz="950" b="1" i="0">
+                <a:solidFill>
+                  <a:srgbClr val="1E3A8A"/>
+                </a:solidFill>
+                <a:latin typeface="Calibri"/>
+              </a:rPr>
+              <a:t>P90 / P10 Ratio</a:t>
+            </a:r>
+          </a:p>
+        </p:txBody>
+      </p:sp>
+      <p:sp>
+        <p:nvSpPr>
+          <p:cNvPr id="15" name="TextBox 14"/>
+          <p:cNvSpPr txBox="1"/>
+          <p:nvPr/>
+        </p:nvSpPr>
+        <p:spPr>
+          <a:xfrm>
+            <a:off x="7068312" y="3291840"/>
+            <a:ext cx="1463040" cy="502920"/>
+          </a:xfrm>
+          <a:prstGeom prst="rect">
+            <a:avLst/>
+          </a:prstGeom>
+          <a:noFill/>
+        </p:spPr>
+        <p:txBody>
+          <a:bodyPr wrap="none" lIns="0" rIns="0" tIns="0" bIns="0">
+            <a:spAutoFit/>
+          </a:bodyPr>
+          <a:lstStyle/>
+          <a:p>
+            <a:r>
+              <a:rPr sz="1800" b="1" i="0">
+                <a:solidFill>
+                  <a:srgbClr val="0F172A"/>
+                </a:solidFill>
+                <a:latin typeface="Georgia"/>
+              </a:rPr>
+              <a:t>Rs 39,000
+</a:t>
+            </a:r>
+            <a:r>
+              <a:rPr sz="900" b="0" i="0">
+                <a:solidFill>
+                  <a:srgbClr val="64748B"/>
+                </a:solidFill>
+                <a:latin typeface="Calibri"/>
+              </a:rPr>
+              <a:t>90th Pct (P10: Rs 3,150)</a:t>
+            </a:r>
+          </a:p>
+        </p:txBody>
+      </p:sp>
+      <p:sp>
+        <p:nvSpPr>
+          <p:cNvPr id="16" name="TextBox 15"/>
+          <p:cNvSpPr txBox="1"/>
+          <p:nvPr/>
+        </p:nvSpPr>
+        <p:spPr>
+          <a:xfrm>
+            <a:off x="5504688" y="3913632"/>
+            <a:ext cx="3054096" cy="502920"/>
+          </a:xfrm>
+          <a:prstGeom prst="rect">
+            <a:avLst/>
+          </a:prstGeom>
+          <a:noFill/>
+        </p:spPr>
+        <p:txBody>
+          <a:bodyPr wrap="square" lIns="0" rIns="0" tIns="0" bIns="0">
+            <a:spAutoFit/>
+          </a:bodyPr>
+          <a:lstStyle/>
+          <a:p>
+            <a:r>
+              <a:rPr sz="950" b="0" i="0">
+                <a:solidFill>
+                  <a:srgbClr val="334155"/>
+                </a:solidFill>
+                <a:latin typeface="Calibri"/>
+              </a:rPr>
+              <a:t>Stark expenditure gap: top 10% of households spend over 12 times more per student than the bottom 10%.</a:t>
+            </a:r>
+          </a:p>
+        </p:txBody>
+      </p:sp>
+      <p:sp>
+        <p:nvSpPr>
+          <p:cNvPr id="17" name="Rectangle 16"/>
+          <p:cNvSpPr/>
+          <p:nvPr/>
+        </p:nvSpPr>
+        <p:spPr>
+          <a:xfrm>
+            <a:off x="5376672" y="4608576"/>
+            <a:ext cx="3310128" cy="1664208"/>
+          </a:xfrm>
+          <a:prstGeom prst="rect">
+            <a:avLst/>
+          </a:prstGeom>
+          <a:solidFill>
+            <a:srgbClr val="F8FAFC"/>
+          </a:solidFill>
+          <a:ln w="9525">
+            <a:solidFill>
+              <a:srgbClr val="E2E8F0"/>
+            </a:solidFill>
+          </a:ln>
+          <a:effectLst/>
+        </p:spPr>
+        <p:style>
+          <a:lnRef idx="1">
+            <a:schemeClr val="accent1"/>
+          </a:lnRef>
+          <a:fillRef idx="3">
+            <a:schemeClr val="accent1"/>
+          </a:fillRef>
+          <a:effectRef idx="2">
+            <a:schemeClr val="accent1"/>
+          </a:effectRef>
+          <a:fontRef idx="minor">
+            <a:schemeClr val="lt1"/>
+          </a:fontRef>
+        </p:style>
+        <p:txBody>
+          <a:bodyPr rtlCol="0" anchor="ctr"/>
+          <a:lstStyle/>
+          <a:p>
+            <a:pPr algn="ctr"/>
+          </a:p>
+        </p:txBody>
+      </p:sp>
+      <p:sp>
+        <p:nvSpPr>
+          <p:cNvPr id="18" name="Rectangle 17"/>
+          <p:cNvSpPr/>
+          <p:nvPr/>
+        </p:nvSpPr>
+        <p:spPr>
+          <a:xfrm>
+            <a:off x="5376672" y="4608576"/>
+            <a:ext cx="3310128" cy="36576"/>
+          </a:xfrm>
+          <a:prstGeom prst="rect">
+            <a:avLst/>
+          </a:prstGeom>
+          <a:solidFill>
+            <a:srgbClr val="CBD5E1"/>
+          </a:solidFill>
+          <a:ln>
+            <a:noFill/>
+          </a:ln>
+          <a:effectLst/>
+        </p:spPr>
+        <p:style>
+          <a:lnRef idx="1">
+            <a:schemeClr val="accent1"/>
+          </a:lnRef>
+          <a:fillRef idx="3">
+            <a:schemeClr val="accent1"/>
+          </a:fillRef>
+          <a:effectRef idx="2">
+            <a:schemeClr val="accent1"/>
+          </a:effectRef>
+          <a:fontRef idx="minor">
+            <a:schemeClr val="lt1"/>
+          </a:fontRef>
+        </p:style>
+        <p:txBody>
+          <a:bodyPr rtlCol="0" anchor="ctr"/>
+          <a:lstStyle/>
+          <a:p>
+            <a:pPr algn="ctr"/>
+          </a:p>
+        </p:txBody>
+      </p:sp>
+      <p:sp>
+        <p:nvSpPr>
           <p:cNvPr id="19" name="TextBox 18"/>
           <p:cNvSpPr txBox="1"/>
           <p:nvPr/>
         </p:nvSpPr>
         <p:spPr>
           <a:xfrm>
-            <a:off x="6163056" y="4864608"/>
-            <a:ext cx="2441448" cy="329184"/>
+            <a:off x="5504688" y="4718304"/>
+            <a:ext cx="3054096" cy="1481328"/>
           </a:xfrm>
           <a:prstGeom prst="rect">
             <a:avLst/>
@@ -4734,39 +4810,95 @@
           <a:noFill/>
         </p:spPr>
         <p:txBody>
-          <a:bodyPr wrap="square"/>
-          <a:lstStyle/>
-          <a:p>
-            <a:pPr algn="l">
+          <a:bodyPr wrap="square" lIns="0" rIns="0" tIns="0" bIns="0"/>
+          <a:lstStyle/>
+          <a:p>
+            <a:r>
+              <a:rPr sz="900" b="1" i="0">
+                <a:solidFill>
+                  <a:srgbClr val="64748B"/>
+                </a:solidFill>
+                <a:latin typeface="Calibri"/>
+              </a:rPr>
+              <a:t>SAMPLE ARCHITECTURE &amp; EXCLUSION</a:t>
+            </a:r>
+          </a:p>
+          <a:p>
+            <a:pPr>
               <a:spcBef>
-                <a:spcPts val="0"/>
+                <a:spcPts val="300"/>
               </a:spcBef>
-              <a:spcAft>
-                <a:spcPts val="0"/>
-              </a:spcAft>
             </a:pPr>
             <a:r>
-              <a:rPr sz="1400" b="1">
-                <a:solidFill>
-                  <a:srgbClr val="8E2F28"/>
-                </a:solidFill>
-                <a:latin typeface="Georgia"/>
-              </a:rPr>
-              <a:t>Data-ink</a:t>
-            </a:r>
-          </a:p>
-        </p:txBody>
-      </p:sp>
-      <p:sp>
-        <p:nvSpPr>
-          <p:cNvPr id="20" name="TextBox 19"/>
+              <a:rPr sz="1000" b="0" i="0">
+                <a:solidFill>
+                  <a:srgbClr val="334155"/>
+                </a:solidFill>
+                <a:latin typeface="Calibri"/>
+              </a:rPr>
+              <a:t>• Students with ed_total &gt; 0: n = 1,061
+• Analysed in histogram (Rs 100–1M): n = 1,060
+• Outlier excluded: 1 student (spending = Rs 80)
+• Population weighted mean: Rs 19,146
+• Log10 scale makes high positive skewness interpretable.</a:t>
+            </a:r>
+          </a:p>
+        </p:txBody>
+      </p:sp>
+      <p:sp>
+        <p:nvSpPr>
+          <p:cNvPr id="20" name="Rectangle 19"/>
+          <p:cNvSpPr/>
+          <p:nvPr/>
+        </p:nvSpPr>
+        <p:spPr>
+          <a:xfrm>
+            <a:off x="457200" y="6473952"/>
+            <a:ext cx="8229600" cy="9144"/>
+          </a:xfrm>
+          <a:prstGeom prst="rect">
+            <a:avLst/>
+          </a:prstGeom>
+          <a:solidFill>
+            <a:srgbClr val="CBD5E1"/>
+          </a:solidFill>
+          <a:ln>
+            <a:noFill/>
+          </a:ln>
+          <a:effectLst/>
+        </p:spPr>
+        <p:style>
+          <a:lnRef idx="1">
+            <a:schemeClr val="accent1"/>
+          </a:lnRef>
+          <a:fillRef idx="3">
+            <a:schemeClr val="accent1"/>
+          </a:fillRef>
+          <a:effectRef idx="2">
+            <a:schemeClr val="accent1"/>
+          </a:effectRef>
+          <a:fontRef idx="minor">
+            <a:schemeClr val="lt1"/>
+          </a:fontRef>
+        </p:style>
+        <p:txBody>
+          <a:bodyPr rtlCol="0" anchor="ctr"/>
+          <a:lstStyle/>
+          <a:p>
+            <a:pPr algn="ctr"/>
+          </a:p>
+        </p:txBody>
+      </p:sp>
+      <p:sp>
+        <p:nvSpPr>
+          <p:cNvPr id="21" name="TextBox 20"/>
           <p:cNvSpPr txBox="1"/>
           <p:nvPr/>
         </p:nvSpPr>
         <p:spPr>
           <a:xfrm>
-            <a:off x="6163056" y="5212080"/>
-            <a:ext cx="2441448" cy="1078992"/>
+            <a:off x="457200" y="6528816"/>
+            <a:ext cx="6400800" cy="228600"/>
           </a:xfrm>
           <a:prstGeom prst="rect">
             <a:avLst/>
@@ -4774,25 +4906,54 @@
           <a:noFill/>
         </p:spPr>
         <p:txBody>
-          <a:bodyPr wrap="square"/>
-          <a:lstStyle/>
-          <a:p>
-            <a:pPr algn="l">
-              <a:spcBef>
-                <a:spcPts val="0"/>
-              </a:spcBef>
-              <a:spcAft>
-                <a:spcPts val="0"/>
-              </a:spcAft>
-            </a:pPr>
-            <a:r>
-              <a:rPr sz="1200" b="0">
-                <a:solidFill>
-                  <a:srgbClr val="5E564C"/>
+          <a:bodyPr wrap="none" lIns="0" rIns="0" tIns="0" bIns="0">
+            <a:spAutoFit/>
+          </a:bodyPr>
+          <a:lstStyle/>
+          <a:p>
+            <a:r>
+              <a:rPr sz="950" b="0" i="0">
+                <a:solidFill>
+                  <a:srgbClr val="64748B"/>
                 </a:solidFill>
                 <a:latin typeface="Calibri"/>
               </a:rPr>
-              <a:t>No legend: each series is labelled at its end. Hollow markers would mark thin cells (none here).</a:t>
+              <a:t>ECO346 Data Visualization · FA24-BEDS-105 · Variant 5 (KP Urban) · PSLM 2019–20</a:t>
+            </a:r>
+          </a:p>
+        </p:txBody>
+      </p:sp>
+      <p:sp>
+        <p:nvSpPr>
+          <p:cNvPr id="22" name="TextBox 21"/>
+          <p:cNvSpPr txBox="1"/>
+          <p:nvPr/>
+        </p:nvSpPr>
+        <p:spPr>
+          <a:xfrm>
+            <a:off x="6949440" y="6528816"/>
+            <a:ext cx="1737360" cy="228600"/>
+          </a:xfrm>
+          <a:prstGeom prst="rect">
+            <a:avLst/>
+          </a:prstGeom>
+          <a:noFill/>
+        </p:spPr>
+        <p:txBody>
+          <a:bodyPr wrap="none" lIns="0" rIns="0" tIns="0" bIns="0">
+            <a:spAutoFit/>
+          </a:bodyPr>
+          <a:lstStyle/>
+          <a:p>
+            <a:pPr algn="r"/>
+            <a:r>
+              <a:rPr sz="950" b="0" i="0">
+                <a:solidFill>
+                  <a:srgbClr val="64748B"/>
+                </a:solidFill>
+                <a:latin typeface="Calibri"/>
+              </a:rPr>
+              <a:t>Slide 2 of 4</a:t>
             </a:r>
           </a:p>
         </p:txBody>
@@ -4811,7 +4972,7 @@
     <p:bg>
       <p:bgPr>
         <a:solidFill>
-          <a:srgbClr val="F3ECDF"/>
+          <a:srgbClr val="FFFFFF"/>
         </a:solidFill>
         <a:effectLst/>
       </p:bgPr>
@@ -4831,14 +4992,14 @@
         </p:nvSpPr>
         <p:spPr>
           <a:xfrm>
-            <a:off x="0" y="0"/>
-            <a:ext cx="164592" cy="6858000"/>
+            <a:off x="457200" y="310896"/>
+            <a:ext cx="365760" cy="36576"/>
           </a:xfrm>
           <a:prstGeom prst="rect">
             <a:avLst/>
           </a:prstGeom>
           <a:solidFill>
-            <a:srgbClr val="8E2F28"/>
+            <a:srgbClr val="1E3A8A"/>
           </a:solidFill>
           <a:ln>
             <a:noFill/>
@@ -4869,58 +5030,14 @@
       </p:sp>
       <p:sp>
         <p:nvSpPr>
-          <p:cNvPr id="3" name="Rectangle 2"/>
-          <p:cNvSpPr/>
-          <p:nvPr/>
-        </p:nvSpPr>
-        <p:spPr>
-          <a:xfrm>
-            <a:off x="164592" y="6565392"/>
-            <a:ext cx="8979408" cy="292608"/>
-          </a:xfrm>
-          <a:prstGeom prst="rect">
-            <a:avLst/>
-          </a:prstGeom>
-          <a:solidFill>
-            <a:srgbClr val="2E4A3F"/>
-          </a:solidFill>
-          <a:ln>
-            <a:noFill/>
-          </a:ln>
-          <a:effectLst/>
-        </p:spPr>
-        <p:style>
-          <a:lnRef idx="1">
-            <a:schemeClr val="accent1"/>
-          </a:lnRef>
-          <a:fillRef idx="3">
-            <a:schemeClr val="accent1"/>
-          </a:fillRef>
-          <a:effectRef idx="2">
-            <a:schemeClr val="accent1"/>
-          </a:effectRef>
-          <a:fontRef idx="minor">
-            <a:schemeClr val="lt1"/>
-          </a:fontRef>
-        </p:style>
-        <p:txBody>
-          <a:bodyPr rtlCol="0" anchor="ctr"/>
-          <a:lstStyle/>
-          <a:p>
-            <a:pPr algn="ctr"/>
-          </a:p>
-        </p:txBody>
-      </p:sp>
-      <p:sp>
-        <p:nvSpPr>
-          <p:cNvPr id="4" name="TextBox 3"/>
+          <p:cNvPr id="3" name="TextBox 2"/>
           <p:cNvSpPr txBox="1"/>
           <p:nvPr/>
         </p:nvSpPr>
         <p:spPr>
           <a:xfrm>
-            <a:off x="411480" y="6565392"/>
-            <a:ext cx="8412480" cy="292608"/>
+            <a:off x="457200" y="384048"/>
+            <a:ext cx="8229600" cy="960120"/>
           </a:xfrm>
           <a:prstGeom prst="rect">
             <a:avLst/>
@@ -4928,43 +5045,48 @@
           <a:noFill/>
         </p:spPr>
         <p:txBody>
-          <a:bodyPr wrap="square"/>
-          <a:lstStyle/>
-          <a:p>
-            <a:pPr algn="l"/>
-            <a:r>
-              <a:rPr sz="1000" b="0">
-                <a:solidFill>
-                  <a:srgbClr val="F3ECDF"/>
+          <a:bodyPr wrap="square" lIns="0" rIns="0" tIns="0" bIns="0"/>
+          <a:lstStyle/>
+          <a:p>
+            <a:pPr>
+              <a:spcBef>
+                <a:spcPts val="0"/>
+              </a:spcBef>
+              <a:spcAft>
+                <a:spcPts val="200"/>
+              </a:spcAft>
+            </a:pPr>
+            <a:r>
+              <a:rPr sz="950" b="1" i="0">
+                <a:solidFill>
+                  <a:srgbClr val="1E3A8A"/>
                 </a:solidFill>
                 <a:latin typeface="Calibri"/>
               </a:rPr>
-              <a:t>ECO346  ·  FA24-BEDS-105  ·  Variant 5, KP urban  ·  PSLM 2019-20</a:t>
-            </a:r>
-          </a:p>
-        </p:txBody>
-      </p:sp>
-      <p:sp>
-        <p:nvSpPr>
-          <p:cNvPr id="5" name="TextBox 4"/>
-          <p:cNvSpPr txBox="1"/>
-          <p:nvPr/>
-        </p:nvSpPr>
-        <p:spPr>
-          <a:xfrm>
-            <a:off x="438912" y="201168"/>
-            <a:ext cx="8321040" cy="292608"/>
-          </a:xfrm>
-          <a:prstGeom prst="rect">
-            <a:avLst/>
-          </a:prstGeom>
-          <a:noFill/>
-        </p:spPr>
-        <p:txBody>
-          <a:bodyPr wrap="square"/>
-          <a:lstStyle/>
-          <a:p>
-            <a:pPr algn="l">
+              <a:t>QUESTION 4  ·  THE MAKEOVER (BEFORE &amp; AFTER)</a:t>
+            </a:r>
+          </a:p>
+          <a:p>
+            <a:pPr>
+              <a:spcBef>
+                <a:spcPts val="0"/>
+              </a:spcBef>
+              <a:spcAft>
+                <a:spcPts val="300"/>
+              </a:spcAft>
+            </a:pPr>
+            <a:r>
+              <a:rPr sz="2100" b="1" i="0">
+                <a:solidFill>
+                  <a:srgbClr val="0F172A"/>
+                </a:solidFill>
+                <a:latin typeface="Georgia"/>
+              </a:rPr>
+              <a:t>From Uninformative Overplotting to Conditional Means</a:t>
+            </a:r>
+          </a:p>
+          <a:p>
+            <a:pPr>
               <a:spcBef>
                 <a:spcPts val="0"/>
               </a:spcBef>
@@ -4973,100 +5095,20 @@
               </a:spcAft>
             </a:pPr>
             <a:r>
-              <a:rPr sz="1100" b="1">
-                <a:solidFill>
-                  <a:srgbClr val="8E2F28"/>
+              <a:rPr sz="1150" b="0" i="0">
+                <a:solidFill>
+                  <a:srgbClr val="64748B"/>
                 </a:solidFill>
                 <a:latin typeface="Calibri"/>
               </a:rPr>
-              <a:t>ONE FINDING</a:t>
-            </a:r>
-          </a:p>
-        </p:txBody>
-      </p:sp>
-      <p:sp>
-        <p:nvSpPr>
-          <p:cNvPr id="6" name="TextBox 5"/>
-          <p:cNvSpPr txBox="1"/>
-          <p:nvPr/>
-        </p:nvSpPr>
-        <p:spPr>
-          <a:xfrm>
-            <a:off x="411480" y="438912"/>
-            <a:ext cx="8412480" cy="658368"/>
-          </a:xfrm>
-          <a:prstGeom prst="rect">
-            <a:avLst/>
-          </a:prstGeom>
-          <a:noFill/>
-        </p:spPr>
-        <p:txBody>
-          <a:bodyPr wrap="square"/>
-          <a:lstStyle/>
-          <a:p>
-            <a:pPr algn="l">
-              <a:spcBef>
-                <a:spcPts val="0"/>
-              </a:spcBef>
-              <a:spcAft>
-                <a:spcPts val="0"/>
-              </a:spcAft>
-            </a:pPr>
-            <a:r>
-              <a:rPr sz="2600" b="1">
-                <a:solidFill>
-                  <a:srgbClr val="2A241F"/>
-                </a:solidFill>
-                <a:latin typeface="Georgia"/>
-              </a:rPr>
-              <a:t>The gender gap is widest at ages 40-44</a:t>
-            </a:r>
-          </a:p>
-        </p:txBody>
-      </p:sp>
-      <p:sp>
-        <p:nvSpPr>
-          <p:cNvPr id="7" name="TextBox 6"/>
-          <p:cNvSpPr txBox="1"/>
-          <p:nvPr/>
-        </p:nvSpPr>
-        <p:spPr>
-          <a:xfrm>
-            <a:off x="411480" y="1042415"/>
-            <a:ext cx="8412480" cy="329184"/>
-          </a:xfrm>
-          <a:prstGeom prst="rect">
-            <a:avLst/>
-          </a:prstGeom>
-          <a:noFill/>
-        </p:spPr>
-        <p:txBody>
-          <a:bodyPr wrap="square"/>
-          <a:lstStyle/>
-          <a:p>
-            <a:pPr algn="l">
-              <a:spcBef>
-                <a:spcPts val="0"/>
-              </a:spcBef>
-              <a:spcAft>
-                <a:spcPts val="0"/>
-              </a:spcAft>
-            </a:pPr>
-            <a:r>
-              <a:rPr sz="1300" b="0">
-                <a:solidFill>
-                  <a:srgbClr val="5E564C"/>
-                </a:solidFill>
-                <a:latin typeface="Calibri"/>
-              </a:rPr>
-              <a:t>Weighted literacy rates, KP urban, ages 10-64. Men in steel blue; women in ochre, as on the figure.</a:t>
+              <a:t>Demonstrating core data visualization principles: identical sample (N = 2,357), radically different insight.</a:t>
             </a:r>
           </a:p>
         </p:txBody>
       </p:sp>
       <p:pic>
         <p:nvPicPr>
-          <p:cNvPr id="8" name="Picture 7" descr="_literacy_slide.png"/>
+          <p:cNvPr id="4" name="Picture 3" descr="_default_slide.png"/>
           <p:cNvPicPr>
             <a:picLocks noChangeAspect="1"/>
           </p:cNvPicPr>
@@ -5086,34 +5128,134 @@
         </p:blipFill>
         <p:spPr>
           <a:xfrm>
-            <a:off x="320040" y="1389888"/>
-            <a:ext cx="5074920" cy="3283772"/>
+            <a:off x="457200" y="1444752"/>
+            <a:ext cx="4005072" cy="2860766"/>
           </a:xfrm>
           <a:prstGeom prst="rect">
             <a:avLst/>
           </a:prstGeom>
         </p:spPr>
       </p:pic>
-      <p:sp>
-        <p:nvSpPr>
-          <p:cNvPr id="9" name="Rectangle 8"/>
+      <p:pic>
+        <p:nvPicPr>
+          <p:cNvPr id="5" name="Picture 4" descr="_literacy_slide.png"/>
+          <p:cNvPicPr>
+            <a:picLocks noChangeAspect="1"/>
+          </p:cNvPicPr>
+          <p:nvPr/>
+        </p:nvPicPr>
+        <p:blipFill>
+          <a:blip r:embed="rId4">
+            <a:extLst>
+              <a:ext uri="{96DAC541-7B7A-43D3-8B79-37D633B846F1}">
+                <ns1:svgBlip xmlns:ns1="http://schemas.microsoft.com/office/drawing/2016/SVG/main" r:embed="rId5"/>
+              </a:ext>
+            </a:extLst>
+          </a:blip>
+          <a:stretch>
+            <a:fillRect/>
+          </a:stretch>
+        </p:blipFill>
+        <p:spPr>
+          <a:xfrm>
+            <a:off x="4681728" y="1444752"/>
+            <a:ext cx="4005072" cy="2591517"/>
+          </a:xfrm>
+          <a:prstGeom prst="rect">
+            <a:avLst/>
+          </a:prstGeom>
+        </p:spPr>
+      </p:pic>
+      <p:sp>
+        <p:nvSpPr>
+          <p:cNvPr id="6" name="TextBox 5"/>
+          <p:cNvSpPr txBox="1"/>
+          <p:nvPr/>
+        </p:nvSpPr>
+        <p:spPr>
+          <a:xfrm>
+            <a:off x="457200" y="4389120"/>
+            <a:ext cx="4005072" cy="219456"/>
+          </a:xfrm>
+          <a:prstGeom prst="rect">
+            <a:avLst/>
+          </a:prstGeom>
+          <a:noFill/>
+        </p:spPr>
+        <p:txBody>
+          <a:bodyPr wrap="none" lIns="0" rIns="0" tIns="0" bIns="0">
+            <a:spAutoFit/>
+          </a:bodyPr>
+          <a:lstStyle/>
+          <a:p>
+            <a:pPr algn="ctr"/>
+            <a:r>
+              <a:rPr sz="950" b="1" i="0">
+                <a:solidFill>
+                  <a:srgbClr val="64748B"/>
+                </a:solidFill>
+                <a:latin typeface="Calibri"/>
+              </a:rPr>
+              <a:t>DEFAULT: R ggplot2 raw scatter (severely overplotted 0/1 points)</a:t>
+            </a:r>
+          </a:p>
+        </p:txBody>
+      </p:sp>
+      <p:sp>
+        <p:nvSpPr>
+          <p:cNvPr id="7" name="TextBox 6"/>
+          <p:cNvSpPr txBox="1"/>
+          <p:nvPr/>
+        </p:nvSpPr>
+        <p:spPr>
+          <a:xfrm>
+            <a:off x="4681728" y="4389120"/>
+            <a:ext cx="4005072" cy="219456"/>
+          </a:xfrm>
+          <a:prstGeom prst="rect">
+            <a:avLst/>
+          </a:prstGeom>
+          <a:noFill/>
+        </p:spPr>
+        <p:txBody>
+          <a:bodyPr wrap="none" lIns="0" rIns="0" tIns="0" bIns="0">
+            <a:spAutoFit/>
+          </a:bodyPr>
+          <a:lstStyle/>
+          <a:p>
+            <a:pPr algn="ctr"/>
+            <a:r>
+              <a:rPr sz="950" b="1" i="0">
+                <a:solidFill>
+                  <a:srgbClr val="1E3A8A"/>
+                </a:solidFill>
+                <a:latin typeface="Calibri"/>
+              </a:rPr>
+              <a:t>REDESIGN: Weighted conditional means by 5-year age band and sex</a:t>
+            </a:r>
+          </a:p>
+        </p:txBody>
+      </p:sp>
+      <p:sp>
+        <p:nvSpPr>
+          <p:cNvPr id="8" name="Rectangle 7"/>
           <p:cNvSpPr/>
           <p:nvPr/>
         </p:nvSpPr>
         <p:spPr>
           <a:xfrm>
-            <a:off x="5577840" y="1444752"/>
-            <a:ext cx="1600200" cy="1234440"/>
+            <a:off x="457200" y="4663440"/>
+            <a:ext cx="2633472" cy="1719072"/>
           </a:xfrm>
           <a:prstGeom prst="rect">
             <a:avLst/>
           </a:prstGeom>
           <a:solidFill>
-            <a:srgbClr val="FBF7F0"/>
+            <a:srgbClr val="F8FAFC"/>
           </a:solidFill>
           <a:ln w="9525">
             <a:solidFill>
-              <a:srgbClr val="D4C8B4"/>
+              <a:srgbClr val="E2E8F0"/>
             </a:solidFill>
           </a:ln>
           <a:effectLst/>
@@ -5142,14 +5284,58 @@
       </p:sp>
       <p:sp>
         <p:nvSpPr>
+          <p:cNvPr id="9" name="Rectangle 8"/>
+          <p:cNvSpPr/>
+          <p:nvPr/>
+        </p:nvSpPr>
+        <p:spPr>
+          <a:xfrm>
+            <a:off x="457200" y="4663440"/>
+            <a:ext cx="2633472" cy="36576"/>
+          </a:xfrm>
+          <a:prstGeom prst="rect">
+            <a:avLst/>
+          </a:prstGeom>
+          <a:solidFill>
+            <a:srgbClr val="B91C1C"/>
+          </a:solidFill>
+          <a:ln>
+            <a:noFill/>
+          </a:ln>
+          <a:effectLst/>
+        </p:spPr>
+        <p:style>
+          <a:lnRef idx="1">
+            <a:schemeClr val="accent1"/>
+          </a:lnRef>
+          <a:fillRef idx="3">
+            <a:schemeClr val="accent1"/>
+          </a:fillRef>
+          <a:effectRef idx="2">
+            <a:schemeClr val="accent1"/>
+          </a:effectRef>
+          <a:fontRef idx="minor">
+            <a:schemeClr val="lt1"/>
+          </a:fontRef>
+        </p:style>
+        <p:txBody>
+          <a:bodyPr rtlCol="0" anchor="ctr"/>
+          <a:lstStyle/>
+          <a:p>
+            <a:pPr algn="ctr"/>
+          </a:p>
+        </p:txBody>
+      </p:sp>
+      <p:sp>
+        <p:nvSpPr>
           <p:cNvPr id="10" name="TextBox 9"/>
           <p:cNvSpPr txBox="1"/>
           <p:nvPr/>
         </p:nvSpPr>
         <p:spPr>
           <a:xfrm>
-            <a:off x="5687568" y="1554480"/>
-            <a:ext cx="1380744" cy="566928"/>
+            <a:off x="585216" y="4773168"/>
+            <a:ext cx="2377440" cy="1536192"/>
           </a:xfrm>
           <a:prstGeom prst="rect">
             <a:avLst/>
@@ -5157,10 +5343,612 @@
           <a:noFill/>
         </p:spPr>
         <p:txBody>
-          <a:bodyPr wrap="square"/>
-          <a:lstStyle/>
-          <a:p>
-            <a:pPr algn="ctr">
+          <a:bodyPr wrap="square" lIns="0" rIns="0" tIns="0" bIns="0"/>
+          <a:lstStyle/>
+          <a:p>
+            <a:r>
+              <a:rPr sz="900" b="1" i="0">
+                <a:solidFill>
+                  <a:srgbClr val="B91C1C"/>
+                </a:solidFill>
+                <a:latin typeface="Calibri"/>
+              </a:rPr>
+              <a:t>1. CONDITIONAL MEANS</a:t>
+            </a:r>
+          </a:p>
+          <a:p>
+            <a:pPr>
+              <a:spcBef>
+                <a:spcPts val="200"/>
+              </a:spcBef>
+              <a:spcAft>
+                <a:spcPts val="400"/>
+              </a:spcAft>
+            </a:pPr>
+            <a:r>
+              <a:rPr sz="1250" b="1" i="0">
+                <a:solidFill>
+                  <a:srgbClr val="0F172A"/>
+                </a:solidFill>
+                <a:latin typeface="Georgia"/>
+              </a:rPr>
+              <a:t>Overcoming Overplotting</a:t>
+            </a:r>
+          </a:p>
+          <a:p>
+            <a:pPr>
+              <a:spcBef>
+                <a:spcPts val="200"/>
+              </a:spcBef>
+            </a:pPr>
+            <a:r>
+              <a:rPr sz="980" b="0" i="0">
+                <a:solidFill>
+                  <a:srgbClr val="334155"/>
+                </a:solidFill>
+                <a:latin typeface="Calibri"/>
+              </a:rPr>
+              <a:t>The default plots 2,357 overlapping dots at 0 and 1, completely hiding density and age patterns. Grouping by 5-year bands and taking weighted conditional means reveals the true cohort trajectory.</a:t>
+            </a:r>
+          </a:p>
+        </p:txBody>
+      </p:sp>
+      <p:sp>
+        <p:nvSpPr>
+          <p:cNvPr id="11" name="Rectangle 10"/>
+          <p:cNvSpPr/>
+          <p:nvPr/>
+        </p:nvSpPr>
+        <p:spPr>
+          <a:xfrm>
+            <a:off x="3255264" y="4663440"/>
+            <a:ext cx="2633472" cy="1719072"/>
+          </a:xfrm>
+          <a:prstGeom prst="rect">
+            <a:avLst/>
+          </a:prstGeom>
+          <a:solidFill>
+            <a:srgbClr val="F8FAFC"/>
+          </a:solidFill>
+          <a:ln w="9525">
+            <a:solidFill>
+              <a:srgbClr val="E2E8F0"/>
+            </a:solidFill>
+          </a:ln>
+          <a:effectLst/>
+        </p:spPr>
+        <p:style>
+          <a:lnRef idx="1">
+            <a:schemeClr val="accent1"/>
+          </a:lnRef>
+          <a:fillRef idx="3">
+            <a:schemeClr val="accent1"/>
+          </a:fillRef>
+          <a:effectRef idx="2">
+            <a:schemeClr val="accent1"/>
+          </a:effectRef>
+          <a:fontRef idx="minor">
+            <a:schemeClr val="lt1"/>
+          </a:fontRef>
+        </p:style>
+        <p:txBody>
+          <a:bodyPr rtlCol="0" anchor="ctr"/>
+          <a:lstStyle/>
+          <a:p>
+            <a:pPr algn="ctr"/>
+          </a:p>
+        </p:txBody>
+      </p:sp>
+      <p:sp>
+        <p:nvSpPr>
+          <p:cNvPr id="12" name="Rectangle 11"/>
+          <p:cNvSpPr/>
+          <p:nvPr/>
+        </p:nvSpPr>
+        <p:spPr>
+          <a:xfrm>
+            <a:off x="3255264" y="4663440"/>
+            <a:ext cx="2633472" cy="36576"/>
+          </a:xfrm>
+          <a:prstGeom prst="rect">
+            <a:avLst/>
+          </a:prstGeom>
+          <a:solidFill>
+            <a:srgbClr val="2C7FB8"/>
+          </a:solidFill>
+          <a:ln>
+            <a:noFill/>
+          </a:ln>
+          <a:effectLst/>
+        </p:spPr>
+        <p:style>
+          <a:lnRef idx="1">
+            <a:schemeClr val="accent1"/>
+          </a:lnRef>
+          <a:fillRef idx="3">
+            <a:schemeClr val="accent1"/>
+          </a:fillRef>
+          <a:effectRef idx="2">
+            <a:schemeClr val="accent1"/>
+          </a:effectRef>
+          <a:fontRef idx="minor">
+            <a:schemeClr val="lt1"/>
+          </a:fontRef>
+        </p:style>
+        <p:txBody>
+          <a:bodyPr rtlCol="0" anchor="ctr"/>
+          <a:lstStyle/>
+          <a:p>
+            <a:pPr algn="ctr"/>
+          </a:p>
+        </p:txBody>
+      </p:sp>
+      <p:sp>
+        <p:nvSpPr>
+          <p:cNvPr id="13" name="TextBox 12"/>
+          <p:cNvSpPr txBox="1"/>
+          <p:nvPr/>
+        </p:nvSpPr>
+        <p:spPr>
+          <a:xfrm>
+            <a:off x="3383280" y="4773168"/>
+            <a:ext cx="2377440" cy="1536192"/>
+          </a:xfrm>
+          <a:prstGeom prst="rect">
+            <a:avLst/>
+          </a:prstGeom>
+          <a:noFill/>
+        </p:spPr>
+        <p:txBody>
+          <a:bodyPr wrap="square" lIns="0" rIns="0" tIns="0" bIns="0"/>
+          <a:lstStyle/>
+          <a:p>
+            <a:r>
+              <a:rPr sz="900" b="1" i="0">
+                <a:solidFill>
+                  <a:srgbClr val="2C7FB8"/>
+                </a:solidFill>
+                <a:latin typeface="Calibri"/>
+              </a:rPr>
+              <a:t>2. CHANNEL RANKING</a:t>
+            </a:r>
+          </a:p>
+          <a:p>
+            <a:pPr>
+              <a:spcBef>
+                <a:spcPts val="200"/>
+              </a:spcBef>
+              <a:spcAft>
+                <a:spcPts val="400"/>
+              </a:spcAft>
+            </a:pPr>
+            <a:r>
+              <a:rPr sz="1250" b="1" i="0">
+                <a:solidFill>
+                  <a:srgbClr val="0F172A"/>
+                </a:solidFill>
+                <a:latin typeface="Georgia"/>
+              </a:rPr>
+              <a:t>Position Over Color</a:t>
+            </a:r>
+          </a:p>
+          <a:p>
+            <a:pPr>
+              <a:spcBef>
+                <a:spcPts val="200"/>
+              </a:spcBef>
+            </a:pPr>
+            <a:r>
+              <a:rPr sz="980" b="0" i="0">
+                <a:solidFill>
+                  <a:srgbClr val="334155"/>
+                </a:solidFill>
+                <a:latin typeface="Calibri"/>
+              </a:rPr>
+              <a:t>Position on a common scale—the highest-ranked visual channel—is dedicated to the continuous variables: age and literacy rate. Color is reserved strictly for the categorical split by sex.</a:t>
+            </a:r>
+          </a:p>
+        </p:txBody>
+      </p:sp>
+      <p:sp>
+        <p:nvSpPr>
+          <p:cNvPr id="14" name="Rectangle 13"/>
+          <p:cNvSpPr/>
+          <p:nvPr/>
+        </p:nvSpPr>
+        <p:spPr>
+          <a:xfrm>
+            <a:off x="6053328" y="4663440"/>
+            <a:ext cx="2633472" cy="1719072"/>
+          </a:xfrm>
+          <a:prstGeom prst="rect">
+            <a:avLst/>
+          </a:prstGeom>
+          <a:solidFill>
+            <a:srgbClr val="F8FAFC"/>
+          </a:solidFill>
+          <a:ln w="9525">
+            <a:solidFill>
+              <a:srgbClr val="E2E8F0"/>
+            </a:solidFill>
+          </a:ln>
+          <a:effectLst/>
+        </p:spPr>
+        <p:style>
+          <a:lnRef idx="1">
+            <a:schemeClr val="accent1"/>
+          </a:lnRef>
+          <a:fillRef idx="3">
+            <a:schemeClr val="accent1"/>
+          </a:fillRef>
+          <a:effectRef idx="2">
+            <a:schemeClr val="accent1"/>
+          </a:effectRef>
+          <a:fontRef idx="minor">
+            <a:schemeClr val="lt1"/>
+          </a:fontRef>
+        </p:style>
+        <p:txBody>
+          <a:bodyPr rtlCol="0" anchor="ctr"/>
+          <a:lstStyle/>
+          <a:p>
+            <a:pPr algn="ctr"/>
+          </a:p>
+        </p:txBody>
+      </p:sp>
+      <p:sp>
+        <p:nvSpPr>
+          <p:cNvPr id="15" name="Rectangle 14"/>
+          <p:cNvSpPr/>
+          <p:nvPr/>
+        </p:nvSpPr>
+        <p:spPr>
+          <a:xfrm>
+            <a:off x="6053328" y="4663440"/>
+            <a:ext cx="2633472" cy="36576"/>
+          </a:xfrm>
+          <a:prstGeom prst="rect">
+            <a:avLst/>
+          </a:prstGeom>
+          <a:solidFill>
+            <a:srgbClr val="0D9488"/>
+          </a:solidFill>
+          <a:ln>
+            <a:noFill/>
+          </a:ln>
+          <a:effectLst/>
+        </p:spPr>
+        <p:style>
+          <a:lnRef idx="1">
+            <a:schemeClr val="accent1"/>
+          </a:lnRef>
+          <a:fillRef idx="3">
+            <a:schemeClr val="accent1"/>
+          </a:fillRef>
+          <a:effectRef idx="2">
+            <a:schemeClr val="accent1"/>
+          </a:effectRef>
+          <a:fontRef idx="minor">
+            <a:schemeClr val="lt1"/>
+          </a:fontRef>
+        </p:style>
+        <p:txBody>
+          <a:bodyPr rtlCol="0" anchor="ctr"/>
+          <a:lstStyle/>
+          <a:p>
+            <a:pPr algn="ctr"/>
+          </a:p>
+        </p:txBody>
+      </p:sp>
+      <p:sp>
+        <p:nvSpPr>
+          <p:cNvPr id="16" name="TextBox 15"/>
+          <p:cNvSpPr txBox="1"/>
+          <p:nvPr/>
+        </p:nvSpPr>
+        <p:spPr>
+          <a:xfrm>
+            <a:off x="6181344" y="4773168"/>
+            <a:ext cx="2377440" cy="1536192"/>
+          </a:xfrm>
+          <a:prstGeom prst="rect">
+            <a:avLst/>
+          </a:prstGeom>
+          <a:noFill/>
+        </p:spPr>
+        <p:txBody>
+          <a:bodyPr wrap="square" lIns="0" rIns="0" tIns="0" bIns="0"/>
+          <a:lstStyle/>
+          <a:p>
+            <a:r>
+              <a:rPr sz="900" b="1" i="0">
+                <a:solidFill>
+                  <a:srgbClr val="0D9488"/>
+                </a:solidFill>
+                <a:latin typeface="Calibri"/>
+              </a:rPr>
+              <a:t>3. DATA-INK &amp; TRADEOFF</a:t>
+            </a:r>
+          </a:p>
+          <a:p>
+            <a:pPr>
+              <a:spcBef>
+                <a:spcPts val="200"/>
+              </a:spcBef>
+              <a:spcAft>
+                <a:spcPts val="400"/>
+              </a:spcAft>
+            </a:pPr>
+            <a:r>
+              <a:rPr sz="1250" b="1" i="0">
+                <a:solidFill>
+                  <a:srgbClr val="0F172A"/>
+                </a:solidFill>
+                <a:latin typeface="Georgia"/>
+              </a:rPr>
+              <a:t>Direct Labels &amp; Hidden Spread</a:t>
+            </a:r>
+          </a:p>
+          <a:p>
+            <a:pPr>
+              <a:spcBef>
+                <a:spcPts val="200"/>
+              </a:spcBef>
+            </a:pPr>
+            <a:r>
+              <a:rPr sz="980" b="0" i="0">
+                <a:solidFill>
+                  <a:srgbClr val="334155"/>
+                </a:solidFill>
+                <a:latin typeface="Calibri"/>
+              </a:rPr>
+              <a:t>Direct end-labels eliminate legend clutter. Trade-off: the default figure shows individual 0/1 spread and sample density, which the redesign hides by aggregating into summary points.</a:t>
+            </a:r>
+          </a:p>
+        </p:txBody>
+      </p:sp>
+      <p:sp>
+        <p:nvSpPr>
+          <p:cNvPr id="17" name="Rectangle 16"/>
+          <p:cNvSpPr/>
+          <p:nvPr/>
+        </p:nvSpPr>
+        <p:spPr>
+          <a:xfrm>
+            <a:off x="457200" y="6473952"/>
+            <a:ext cx="8229600" cy="9144"/>
+          </a:xfrm>
+          <a:prstGeom prst="rect">
+            <a:avLst/>
+          </a:prstGeom>
+          <a:solidFill>
+            <a:srgbClr val="CBD5E1"/>
+          </a:solidFill>
+          <a:ln>
+            <a:noFill/>
+          </a:ln>
+          <a:effectLst/>
+        </p:spPr>
+        <p:style>
+          <a:lnRef idx="1">
+            <a:schemeClr val="accent1"/>
+          </a:lnRef>
+          <a:fillRef idx="3">
+            <a:schemeClr val="accent1"/>
+          </a:fillRef>
+          <a:effectRef idx="2">
+            <a:schemeClr val="accent1"/>
+          </a:effectRef>
+          <a:fontRef idx="minor">
+            <a:schemeClr val="lt1"/>
+          </a:fontRef>
+        </p:style>
+        <p:txBody>
+          <a:bodyPr rtlCol="0" anchor="ctr"/>
+          <a:lstStyle/>
+          <a:p>
+            <a:pPr algn="ctr"/>
+          </a:p>
+        </p:txBody>
+      </p:sp>
+      <p:sp>
+        <p:nvSpPr>
+          <p:cNvPr id="18" name="TextBox 17"/>
+          <p:cNvSpPr txBox="1"/>
+          <p:nvPr/>
+        </p:nvSpPr>
+        <p:spPr>
+          <a:xfrm>
+            <a:off x="457200" y="6528816"/>
+            <a:ext cx="6400800" cy="228600"/>
+          </a:xfrm>
+          <a:prstGeom prst="rect">
+            <a:avLst/>
+          </a:prstGeom>
+          <a:noFill/>
+        </p:spPr>
+        <p:txBody>
+          <a:bodyPr wrap="none" lIns="0" rIns="0" tIns="0" bIns="0">
+            <a:spAutoFit/>
+          </a:bodyPr>
+          <a:lstStyle/>
+          <a:p>
+            <a:r>
+              <a:rPr sz="950" b="0" i="0">
+                <a:solidFill>
+                  <a:srgbClr val="64748B"/>
+                </a:solidFill>
+                <a:latin typeface="Calibri"/>
+              </a:rPr>
+              <a:t>ECO346 Data Visualization · FA24-BEDS-105 · Variant 5 (KP Urban) · PSLM 2019–20</a:t>
+            </a:r>
+          </a:p>
+        </p:txBody>
+      </p:sp>
+      <p:sp>
+        <p:nvSpPr>
+          <p:cNvPr id="19" name="TextBox 18"/>
+          <p:cNvSpPr txBox="1"/>
+          <p:nvPr/>
+        </p:nvSpPr>
+        <p:spPr>
+          <a:xfrm>
+            <a:off x="6949440" y="6528816"/>
+            <a:ext cx="1737360" cy="228600"/>
+          </a:xfrm>
+          <a:prstGeom prst="rect">
+            <a:avLst/>
+          </a:prstGeom>
+          <a:noFill/>
+        </p:spPr>
+        <p:txBody>
+          <a:bodyPr wrap="none" lIns="0" rIns="0" tIns="0" bIns="0">
+            <a:spAutoFit/>
+          </a:bodyPr>
+          <a:lstStyle/>
+          <a:p>
+            <a:pPr algn="r"/>
+            <a:r>
+              <a:rPr sz="950" b="0" i="0">
+                <a:solidFill>
+                  <a:srgbClr val="64748B"/>
+                </a:solidFill>
+                <a:latin typeface="Calibri"/>
+              </a:rPr>
+              <a:t>Slide 3 of 4</a:t>
+            </a:r>
+          </a:p>
+        </p:txBody>
+      </p:sp>
+    </p:spTree>
+  </p:cSld>
+  <p:clrMapOvr>
+    <a:masterClrMapping/>
+  </p:clrMapOvr>
+</p:sld>
+</file>
+
+<file path=ppt/slides/slide4.xml><?xml version="1.0" encoding="utf-8"?>
+<p:sld xmlns:a="http://schemas.openxmlformats.org/drawingml/2006/main" xmlns:p="http://schemas.openxmlformats.org/presentationml/2006/main" xmlns:r="http://schemas.openxmlformats.org/officeDocument/2006/relationships">
+  <p:cSld>
+    <p:bg>
+      <p:bgPr>
+        <a:solidFill>
+          <a:srgbClr val="FFFFFF"/>
+        </a:solidFill>
+        <a:effectLst/>
+      </p:bgPr>
+    </p:bg>
+    <p:spTree>
+      <p:nvGrpSpPr>
+        <p:cNvPr id="1" name=""/>
+        <p:cNvGrpSpPr/>
+        <p:nvPr/>
+      </p:nvGrpSpPr>
+      <p:grpSpPr/>
+      <p:sp>
+        <p:nvSpPr>
+          <p:cNvPr id="2" name="Rectangle 1"/>
+          <p:cNvSpPr/>
+          <p:nvPr/>
+        </p:nvSpPr>
+        <p:spPr>
+          <a:xfrm>
+            <a:off x="457200" y="310896"/>
+            <a:ext cx="365760" cy="36576"/>
+          </a:xfrm>
+          <a:prstGeom prst="rect">
+            <a:avLst/>
+          </a:prstGeom>
+          <a:solidFill>
+            <a:srgbClr val="1E3A8A"/>
+          </a:solidFill>
+          <a:ln>
+            <a:noFill/>
+          </a:ln>
+          <a:effectLst/>
+        </p:spPr>
+        <p:style>
+          <a:lnRef idx="1">
+            <a:schemeClr val="accent1"/>
+          </a:lnRef>
+          <a:fillRef idx="3">
+            <a:schemeClr val="accent1"/>
+          </a:fillRef>
+          <a:effectRef idx="2">
+            <a:schemeClr val="accent1"/>
+          </a:effectRef>
+          <a:fontRef idx="minor">
+            <a:schemeClr val="lt1"/>
+          </a:fontRef>
+        </p:style>
+        <p:txBody>
+          <a:bodyPr rtlCol="0" anchor="ctr"/>
+          <a:lstStyle/>
+          <a:p>
+            <a:pPr algn="ctr"/>
+          </a:p>
+        </p:txBody>
+      </p:sp>
+      <p:sp>
+        <p:nvSpPr>
+          <p:cNvPr id="3" name="TextBox 2"/>
+          <p:cNvSpPr txBox="1"/>
+          <p:nvPr/>
+        </p:nvSpPr>
+        <p:spPr>
+          <a:xfrm>
+            <a:off x="457200" y="384048"/>
+            <a:ext cx="8229600" cy="960120"/>
+          </a:xfrm>
+          <a:prstGeom prst="rect">
+            <a:avLst/>
+          </a:prstGeom>
+          <a:noFill/>
+        </p:spPr>
+        <p:txBody>
+          <a:bodyPr wrap="square" lIns="0" rIns="0" tIns="0" bIns="0"/>
+          <a:lstStyle/>
+          <a:p>
+            <a:pPr>
+              <a:spcBef>
+                <a:spcPts val="0"/>
+              </a:spcBef>
+              <a:spcAft>
+                <a:spcPts val="200"/>
+              </a:spcAft>
+            </a:pPr>
+            <a:r>
+              <a:rPr sz="950" b="1" i="0">
+                <a:solidFill>
+                  <a:srgbClr val="1E3A8A"/>
+                </a:solidFill>
+                <a:latin typeface="Calibri"/>
+              </a:rPr>
+              <a:t>QUESTION 3 &amp; 6  ·  PRIMARY DEMOGRAPHIC FINDING</a:t>
+            </a:r>
+          </a:p>
+          <a:p>
+            <a:pPr>
+              <a:spcBef>
+                <a:spcPts val="0"/>
+              </a:spcBef>
+              <a:spcAft>
+                <a:spcPts val="300"/>
+              </a:spcAft>
+            </a:pPr>
+            <a:r>
+              <a:rPr sz="2100" b="1" i="0">
+                <a:solidFill>
+                  <a:srgbClr val="0F172A"/>
+                </a:solidFill>
+                <a:latin typeface="Georgia"/>
+              </a:rPr>
+              <a:t>Widest Gender Literacy Gap at Ages 40–44 (47.4 Points)</a:t>
+            </a:r>
+          </a:p>
+          <a:p>
+            <a:pPr>
               <a:spcBef>
                 <a:spcPts val="0"/>
               </a:spcBef>
@@ -5169,77 +5957,67 @@
               </a:spcAft>
             </a:pPr>
             <a:r>
-              <a:rPr sz="2600" b="1">
-                <a:solidFill>
-                  <a:srgbClr val="D95F02"/>
-                </a:solidFill>
-                <a:latin typeface="Georgia"/>
-              </a:rPr>
-              <a:t>68.1%</a:t>
-            </a:r>
-          </a:p>
-        </p:txBody>
-      </p:sp>
-      <p:sp>
-        <p:nvSpPr>
-          <p:cNvPr id="11" name="TextBox 10"/>
-          <p:cNvSpPr txBox="1"/>
-          <p:nvPr/>
-        </p:nvSpPr>
-        <p:spPr>
-          <a:xfrm>
-            <a:off x="5687568" y="2121408"/>
-            <a:ext cx="1380744" cy="457200"/>
-          </a:xfrm>
-          <a:prstGeom prst="rect">
-            <a:avLst/>
-          </a:prstGeom>
-          <a:noFill/>
-        </p:spPr>
-        <p:txBody>
-          <a:bodyPr wrap="square"/>
-          <a:lstStyle/>
-          <a:p>
-            <a:pPr algn="ctr">
-              <a:spcBef>
-                <a:spcPts val="0"/>
-              </a:spcBef>
-              <a:spcAft>
-                <a:spcPts val="0"/>
-              </a:spcAft>
-            </a:pPr>
-            <a:r>
-              <a:rPr sz="1200" b="0">
-                <a:solidFill>
-                  <a:srgbClr val="5E564C"/>
+              <a:rPr sz="1150" b="0" i="0">
+                <a:solidFill>
+                  <a:srgbClr val="64748B"/>
                 </a:solidFill>
                 <a:latin typeface="Calibri"/>
               </a:rPr>
-              <a:t>Women 15-19</a:t>
-            </a:r>
-          </a:p>
-        </p:txBody>
-      </p:sp>
-      <p:sp>
-        <p:nvSpPr>
-          <p:cNvPr id="12" name="Rectangle 11"/>
+              <a:t>Weighted literacy rates by age band and sex in urban Khyber Pakhtunkhwa (PSLM 2019–20).</a:t>
+            </a:r>
+          </a:p>
+        </p:txBody>
+      </p:sp>
+      <p:pic>
+        <p:nvPicPr>
+          <p:cNvPr id="4" name="Picture 3" descr="_literacy_slide.png"/>
+          <p:cNvPicPr>
+            <a:picLocks noChangeAspect="1"/>
+          </p:cNvPicPr>
+          <p:nvPr/>
+        </p:nvPicPr>
+        <p:blipFill>
+          <a:blip r:embed="rId2">
+            <a:extLst>
+              <a:ext uri="{96DAC541-7B7A-43D3-8B79-37D633B846F1}">
+                <ns0:svgBlip xmlns:ns0="http://schemas.microsoft.com/office/drawing/2016/SVG/main" r:embed="rId3"/>
+              </a:ext>
+            </a:extLst>
+          </a:blip>
+          <a:stretch>
+            <a:fillRect/>
+          </a:stretch>
+        </p:blipFill>
+        <p:spPr>
+          <a:xfrm>
+            <a:off x="457200" y="1444752"/>
+            <a:ext cx="4846320" cy="3135854"/>
+          </a:xfrm>
+          <a:prstGeom prst="rect">
+            <a:avLst/>
+          </a:prstGeom>
+        </p:spPr>
+      </p:pic>
+      <p:sp>
+        <p:nvSpPr>
+          <p:cNvPr id="5" name="Rectangle 4"/>
           <p:cNvSpPr/>
           <p:nvPr/>
         </p:nvSpPr>
         <p:spPr>
           <a:xfrm>
-            <a:off x="7315200" y="1444752"/>
-            <a:ext cx="1600200" cy="1234440"/>
+            <a:off x="5440680" y="1444752"/>
+            <a:ext cx="3246120" cy="1188720"/>
           </a:xfrm>
           <a:prstGeom prst="rect">
             <a:avLst/>
           </a:prstGeom>
           <a:solidFill>
-            <a:srgbClr val="FBF7F0"/>
+            <a:srgbClr val="F8FAFC"/>
           </a:solidFill>
           <a:ln w="9525">
             <a:solidFill>
-              <a:srgbClr val="D4C8B4"/>
+              <a:srgbClr val="E2E8F0"/>
             </a:solidFill>
           </a:ln>
           <a:effectLst/>
@@ -5268,105 +6046,23 @@
       </p:sp>
       <p:sp>
         <p:nvSpPr>
-          <p:cNvPr id="13" name="TextBox 12"/>
-          <p:cNvSpPr txBox="1"/>
-          <p:nvPr/>
-        </p:nvSpPr>
-        <p:spPr>
-          <a:xfrm>
-            <a:off x="7424928" y="1554480"/>
-            <a:ext cx="1380744" cy="566928"/>
-          </a:xfrm>
-          <a:prstGeom prst="rect">
-            <a:avLst/>
-          </a:prstGeom>
-          <a:noFill/>
-        </p:spPr>
-        <p:txBody>
-          <a:bodyPr wrap="square"/>
-          <a:lstStyle/>
-          <a:p>
-            <a:pPr algn="ctr">
-              <a:spcBef>
-                <a:spcPts val="0"/>
-              </a:spcBef>
-              <a:spcAft>
-                <a:spcPts val="0"/>
-              </a:spcAft>
-            </a:pPr>
-            <a:r>
-              <a:rPr sz="2600" b="1">
-                <a:solidFill>
-                  <a:srgbClr val="D95F02"/>
-                </a:solidFill>
-                <a:latin typeface="Georgia"/>
-              </a:rPr>
-              <a:t>16.2%</a:t>
-            </a:r>
-          </a:p>
-        </p:txBody>
-      </p:sp>
-      <p:sp>
-        <p:nvSpPr>
-          <p:cNvPr id="14" name="TextBox 13"/>
-          <p:cNvSpPr txBox="1"/>
-          <p:nvPr/>
-        </p:nvSpPr>
-        <p:spPr>
-          <a:xfrm>
-            <a:off x="7424928" y="2121408"/>
-            <a:ext cx="1380744" cy="457200"/>
-          </a:xfrm>
-          <a:prstGeom prst="rect">
-            <a:avLst/>
-          </a:prstGeom>
-          <a:noFill/>
-        </p:spPr>
-        <p:txBody>
-          <a:bodyPr wrap="square"/>
-          <a:lstStyle/>
-          <a:p>
-            <a:pPr algn="ctr">
-              <a:spcBef>
-                <a:spcPts val="0"/>
-              </a:spcBef>
-              <a:spcAft>
-                <a:spcPts val="0"/>
-              </a:spcAft>
-            </a:pPr>
-            <a:r>
-              <a:rPr sz="1200" b="0">
-                <a:solidFill>
-                  <a:srgbClr val="5E564C"/>
-                </a:solidFill>
-                <a:latin typeface="Calibri"/>
-              </a:rPr>
-              <a:t>Women 55-59</a:t>
-            </a:r>
-          </a:p>
-        </p:txBody>
-      </p:sp>
-      <p:sp>
-        <p:nvSpPr>
-          <p:cNvPr id="15" name="Rectangle 14"/>
+          <p:cNvPr id="6" name="Rectangle 5"/>
           <p:cNvSpPr/>
           <p:nvPr/>
         </p:nvSpPr>
         <p:spPr>
           <a:xfrm>
-            <a:off x="5577840" y="2816352"/>
-            <a:ext cx="1600200" cy="1234440"/>
+            <a:off x="5440680" y="1444752"/>
+            <a:ext cx="3246120" cy="36576"/>
           </a:xfrm>
           <a:prstGeom prst="rect">
             <a:avLst/>
           </a:prstGeom>
           <a:solidFill>
-            <a:srgbClr val="FBF7F0"/>
+            <a:srgbClr val="0D9488"/>
           </a:solidFill>
-          <a:ln w="9525">
-            <a:solidFill>
-              <a:srgbClr val="D4C8B4"/>
-            </a:solidFill>
+          <a:ln>
+            <a:noFill/>
           </a:ln>
           <a:effectLst/>
         </p:spPr>
@@ -5394,14 +6090,14 @@
       </p:sp>
       <p:sp>
         <p:nvSpPr>
-          <p:cNvPr id="16" name="TextBox 15"/>
+          <p:cNvPr id="7" name="TextBox 6"/>
           <p:cNvSpPr txBox="1"/>
           <p:nvPr/>
         </p:nvSpPr>
         <p:spPr>
           <a:xfrm>
-            <a:off x="5687568" y="2926080"/>
-            <a:ext cx="1380744" cy="566928"/>
+            <a:off x="5568696" y="1554480"/>
+            <a:ext cx="2990088" cy="1005840"/>
           </a:xfrm>
           <a:prstGeom prst="rect">
             <a:avLst/>
@@ -5409,39 +6105,75 @@
           <a:noFill/>
         </p:spPr>
         <p:txBody>
-          <a:bodyPr wrap="square"/>
-          <a:lstStyle/>
-          <a:p>
-            <a:pPr algn="ctr">
-              <a:spcBef>
-                <a:spcPts val="0"/>
-              </a:spcBef>
-              <a:spcAft>
-                <a:spcPts val="0"/>
-              </a:spcAft>
-            </a:pPr>
-            <a:r>
-              <a:rPr sz="2600" b="1">
+          <a:bodyPr wrap="square" lIns="0" rIns="0" tIns="0" bIns="0"/>
+          <a:lstStyle/>
+          <a:p>
+            <a:r>
+              <a:rPr sz="850" b="1" i="0">
+                <a:solidFill>
+                  <a:srgbClr val="0D9488"/>
+                </a:solidFill>
+                <a:latin typeface="Calibri"/>
+              </a:rPr>
+              <a:t>YOUTH COHORT (AGES 15–19)  ·  21.6 POINT GAP</a:t>
+            </a:r>
+          </a:p>
+        </p:txBody>
+      </p:sp>
+      <p:sp>
+        <p:nvSpPr>
+          <p:cNvPr id="8" name="TextBox 7"/>
+          <p:cNvSpPr txBox="1"/>
+          <p:nvPr/>
+        </p:nvSpPr>
+        <p:spPr>
+          <a:xfrm>
+            <a:off x="5550408" y="1682496"/>
+            <a:ext cx="1463040" cy="457200"/>
+          </a:xfrm>
+          <a:prstGeom prst="rect">
+            <a:avLst/>
+          </a:prstGeom>
+          <a:noFill/>
+        </p:spPr>
+        <p:txBody>
+          <a:bodyPr wrap="none" lIns="0" rIns="0" tIns="0" bIns="0">
+            <a:spAutoFit/>
+          </a:bodyPr>
+          <a:lstStyle/>
+          <a:p>
+            <a:r>
+              <a:rPr sz="1900" b="1" i="0">
                 <a:solidFill>
                   <a:srgbClr val="2C7FB8"/>
                 </a:solidFill>
                 <a:latin typeface="Georgia"/>
               </a:rPr>
-              <a:t>89.7%</a:t>
-            </a:r>
-          </a:p>
-        </p:txBody>
-      </p:sp>
-      <p:sp>
-        <p:nvSpPr>
-          <p:cNvPr id="17" name="TextBox 16"/>
+              <a:t>89.7%
+</a:t>
+            </a:r>
+            <a:r>
+              <a:rPr sz="900" b="0" i="0">
+                <a:solidFill>
+                  <a:srgbClr val="64748B"/>
+                </a:solidFill>
+                <a:latin typeface="Calibri"/>
+              </a:rPr>
+              <a:t>Men (n = 193)</a:t>
+            </a:r>
+          </a:p>
+        </p:txBody>
+      </p:sp>
+      <p:sp>
+        <p:nvSpPr>
+          <p:cNvPr id="9" name="TextBox 8"/>
           <p:cNvSpPr txBox="1"/>
           <p:nvPr/>
         </p:nvSpPr>
         <p:spPr>
           <a:xfrm>
-            <a:off x="5687568" y="3493008"/>
-            <a:ext cx="1380744" cy="457200"/>
+            <a:off x="7086600" y="1682496"/>
+            <a:ext cx="1463040" cy="457200"/>
           </a:xfrm>
           <a:prstGeom prst="rect">
             <a:avLst/>
@@ -5449,49 +6181,87 @@
           <a:noFill/>
         </p:spPr>
         <p:txBody>
-          <a:bodyPr wrap="square"/>
-          <a:lstStyle/>
-          <a:p>
-            <a:pPr algn="ctr">
-              <a:spcBef>
-                <a:spcPts val="0"/>
-              </a:spcBef>
-              <a:spcAft>
-                <a:spcPts val="0"/>
-              </a:spcAft>
-            </a:pPr>
-            <a:r>
-              <a:rPr sz="1200" b="0">
-                <a:solidFill>
-                  <a:srgbClr val="5E564C"/>
+          <a:bodyPr wrap="none" lIns="0" rIns="0" tIns="0" bIns="0">
+            <a:spAutoFit/>
+          </a:bodyPr>
+          <a:lstStyle/>
+          <a:p>
+            <a:r>
+              <a:rPr sz="1900" b="1" i="0">
+                <a:solidFill>
+                  <a:srgbClr val="D95F02"/>
+                </a:solidFill>
+                <a:latin typeface="Georgia"/>
+              </a:rPr>
+              <a:t>68.1%
+</a:t>
+            </a:r>
+            <a:r>
+              <a:rPr sz="900" b="0" i="0">
+                <a:solidFill>
+                  <a:srgbClr val="64748B"/>
                 </a:solidFill>
                 <a:latin typeface="Calibri"/>
               </a:rPr>
-              <a:t>Men 15-19</a:t>
-            </a:r>
-          </a:p>
-        </p:txBody>
-      </p:sp>
-      <p:sp>
-        <p:nvSpPr>
-          <p:cNvPr id="18" name="Rectangle 17"/>
+              <a:t>Women (n = 163)</a:t>
+            </a:r>
+          </a:p>
+        </p:txBody>
+      </p:sp>
+      <p:sp>
+        <p:nvSpPr>
+          <p:cNvPr id="10" name="TextBox 9"/>
+          <p:cNvSpPr txBox="1"/>
+          <p:nvPr/>
+        </p:nvSpPr>
+        <p:spPr>
+          <a:xfrm>
+            <a:off x="5550408" y="2304288"/>
+            <a:ext cx="3026664" cy="274320"/>
+          </a:xfrm>
+          <a:prstGeom prst="rect">
+            <a:avLst/>
+          </a:prstGeom>
+          <a:noFill/>
+        </p:spPr>
+        <p:txBody>
+          <a:bodyPr wrap="none" lIns="0" rIns="0" tIns="0" bIns="0">
+            <a:spAutoFit/>
+          </a:bodyPr>
+          <a:lstStyle/>
+          <a:p>
+            <a:r>
+              <a:rPr sz="900" b="0" i="0">
+                <a:solidFill>
+                  <a:srgbClr val="334155"/>
+                </a:solidFill>
+                <a:latin typeface="Calibri"/>
+              </a:rPr>
+              <a:t>Highest female literacy band in adult cohorts; gap narrows among youth.</a:t>
+            </a:r>
+          </a:p>
+        </p:txBody>
+      </p:sp>
+      <p:sp>
+        <p:nvSpPr>
+          <p:cNvPr id="11" name="Rectangle 10"/>
           <p:cNvSpPr/>
           <p:nvPr/>
         </p:nvSpPr>
         <p:spPr>
           <a:xfrm>
-            <a:off x="7315200" y="2816352"/>
-            <a:ext cx="1600200" cy="1234440"/>
+            <a:off x="5440680" y="2724912"/>
+            <a:ext cx="3246120" cy="1188720"/>
           </a:xfrm>
           <a:prstGeom prst="rect">
             <a:avLst/>
           </a:prstGeom>
           <a:solidFill>
-            <a:srgbClr val="FBF7F0"/>
+            <a:srgbClr val="F8FAFC"/>
           </a:solidFill>
           <a:ln w="9525">
             <a:solidFill>
-              <a:srgbClr val="D4C8B4"/>
+              <a:srgbClr val="E2E8F0"/>
             </a:solidFill>
           </a:ln>
           <a:effectLst/>
@@ -5520,105 +6290,23 @@
       </p:sp>
       <p:sp>
         <p:nvSpPr>
-          <p:cNvPr id="19" name="TextBox 18"/>
-          <p:cNvSpPr txBox="1"/>
-          <p:nvPr/>
-        </p:nvSpPr>
-        <p:spPr>
-          <a:xfrm>
-            <a:off x="7424928" y="2926080"/>
-            <a:ext cx="1380744" cy="566928"/>
-          </a:xfrm>
-          <a:prstGeom prst="rect">
-            <a:avLst/>
-          </a:prstGeom>
-          <a:noFill/>
-        </p:spPr>
-        <p:txBody>
-          <a:bodyPr wrap="square"/>
-          <a:lstStyle/>
-          <a:p>
-            <a:pPr algn="ctr">
-              <a:spcBef>
-                <a:spcPts val="0"/>
-              </a:spcBef>
-              <a:spcAft>
-                <a:spcPts val="0"/>
-              </a:spcAft>
-            </a:pPr>
-            <a:r>
-              <a:rPr sz="2600" b="1">
-                <a:solidFill>
-                  <a:srgbClr val="2C7FB8"/>
-                </a:solidFill>
-                <a:latin typeface="Georgia"/>
-              </a:rPr>
-              <a:t>58.8%</a:t>
-            </a:r>
-          </a:p>
-        </p:txBody>
-      </p:sp>
-      <p:sp>
-        <p:nvSpPr>
-          <p:cNvPr id="20" name="TextBox 19"/>
-          <p:cNvSpPr txBox="1"/>
-          <p:nvPr/>
-        </p:nvSpPr>
-        <p:spPr>
-          <a:xfrm>
-            <a:off x="7424928" y="3493008"/>
-            <a:ext cx="1380744" cy="457200"/>
-          </a:xfrm>
-          <a:prstGeom prst="rect">
-            <a:avLst/>
-          </a:prstGeom>
-          <a:noFill/>
-        </p:spPr>
-        <p:txBody>
-          <a:bodyPr wrap="square"/>
-          <a:lstStyle/>
-          <a:p>
-            <a:pPr algn="ctr">
-              <a:spcBef>
-                <a:spcPts val="0"/>
-              </a:spcBef>
-              <a:spcAft>
-                <a:spcPts val="0"/>
-              </a:spcAft>
-            </a:pPr>
-            <a:r>
-              <a:rPr sz="1200" b="0">
-                <a:solidFill>
-                  <a:srgbClr val="5E564C"/>
-                </a:solidFill>
-                <a:latin typeface="Calibri"/>
-              </a:rPr>
-              <a:t>Men 55-59</a:t>
-            </a:r>
-          </a:p>
-        </p:txBody>
-      </p:sp>
-      <p:sp>
-        <p:nvSpPr>
-          <p:cNvPr id="21" name="Rectangle 20"/>
+          <p:cNvPr id="12" name="Rectangle 11"/>
           <p:cNvSpPr/>
           <p:nvPr/>
         </p:nvSpPr>
         <p:spPr>
           <a:xfrm>
-            <a:off x="5577840" y="4187952"/>
-            <a:ext cx="3337560" cy="1234440"/>
+            <a:off x="5440680" y="2724912"/>
+            <a:ext cx="3246120" cy="36576"/>
           </a:xfrm>
           <a:prstGeom prst="rect">
             <a:avLst/>
           </a:prstGeom>
           <a:solidFill>
-            <a:srgbClr val="FBF7F0"/>
+            <a:srgbClr val="1E3A8A"/>
           </a:solidFill>
-          <a:ln w="9525">
-            <a:solidFill>
-              <a:srgbClr val="D4C8B4"/>
-            </a:solidFill>
+          <a:ln>
+            <a:noFill/>
           </a:ln>
           <a:effectLst/>
         </p:spPr>
@@ -5646,14 +6334,416 @@
       </p:sp>
       <p:sp>
         <p:nvSpPr>
+          <p:cNvPr id="13" name="TextBox 12"/>
+          <p:cNvSpPr txBox="1"/>
+          <p:nvPr/>
+        </p:nvSpPr>
+        <p:spPr>
+          <a:xfrm>
+            <a:off x="5568696" y="2834640"/>
+            <a:ext cx="2990088" cy="1005840"/>
+          </a:xfrm>
+          <a:prstGeom prst="rect">
+            <a:avLst/>
+          </a:prstGeom>
+          <a:noFill/>
+        </p:spPr>
+        <p:txBody>
+          <a:bodyPr wrap="square" lIns="0" rIns="0" tIns="0" bIns="0"/>
+          <a:lstStyle/>
+          <a:p>
+            <a:r>
+              <a:rPr sz="850" b="1" i="0">
+                <a:solidFill>
+                  <a:srgbClr val="1E3A8A"/>
+                </a:solidFill>
+                <a:latin typeface="Calibri"/>
+              </a:rPr>
+              <a:t>OLDER COHORT (AGES 55–59)  ·  42.6 POINT GAP</a:t>
+            </a:r>
+          </a:p>
+        </p:txBody>
+      </p:sp>
+      <p:sp>
+        <p:nvSpPr>
+          <p:cNvPr id="14" name="TextBox 13"/>
+          <p:cNvSpPr txBox="1"/>
+          <p:nvPr/>
+        </p:nvSpPr>
+        <p:spPr>
+          <a:xfrm>
+            <a:off x="5550408" y="2962656"/>
+            <a:ext cx="1463040" cy="457200"/>
+          </a:xfrm>
+          <a:prstGeom prst="rect">
+            <a:avLst/>
+          </a:prstGeom>
+          <a:noFill/>
+        </p:spPr>
+        <p:txBody>
+          <a:bodyPr wrap="none" lIns="0" rIns="0" tIns="0" bIns="0">
+            <a:spAutoFit/>
+          </a:bodyPr>
+          <a:lstStyle/>
+          <a:p>
+            <a:r>
+              <a:rPr sz="1900" b="1" i="0">
+                <a:solidFill>
+                  <a:srgbClr val="2C7FB8"/>
+                </a:solidFill>
+                <a:latin typeface="Georgia"/>
+              </a:rPr>
+              <a:t>58.8%
+</a:t>
+            </a:r>
+            <a:r>
+              <a:rPr sz="900" b="0" i="0">
+                <a:solidFill>
+                  <a:srgbClr val="64748B"/>
+                </a:solidFill>
+                <a:latin typeface="Calibri"/>
+              </a:rPr>
+              <a:t>Men (n = 41)</a:t>
+            </a:r>
+          </a:p>
+        </p:txBody>
+      </p:sp>
+      <p:sp>
+        <p:nvSpPr>
+          <p:cNvPr id="15" name="TextBox 14"/>
+          <p:cNvSpPr txBox="1"/>
+          <p:nvPr/>
+        </p:nvSpPr>
+        <p:spPr>
+          <a:xfrm>
+            <a:off x="7086600" y="2962656"/>
+            <a:ext cx="1463040" cy="457200"/>
+          </a:xfrm>
+          <a:prstGeom prst="rect">
+            <a:avLst/>
+          </a:prstGeom>
+          <a:noFill/>
+        </p:spPr>
+        <p:txBody>
+          <a:bodyPr wrap="none" lIns="0" rIns="0" tIns="0" bIns="0">
+            <a:spAutoFit/>
+          </a:bodyPr>
+          <a:lstStyle/>
+          <a:p>
+            <a:r>
+              <a:rPr sz="1900" b="1" i="0">
+                <a:solidFill>
+                  <a:srgbClr val="D95F02"/>
+                </a:solidFill>
+                <a:latin typeface="Georgia"/>
+              </a:rPr>
+              <a:t>16.2%
+</a:t>
+            </a:r>
+            <a:r>
+              <a:rPr sz="900" b="0" i="0">
+                <a:solidFill>
+                  <a:srgbClr val="64748B"/>
+                </a:solidFill>
+                <a:latin typeface="Calibri"/>
+              </a:rPr>
+              <a:t>Women (n = 41)</a:t>
+            </a:r>
+          </a:p>
+        </p:txBody>
+      </p:sp>
+      <p:sp>
+        <p:nvSpPr>
+          <p:cNvPr id="16" name="TextBox 15"/>
+          <p:cNvSpPr txBox="1"/>
+          <p:nvPr/>
+        </p:nvSpPr>
+        <p:spPr>
+          <a:xfrm>
+            <a:off x="5550408" y="3584448"/>
+            <a:ext cx="3026664" cy="274320"/>
+          </a:xfrm>
+          <a:prstGeom prst="rect">
+            <a:avLst/>
+          </a:prstGeom>
+          <a:noFill/>
+        </p:spPr>
+        <p:txBody>
+          <a:bodyPr wrap="none" lIns="0" rIns="0" tIns="0" bIns="0">
+            <a:spAutoFit/>
+          </a:bodyPr>
+          <a:lstStyle/>
+          <a:p>
+            <a:r>
+              <a:rPr sz="900" b="0" i="0">
+                <a:solidFill>
+                  <a:srgbClr val="334155"/>
+                </a:solidFill>
+                <a:latin typeface="Calibri"/>
+              </a:rPr>
+              <a:t>Severe female disadvantage in older cohorts educated in earlier decades.</a:t>
+            </a:r>
+          </a:p>
+        </p:txBody>
+      </p:sp>
+      <p:sp>
+        <p:nvSpPr>
+          <p:cNvPr id="17" name="Rectangle 16"/>
+          <p:cNvSpPr/>
+          <p:nvPr/>
+        </p:nvSpPr>
+        <p:spPr>
+          <a:xfrm>
+            <a:off x="5440680" y="4005072"/>
+            <a:ext cx="3246120" cy="1298448"/>
+          </a:xfrm>
+          <a:prstGeom prst="rect">
+            <a:avLst/>
+          </a:prstGeom>
+          <a:solidFill>
+            <a:srgbClr val="F8FAFC"/>
+          </a:solidFill>
+          <a:ln w="9525">
+            <a:solidFill>
+              <a:srgbClr val="E2E8F0"/>
+            </a:solidFill>
+          </a:ln>
+          <a:effectLst/>
+        </p:spPr>
+        <p:style>
+          <a:lnRef idx="1">
+            <a:schemeClr val="accent1"/>
+          </a:lnRef>
+          <a:fillRef idx="3">
+            <a:schemeClr val="accent1"/>
+          </a:fillRef>
+          <a:effectRef idx="2">
+            <a:schemeClr val="accent1"/>
+          </a:effectRef>
+          <a:fontRef idx="minor">
+            <a:schemeClr val="lt1"/>
+          </a:fontRef>
+        </p:style>
+        <p:txBody>
+          <a:bodyPr rtlCol="0" anchor="ctr"/>
+          <a:lstStyle/>
+          <a:p>
+            <a:pPr algn="ctr"/>
+          </a:p>
+        </p:txBody>
+      </p:sp>
+      <p:sp>
+        <p:nvSpPr>
+          <p:cNvPr id="18" name="Rectangle 17"/>
+          <p:cNvSpPr/>
+          <p:nvPr/>
+        </p:nvSpPr>
+        <p:spPr>
+          <a:xfrm>
+            <a:off x="5440680" y="4005072"/>
+            <a:ext cx="3246120" cy="36576"/>
+          </a:xfrm>
+          <a:prstGeom prst="rect">
+            <a:avLst/>
+          </a:prstGeom>
+          <a:solidFill>
+            <a:srgbClr val="B91C1C"/>
+          </a:solidFill>
+          <a:ln>
+            <a:noFill/>
+          </a:ln>
+          <a:effectLst/>
+        </p:spPr>
+        <p:style>
+          <a:lnRef idx="1">
+            <a:schemeClr val="accent1"/>
+          </a:lnRef>
+          <a:fillRef idx="3">
+            <a:schemeClr val="accent1"/>
+          </a:fillRef>
+          <a:effectRef idx="2">
+            <a:schemeClr val="accent1"/>
+          </a:effectRef>
+          <a:fontRef idx="minor">
+            <a:schemeClr val="lt1"/>
+          </a:fontRef>
+        </p:style>
+        <p:txBody>
+          <a:bodyPr rtlCol="0" anchor="ctr"/>
+          <a:lstStyle/>
+          <a:p>
+            <a:pPr algn="ctr"/>
+          </a:p>
+        </p:txBody>
+      </p:sp>
+      <p:sp>
+        <p:nvSpPr>
+          <p:cNvPr id="19" name="TextBox 18"/>
+          <p:cNvSpPr txBox="1"/>
+          <p:nvPr/>
+        </p:nvSpPr>
+        <p:spPr>
+          <a:xfrm>
+            <a:off x="5568696" y="4114800"/>
+            <a:ext cx="2990088" cy="1115568"/>
+          </a:xfrm>
+          <a:prstGeom prst="rect">
+            <a:avLst/>
+          </a:prstGeom>
+          <a:noFill/>
+        </p:spPr>
+        <p:txBody>
+          <a:bodyPr wrap="square" lIns="0" rIns="0" tIns="0" bIns="0"/>
+          <a:lstStyle/>
+          <a:p>
+            <a:r>
+              <a:rPr sz="900" b="1" i="0">
+                <a:solidFill>
+                  <a:srgbClr val="B91C1C"/>
+                </a:solidFill>
+                <a:latin typeface="Calibri"/>
+              </a:rPr>
+              <a:t>LARGEST DISPARITY: AGES 40–44</a:t>
+            </a:r>
+          </a:p>
+          <a:p>
+            <a:pPr>
+              <a:spcBef>
+                <a:spcPts val="200"/>
+              </a:spcBef>
+              <a:spcAft>
+                <a:spcPts val="200"/>
+              </a:spcAft>
+            </a:pPr>
+            <a:r>
+              <a:rPr sz="2000" b="1" i="0">
+                <a:solidFill>
+                  <a:srgbClr val="B91C1C"/>
+                </a:solidFill>
+                <a:latin typeface="Georgia"/>
+              </a:rPr>
+              <a:t>47.4 Points Gap</a:t>
+            </a:r>
+          </a:p>
+          <a:p>
+            <a:pPr>
+              <a:spcBef>
+                <a:spcPts val="200"/>
+              </a:spcBef>
+            </a:pPr>
+            <a:r>
+              <a:rPr sz="980" b="0" i="0">
+                <a:solidFill>
+                  <a:srgbClr val="334155"/>
+                </a:solidFill>
+                <a:latin typeface="Calibri"/>
+              </a:rPr>
+              <a:t>Men: 77.1% (n = 100) vs Women: 29.7% (n = 110).
+Wider than both youth (21.6 pts) and oldest adults (37.8 pts).</a:t>
+            </a:r>
+          </a:p>
+        </p:txBody>
+      </p:sp>
+      <p:sp>
+        <p:nvSpPr>
+          <p:cNvPr id="20" name="Rectangle 19"/>
+          <p:cNvSpPr/>
+          <p:nvPr/>
+        </p:nvSpPr>
+        <p:spPr>
+          <a:xfrm>
+            <a:off x="457200" y="5413248"/>
+            <a:ext cx="8229600" cy="868680"/>
+          </a:xfrm>
+          <a:prstGeom prst="rect">
+            <a:avLst/>
+          </a:prstGeom>
+          <a:solidFill>
+            <a:srgbClr val="F8FAFC"/>
+          </a:solidFill>
+          <a:ln w="9525">
+            <a:solidFill>
+              <a:srgbClr val="E2E8F0"/>
+            </a:solidFill>
+          </a:ln>
+          <a:effectLst/>
+        </p:spPr>
+        <p:style>
+          <a:lnRef idx="1">
+            <a:schemeClr val="accent1"/>
+          </a:lnRef>
+          <a:fillRef idx="3">
+            <a:schemeClr val="accent1"/>
+          </a:fillRef>
+          <a:effectRef idx="2">
+            <a:schemeClr val="accent1"/>
+          </a:effectRef>
+          <a:fontRef idx="minor">
+            <a:schemeClr val="lt1"/>
+          </a:fontRef>
+        </p:style>
+        <p:txBody>
+          <a:bodyPr rtlCol="0" anchor="ctr"/>
+          <a:lstStyle/>
+          <a:p>
+            <a:pPr algn="ctr"/>
+          </a:p>
+        </p:txBody>
+      </p:sp>
+      <p:sp>
+        <p:nvSpPr>
+          <p:cNvPr id="21" name="Rectangle 20"/>
+          <p:cNvSpPr/>
+          <p:nvPr/>
+        </p:nvSpPr>
+        <p:spPr>
+          <a:xfrm>
+            <a:off x="457200" y="5413248"/>
+            <a:ext cx="8229600" cy="36576"/>
+          </a:xfrm>
+          <a:prstGeom prst="rect">
+            <a:avLst/>
+          </a:prstGeom>
+          <a:solidFill>
+            <a:srgbClr val="1E3A8A"/>
+          </a:solidFill>
+          <a:ln>
+            <a:noFill/>
+          </a:ln>
+          <a:effectLst/>
+        </p:spPr>
+        <p:style>
+          <a:lnRef idx="1">
+            <a:schemeClr val="accent1"/>
+          </a:lnRef>
+          <a:fillRef idx="3">
+            <a:schemeClr val="accent1"/>
+          </a:fillRef>
+          <a:effectRef idx="2">
+            <a:schemeClr val="accent1"/>
+          </a:effectRef>
+          <a:fontRef idx="minor">
+            <a:schemeClr val="lt1"/>
+          </a:fontRef>
+        </p:style>
+        <p:txBody>
+          <a:bodyPr rtlCol="0" anchor="ctr"/>
+          <a:lstStyle/>
+          <a:p>
+            <a:pPr algn="ctr"/>
+          </a:p>
+        </p:txBody>
+      </p:sp>
+      <p:sp>
+        <p:nvSpPr>
           <p:cNvPr id="22" name="TextBox 21"/>
           <p:cNvSpPr txBox="1"/>
           <p:nvPr/>
         </p:nvSpPr>
         <p:spPr>
           <a:xfrm>
-            <a:off x="5687568" y="4297680"/>
-            <a:ext cx="3118104" cy="566928"/>
+            <a:off x="585216" y="5522976"/>
+            <a:ext cx="7973568" cy="685800"/>
           </a:xfrm>
           <a:prstGeom prst="rect">
             <a:avLst/>
@@ -5661,67 +6751,78 @@
           <a:noFill/>
         </p:spPr>
         <p:txBody>
-          <a:bodyPr wrap="square"/>
-          <a:lstStyle/>
-          <a:p>
-            <a:pPr algn="ctr">
+          <a:bodyPr wrap="square" lIns="0" rIns="0" tIns="0" bIns="0"/>
+          <a:lstStyle/>
+          <a:p>
+            <a:r>
+              <a:rPr sz="900" b="1" i="0">
+                <a:solidFill>
+                  <a:srgbClr val="1E3A8A"/>
+                </a:solidFill>
+                <a:latin typeface="Calibri"/>
+              </a:rPr>
+              <a:t>CRITICAL ECONOMIC INTERPRETATION: WHAT THIS CANNOT TELL US</a:t>
+            </a:r>
+          </a:p>
+          <a:p>
+            <a:pPr>
               <a:spcBef>
-                <a:spcPts val="0"/>
+                <a:spcPts val="200"/>
               </a:spcBef>
-              <a:spcAft>
-                <a:spcPts val="0"/>
-              </a:spcAft>
             </a:pPr>
             <a:r>
-              <a:rPr sz="2600" b="1">
-                <a:solidFill>
-                  <a:srgbClr val="8E2F28"/>
-                </a:solidFill>
-                <a:latin typeface="Georgia"/>
-              </a:rPr>
-              <a:t>47.4 points</a:t>
-            </a:r>
-          </a:p>
-        </p:txBody>
-      </p:sp>
-      <p:sp>
-        <p:nvSpPr>
-          <p:cNvPr id="23" name="TextBox 22"/>
-          <p:cNvSpPr txBox="1"/>
-          <p:nvPr/>
-        </p:nvSpPr>
-        <p:spPr>
-          <a:xfrm>
-            <a:off x="5687568" y="4864608"/>
-            <a:ext cx="3118104" cy="457200"/>
-          </a:xfrm>
-          <a:prstGeom prst="rect">
-            <a:avLst/>
-          </a:prstGeom>
-          <a:noFill/>
-        </p:spPr>
-        <p:txBody>
-          <a:bodyPr wrap="square"/>
-          <a:lstStyle/>
-          <a:p>
-            <a:pPr algn="ctr">
-              <a:spcBef>
-                <a:spcPts val="0"/>
-              </a:spcBef>
-              <a:spcAft>
-                <a:spcPts val="0"/>
-              </a:spcAft>
-            </a:pPr>
-            <a:r>
-              <a:rPr sz="1200" b="0">
-                <a:solidFill>
-                  <a:srgbClr val="5E564C"/>
+              <a:rPr sz="1000" b="0" i="0">
+                <a:solidFill>
+                  <a:srgbClr val="334155"/>
                 </a:solidFill>
                 <a:latin typeface="Calibri"/>
               </a:rPr>
-              <a:t>Men 77.1% vs women 29.7% at ages 40-44
-(gap at 55-59 is 42.6 points)</a:t>
-            </a:r>
+              <a:t>This cross-section reflects the historical expansion of schooling across birth cohorts over time, not individual people losing literacy as they age. A single cross-section cannot separate aging from birth cohort effects, nor identify causal drivers.</a:t>
+            </a:r>
+          </a:p>
+        </p:txBody>
+      </p:sp>
+      <p:sp>
+        <p:nvSpPr>
+          <p:cNvPr id="23" name="Rectangle 22"/>
+          <p:cNvSpPr/>
+          <p:nvPr/>
+        </p:nvSpPr>
+        <p:spPr>
+          <a:xfrm>
+            <a:off x="457200" y="6473952"/>
+            <a:ext cx="8229600" cy="9144"/>
+          </a:xfrm>
+          <a:prstGeom prst="rect">
+            <a:avLst/>
+          </a:prstGeom>
+          <a:solidFill>
+            <a:srgbClr val="CBD5E1"/>
+          </a:solidFill>
+          <a:ln>
+            <a:noFill/>
+          </a:ln>
+          <a:effectLst/>
+        </p:spPr>
+        <p:style>
+          <a:lnRef idx="1">
+            <a:schemeClr val="accent1"/>
+          </a:lnRef>
+          <a:fillRef idx="3">
+            <a:schemeClr val="accent1"/>
+          </a:fillRef>
+          <a:effectRef idx="2">
+            <a:schemeClr val="accent1"/>
+          </a:effectRef>
+          <a:fontRef idx="minor">
+            <a:schemeClr val="lt1"/>
+          </a:fontRef>
+        </p:style>
+        <p:txBody>
+          <a:bodyPr rtlCol="0" anchor="ctr"/>
+          <a:lstStyle/>
+          <a:p>
+            <a:pPr algn="ctr"/>
           </a:p>
         </p:txBody>
       </p:sp>
@@ -5733,8 +6834,8 @@
         </p:nvSpPr>
         <p:spPr>
           <a:xfrm>
-            <a:off x="411480" y="5806440"/>
-            <a:ext cx="8321040" cy="640080"/>
+            <a:off x="457200" y="6528816"/>
+            <a:ext cx="6400800" cy="228600"/>
           </a:xfrm>
           <a:prstGeom prst="rect">
             <a:avLst/>
@@ -5742,25 +6843,54 @@
           <a:noFill/>
         </p:spPr>
         <p:txBody>
-          <a:bodyPr wrap="square"/>
-          <a:lstStyle/>
-          <a:p>
-            <a:pPr algn="l">
-              <a:spcBef>
-                <a:spcPts val="0"/>
-              </a:spcBef>
-              <a:spcAft>
-                <a:spcPts val="0"/>
-              </a:spcAft>
-            </a:pPr>
-            <a:r>
-              <a:rPr sz="1400" b="0">
-                <a:solidFill>
-                  <a:srgbClr val="2A241F"/>
+          <a:bodyPr wrap="none" lIns="0" rIns="0" tIns="0" bIns="0">
+            <a:spAutoFit/>
+          </a:bodyPr>
+          <a:lstStyle/>
+          <a:p>
+            <a:r>
+              <a:rPr sz="950" b="0" i="0">
+                <a:solidFill>
+                  <a:srgbClr val="64748B"/>
                 </a:solidFill>
                 <a:latin typeface="Calibri"/>
               </a:rPr>
-              <a:t>This is a cross-section, not a life history. It cannot tell us why the gap exists, or whether it is a cohort effect or aging.</a:t>
+              <a:t>ECO346 Data Visualization · FA24-BEDS-105 · Variant 5 (KP Urban) · PSLM 2019–20</a:t>
+            </a:r>
+          </a:p>
+        </p:txBody>
+      </p:sp>
+      <p:sp>
+        <p:nvSpPr>
+          <p:cNvPr id="25" name="TextBox 24"/>
+          <p:cNvSpPr txBox="1"/>
+          <p:nvPr/>
+        </p:nvSpPr>
+        <p:spPr>
+          <a:xfrm>
+            <a:off x="6949440" y="6528816"/>
+            <a:ext cx="1737360" cy="228600"/>
+          </a:xfrm>
+          <a:prstGeom prst="rect">
+            <a:avLst/>
+          </a:prstGeom>
+          <a:noFill/>
+        </p:spPr>
+        <p:txBody>
+          <a:bodyPr wrap="none" lIns="0" rIns="0" tIns="0" bIns="0">
+            <a:spAutoFit/>
+          </a:bodyPr>
+          <a:lstStyle/>
+          <a:p>
+            <a:pPr algn="r"/>
+            <a:r>
+              <a:rPr sz="950" b="0" i="0">
+                <a:solidFill>
+                  <a:srgbClr val="64748B"/>
+                </a:solidFill>
+                <a:latin typeface="Calibri"/>
+              </a:rPr>
+              <a:t>Slide 4 of 4</a:t>
             </a:r>
           </a:p>
         </p:txBody>

</xml_diff>